<commit_message>
Reports, README, license, reference materials
</commit_message>
<xml_diff>
--- a/presentation/MASLD_stages_computational_analysis_roee_shira.pptx
+++ b/presentation/MASLD_stages_computational_analysis_roee_shira.pptx
@@ -22,7 +22,7 @@
     <p:sldId id="266" r:id="rId13"/>
     <p:sldId id="267" r:id="rId14"/>
     <p:sldId id="268" r:id="rId15"/>
-    <p:sldId id="270" r:id="rId16"/>
+    <p:sldId id="287" r:id="rId16"/>
     <p:sldId id="269" r:id="rId17"/>
     <p:sldId id="271" r:id="rId18"/>
     <p:sldId id="272" r:id="rId19"/>
@@ -905,13 +905,6 @@
           </p:nvPr>
         </p:nvSpPr>
         <p:spPr/>
-        <p:txBody>
-          <a:bodyPr/>
-          <a:lstStyle/>
-          <a:p>
-            <a:endParaRPr lang="en-US"/>
-          </a:p>
-        </p:txBody>
       </p:sp>
       <p:sp>
         <p:nvSpPr>
@@ -928,10 +921,7 @@
           <a:bodyPr/>
           <a:lstStyle/>
           <a:p>
-            <a:r>
-              <a:rPr lang="en-US" dirty="0"/>
-              <a:t>Distinguish evidence levels. Strong: the genes are 5-78x more abundant in cholangiocytes and per-cell hepatocyte co-expression is ~0.4%. Suggestive: decontX halves the hits and drops SOX4/SOX9 — supports an ambient contribution but not proof. Open: EPCAM/SPINT2/B3GNT3 survive — a rare intrinsic state is not excluded; CXCL10 is set aside as a candidate real inflammatory signal. So the dominant evidence points to composition/ambient RNA, a lead not a closed verdict.</a:t>
-            </a:r>
+            <a:endParaRPr lang="en-US" dirty="0"/>
           </a:p>
         </p:txBody>
       </p:sp>
@@ -7289,15 +7279,7 @@
 
 <file path=ppt/slides/slide15.xml><?xml version="1.0" encoding="utf-8"?>
 <p:sld xmlns:a="http://schemas.openxmlformats.org/drawingml/2006/main" xmlns:r="http://schemas.openxmlformats.org/officeDocument/2006/relationships" xmlns:p="http://schemas.openxmlformats.org/presentationml/2006/main">
-  <p:cSld name="Slide 15">
-    <p:bg>
-      <p:bgPr>
-        <a:solidFill>
-          <a:srgbClr val="F7F5F1"/>
-        </a:solidFill>
-        <a:effectLst/>
-      </p:bgPr>
-    </p:bg>
+  <p:cSld>
     <p:spTree>
       <p:nvGrpSpPr>
         <p:cNvPr id="1" name=""/>
@@ -7320,6 +7302,36 @@
         </p:nvSpPr>
         <p:spPr>
           <a:xfrm>
+            <a:off x="0" y="0"/>
+            <a:ext cx="12191695" cy="6858000"/>
+          </a:xfrm>
+          <a:prstGeom prst="rect">
+            <a:avLst/>
+          </a:prstGeom>
+          <a:solidFill>
+            <a:srgbClr val="F7F5F1"/>
+          </a:solidFill>
+          <a:ln/>
+        </p:spPr>
+        <p:txBody>
+          <a:bodyPr/>
+          <a:lstStyle/>
+          <a:p>
+            <a:r>
+              <a:rPr lang="en-US" dirty="0"/>
+              <a:t>c</a:t>
+            </a:r>
+          </a:p>
+        </p:txBody>
+      </p:sp>
+      <p:sp>
+        <p:nvSpPr>
+          <p:cNvPr id="3" name="Shape 1"/>
+          <p:cNvSpPr/>
+          <p:nvPr/>
+        </p:nvSpPr>
+        <p:spPr>
+          <a:xfrm>
             <a:off x="457200" y="310896"/>
             <a:ext cx="146304" cy="237744"/>
           </a:xfrm>
@@ -7331,17 +7343,10 @@
           </a:solidFill>
           <a:ln/>
         </p:spPr>
-        <p:txBody>
-          <a:bodyPr/>
-          <a:lstStyle/>
-          <a:p>
-            <a:endParaRPr lang="en-US"/>
-          </a:p>
-        </p:txBody>
-      </p:sp>
-      <p:sp>
-        <p:nvSpPr>
-          <p:cNvPr id="3" name="Text 1"/>
+      </p:sp>
+      <p:sp>
+        <p:nvSpPr>
+          <p:cNvPr id="4" name="Text 2"/>
           <p:cNvSpPr/>
           <p:nvPr/>
         </p:nvSpPr>
@@ -7377,7 +7382,7 @@
       </p:sp>
       <p:sp>
         <p:nvSpPr>
-          <p:cNvPr id="4" name="Text 2"/>
+          <p:cNvPr id="5" name="Text 3"/>
           <p:cNvSpPr/>
           <p:nvPr/>
         </p:nvSpPr>
@@ -7413,7 +7418,7 @@
       </p:sp>
       <p:sp>
         <p:nvSpPr>
-          <p:cNvPr id="5" name="Text 3"/>
+          <p:cNvPr id="6" name="Text 4"/>
           <p:cNvSpPr/>
           <p:nvPr/>
         </p:nvSpPr>
@@ -7444,15 +7449,59 @@
                 <a:ea typeface="Georgia" pitchFamily="34" charset="-122"/>
                 <a:cs typeface="Georgia" pitchFamily="34" charset="-120"/>
               </a:rPr>
-              <a:t>The biliary signal: a compositional confounder? — a lead</a:t>
+              <a:t>The biliary signal: compositional? a lead</a:t>
             </a:r>
             <a:endParaRPr lang="en-US" sz="2800" dirty="0"/>
+          </a:p>
+        </p:txBody>
+      </p:sp>
+      <p:sp>
+        <p:nvSpPr>
+          <p:cNvPr id="7" name="Text 5"/>
+          <p:cNvSpPr/>
+          <p:nvPr/>
+        </p:nvSpPr>
+        <p:spPr>
+          <a:xfrm>
+            <a:off x="640080" y="1335024"/>
+            <a:ext cx="11247120" cy="411480"/>
+          </a:xfrm>
+          <a:prstGeom prst="rect">
+            <a:avLst/>
+          </a:prstGeom>
+          <a:noFill/>
+          <a:ln/>
+        </p:spPr>
+        <p:txBody>
+          <a:bodyPr wrap="square" rtlCol="0" anchor="ctr"/>
+          <a:lstStyle/>
+          <a:p>
+            <a:pPr marL="0" indent="0" algn="l">
+              <a:buNone/>
+            </a:pPr>
+            <a:r>
+              <a:rPr lang="en-US" sz="1450" b="1" dirty="0">
+                <a:solidFill>
+                  <a:srgbClr val="1B2B31"/>
+                </a:solidFill>
+              </a:rPr>
+              <a:t>What we see:  </a:t>
+            </a:r>
+            <a:r>
+              <a:rPr lang="en-US" sz="1450" dirty="0">
+                <a:solidFill>
+                  <a:srgbClr val="1B2B31"/>
+                </a:solidFill>
+              </a:rPr>
+              <a:t>biliary / ductular genes (EPCAM, SOX9, GRHL2, B3GNT3, SPINT2) rise at F4 — exactly where cirrhosis’s ductular reaction floods the tissue with cholangiocytes.</a:t>
+            </a:r>
+            <a:endParaRPr lang="en-US" sz="1450" dirty="0"/>
           </a:p>
         </p:txBody>
       </p:sp>
       <p:pic>
         <p:nvPicPr>
-          <p:cNvPr id="6" name="Image 0" descr="D:\CS\Genomics\Hackathon\presentation/assets/fig_compositional.png"/>
+          <p:cNvPr id="8" name="Image 0" descr="D:\CS\Genomics\Hackathon\presentation/assets/fig_compositional.png"/>
           <p:cNvPicPr>
             <a:picLocks noChangeAspect="1"/>
           </p:cNvPicPr>
@@ -7466,8 +7515,8 @@
         </p:blipFill>
         <p:spPr>
           <a:xfrm>
-            <a:off x="2208441" y="1371600"/>
-            <a:ext cx="7744638" cy="3063240"/>
+            <a:off x="3791788" y="1783080"/>
+            <a:ext cx="4623665" cy="1828800"/>
           </a:xfrm>
           <a:prstGeom prst="rect">
             <a:avLst/>
@@ -7476,14 +7525,14 @@
       </p:pic>
       <p:sp>
         <p:nvSpPr>
-          <p:cNvPr id="7" name="Text 4"/>
-          <p:cNvSpPr/>
-          <p:nvPr/>
-        </p:nvSpPr>
-        <p:spPr>
-          <a:xfrm>
-            <a:off x="274320" y="4304885"/>
-            <a:ext cx="11612880" cy="365760"/>
+          <p:cNvPr id="9" name="Text 6"/>
+          <p:cNvSpPr/>
+          <p:nvPr/>
+        </p:nvSpPr>
+        <p:spPr>
+          <a:xfrm>
+            <a:off x="365760" y="3657600"/>
+            <a:ext cx="11475720" cy="365760"/>
           </a:xfrm>
           <a:prstGeom prst="rect">
             <a:avLst/>
@@ -7504,7 +7553,7 @@
                   <a:srgbClr val="5C6E73"/>
                 </a:solidFill>
               </a:rPr>
-              <a:t>Figure 6.  Source attribution — cross-lineage abundance, decontX ambient-RNA removal, and the F4 ductular reaction.</a:t>
+              <a:t>Figure.  Source attribution — cross-lineage abundance, decontX ambient-RNA removal, and the F4 ductular reaction.</a:t>
             </a:r>
             <a:endParaRPr lang="en-US" sz="1200" dirty="0"/>
           </a:p>
@@ -7512,18 +7561,18 @@
       </p:sp>
       <p:sp>
         <p:nvSpPr>
-          <p:cNvPr id="8" name="Shape 5"/>
-          <p:cNvSpPr/>
-          <p:nvPr/>
-        </p:nvSpPr>
-        <p:spPr>
-          <a:xfrm>
-            <a:off x="548640" y="4828032"/>
-            <a:ext cx="11155680" cy="384048"/>
+          <p:cNvPr id="10" name="Shape 7"/>
+          <p:cNvSpPr/>
+          <p:nvPr/>
+        </p:nvSpPr>
+        <p:spPr>
+          <a:xfrm>
+            <a:off x="548640" y="4041648"/>
+            <a:ext cx="11201400" cy="603504"/>
           </a:xfrm>
           <a:prstGeom prst="roundRect">
             <a:avLst>
-              <a:gd name="adj" fmla="val 11905"/>
+              <a:gd name="adj" fmla="val 7576"/>
             </a:avLst>
           </a:prstGeom>
           <a:solidFill>
@@ -7531,24 +7580,17 @@
           </a:solidFill>
           <a:ln/>
         </p:spPr>
-        <p:txBody>
-          <a:bodyPr/>
-          <a:lstStyle/>
-          <a:p>
-            <a:endParaRPr lang="en-US"/>
-          </a:p>
-        </p:txBody>
-      </p:sp>
-      <p:sp>
-        <p:nvSpPr>
-          <p:cNvPr id="9" name="Text 6"/>
-          <p:cNvSpPr/>
-          <p:nvPr/>
-        </p:nvSpPr>
-        <p:spPr>
-          <a:xfrm>
-            <a:off x="713232" y="4828032"/>
-            <a:ext cx="1737360" cy="384048"/>
+      </p:sp>
+      <p:sp>
+        <p:nvSpPr>
+          <p:cNvPr id="11" name="Text 8"/>
+          <p:cNvSpPr/>
+          <p:nvPr/>
+        </p:nvSpPr>
+        <p:spPr>
+          <a:xfrm>
+            <a:off x="713232" y="4041648"/>
+            <a:ext cx="2697480" cy="603504"/>
           </a:xfrm>
           <a:prstGeom prst="rect">
             <a:avLst/>
@@ -7564,27 +7606,27 @@
               <a:buNone/>
             </a:pPr>
             <a:r>
-              <a:rPr lang="en-US" sz="1200" b="1" kern="0" spc="100" dirty="0">
+              <a:rPr lang="en-US" sz="1100" b="1" kern="0" spc="50" dirty="0">
                 <a:solidFill>
                   <a:srgbClr val="065F46"/>
                 </a:solidFill>
               </a:rPr>
-              <a:t>STRONG</a:t>
-            </a:r>
-            <a:endParaRPr lang="en-US" sz="1200" dirty="0"/>
-          </a:p>
-        </p:txBody>
-      </p:sp>
-      <p:sp>
-        <p:nvSpPr>
-          <p:cNvPr id="10" name="Text 7"/>
-          <p:cNvSpPr/>
-          <p:nvPr/>
-        </p:nvSpPr>
-        <p:spPr>
-          <a:xfrm>
-            <a:off x="2468880" y="4828032"/>
-            <a:ext cx="9052560" cy="384048"/>
+              <a:t>COMPOSITIONAL  (the lead)</a:t>
+            </a:r>
+            <a:endParaRPr lang="en-US" sz="1100" dirty="0"/>
+          </a:p>
+        </p:txBody>
+      </p:sp>
+      <p:sp>
+        <p:nvSpPr>
+          <p:cNvPr id="12" name="Text 9"/>
+          <p:cNvSpPr/>
+          <p:nvPr/>
+        </p:nvSpPr>
+        <p:spPr>
+          <a:xfrm>
+            <a:off x="3474720" y="4041648"/>
+            <a:ext cx="8138160" cy="603504"/>
           </a:xfrm>
           <a:prstGeom prst="rect">
             <a:avLst/>
@@ -7600,31 +7642,31 @@
               <a:buNone/>
             </a:pPr>
             <a:r>
-              <a:rPr lang="en-US" sz="1300" dirty="0">
+              <a:rPr lang="en-US" sz="1100" dirty="0">
                 <a:solidFill>
                   <a:srgbClr val="1B2B31"/>
                 </a:solidFill>
               </a:rPr>
-              <a:t>Biliary genes are cholangiocyte genes; hepatocyte co-expression ~0.4%</a:t>
-            </a:r>
-            <a:endParaRPr lang="en-US" sz="1300" dirty="0"/>
-          </a:p>
-        </p:txBody>
-      </p:sp>
-      <p:sp>
-        <p:nvSpPr>
-          <p:cNvPr id="11" name="Shape 8"/>
-          <p:cNvSpPr/>
-          <p:nvPr/>
-        </p:nvSpPr>
-        <p:spPr>
-          <a:xfrm>
-            <a:off x="548640" y="5257800"/>
-            <a:ext cx="11155680" cy="384048"/>
+              <a:t>These are cholangiocyte genes. At F4 there are more cholangiocytes → more of their RNA in the ambient “soup” (plus the odd doublet) enters hepatocyte droplets → hepatocytes look biliary without transdifferentiating.</a:t>
+            </a:r>
+            <a:endParaRPr lang="en-US" sz="1100" dirty="0"/>
+          </a:p>
+        </p:txBody>
+      </p:sp>
+      <p:sp>
+        <p:nvSpPr>
+          <p:cNvPr id="13" name="Shape 10"/>
+          <p:cNvSpPr/>
+          <p:nvPr/>
+        </p:nvSpPr>
+        <p:spPr>
+          <a:xfrm>
+            <a:off x="548640" y="4700016"/>
+            <a:ext cx="11201400" cy="603504"/>
           </a:xfrm>
           <a:prstGeom prst="roundRect">
             <a:avLst>
-              <a:gd name="adj" fmla="val 11905"/>
+              <a:gd name="adj" fmla="val 7576"/>
             </a:avLst>
           </a:prstGeom>
           <a:solidFill>
@@ -7632,24 +7674,17 @@
           </a:solidFill>
           <a:ln/>
         </p:spPr>
-        <p:txBody>
-          <a:bodyPr/>
-          <a:lstStyle/>
-          <a:p>
-            <a:endParaRPr lang="en-US"/>
-          </a:p>
-        </p:txBody>
-      </p:sp>
-      <p:sp>
-        <p:nvSpPr>
-          <p:cNvPr id="12" name="Text 9"/>
-          <p:cNvSpPr/>
-          <p:nvPr/>
-        </p:nvSpPr>
-        <p:spPr>
-          <a:xfrm>
-            <a:off x="713232" y="5257800"/>
-            <a:ext cx="1737360" cy="384048"/>
+      </p:sp>
+      <p:sp>
+        <p:nvSpPr>
+          <p:cNvPr id="14" name="Text 11"/>
+          <p:cNvSpPr/>
+          <p:nvPr/>
+        </p:nvSpPr>
+        <p:spPr>
+          <a:xfrm>
+            <a:off x="713232" y="4700016"/>
+            <a:ext cx="2697480" cy="603504"/>
           </a:xfrm>
           <a:prstGeom prst="rect">
             <a:avLst/>
@@ -7665,27 +7700,27 @@
               <a:buNone/>
             </a:pPr>
             <a:r>
-              <a:rPr lang="en-US" sz="1200" b="1" kern="0" spc="100" dirty="0">
+              <a:rPr lang="en-US" sz="1100" b="1" kern="0" spc="50" dirty="0">
                 <a:solidFill>
                   <a:srgbClr val="B45309"/>
                 </a:solidFill>
               </a:rPr>
-              <a:t>SUGGESTIVE</a:t>
-            </a:r>
-            <a:endParaRPr lang="en-US" sz="1200" dirty="0"/>
-          </a:p>
-        </p:txBody>
-      </p:sp>
-      <p:sp>
-        <p:nvSpPr>
-          <p:cNvPr id="13" name="Text 10"/>
-          <p:cNvSpPr/>
-          <p:nvPr/>
-        </p:nvSpPr>
-        <p:spPr>
-          <a:xfrm>
-            <a:off x="2468880" y="5257800"/>
-            <a:ext cx="9052560" cy="384048"/>
+              <a:t>RARE PER CELL  (read carefully)</a:t>
+            </a:r>
+            <a:endParaRPr lang="en-US" sz="1100" dirty="0"/>
+          </a:p>
+        </p:txBody>
+      </p:sp>
+      <p:sp>
+        <p:nvSpPr>
+          <p:cNvPr id="15" name="Text 12"/>
+          <p:cNvSpPr/>
+          <p:nvPr/>
+        </p:nvSpPr>
+        <p:spPr>
+          <a:xfrm>
+            <a:off x="3474720" y="4700016"/>
+            <a:ext cx="8138160" cy="603504"/>
           </a:xfrm>
           <a:prstGeom prst="rect">
             <a:avLst/>
@@ -7701,31 +7736,31 @@
               <a:buNone/>
             </a:pPr>
             <a:r>
-              <a:rPr lang="en-US" sz="1300" dirty="0">
+              <a:rPr lang="en-US" sz="1100" dirty="0">
                 <a:solidFill>
                   <a:srgbClr val="1B2B31"/>
                 </a:solidFill>
               </a:rPr>
-              <a:t>decontX¹ halves the hits — an ambient contribution, not proof</a:t>
-            </a:r>
-            <a:endParaRPr lang="en-US" sz="1300" dirty="0"/>
-          </a:p>
-        </p:txBody>
-      </p:sp>
-      <p:sp>
-        <p:nvSpPr>
-          <p:cNvPr id="14" name="Shape 11"/>
-          <p:cNvSpPr/>
-          <p:nvPr/>
-        </p:nvSpPr>
-        <p:spPr>
-          <a:xfrm>
-            <a:off x="548640" y="5687568"/>
-            <a:ext cx="11155680" cy="384048"/>
+              <a:t>Only ~0.4% of hepatocyte nuclei co-detect biliary markers at ≥2 UMI — not population-wide. But that is prevalence over ALL hepatocytes: it argues against MASS transdifferentiation, not against a rare sub-population (class imbalance).</a:t>
+            </a:r>
+            <a:endParaRPr lang="en-US" sz="1100" dirty="0"/>
+          </a:p>
+        </p:txBody>
+      </p:sp>
+      <p:sp>
+        <p:nvSpPr>
+          <p:cNvPr id="16" name="Shape 13"/>
+          <p:cNvSpPr/>
+          <p:nvPr/>
+        </p:nvSpPr>
+        <p:spPr>
+          <a:xfrm>
+            <a:off x="548640" y="5358384"/>
+            <a:ext cx="11201400" cy="603504"/>
           </a:xfrm>
           <a:prstGeom prst="roundRect">
             <a:avLst>
-              <a:gd name="adj" fmla="val 11905"/>
+              <a:gd name="adj" fmla="val 7576"/>
             </a:avLst>
           </a:prstGeom>
           <a:solidFill>
@@ -7733,24 +7768,17 @@
           </a:solidFill>
           <a:ln/>
         </p:spPr>
-        <p:txBody>
-          <a:bodyPr/>
-          <a:lstStyle/>
-          <a:p>
-            <a:endParaRPr lang="en-US"/>
-          </a:p>
-        </p:txBody>
-      </p:sp>
-      <p:sp>
-        <p:nvSpPr>
-          <p:cNvPr id="15" name="Text 12"/>
-          <p:cNvSpPr/>
-          <p:nvPr/>
-        </p:nvSpPr>
-        <p:spPr>
-          <a:xfrm>
-            <a:off x="713232" y="5687568"/>
-            <a:ext cx="1737360" cy="384048"/>
+      </p:sp>
+      <p:sp>
+        <p:nvSpPr>
+          <p:cNvPr id="17" name="Text 14"/>
+          <p:cNvSpPr/>
+          <p:nvPr/>
+        </p:nvSpPr>
+        <p:spPr>
+          <a:xfrm>
+            <a:off x="713232" y="5358384"/>
+            <a:ext cx="2697480" cy="603504"/>
           </a:xfrm>
           <a:prstGeom prst="rect">
             <a:avLst/>
@@ -7766,27 +7794,27 @@
               <a:buNone/>
             </a:pPr>
             <a:r>
-              <a:rPr lang="en-US" sz="1200" b="1" kern="0" spc="100" dirty="0">
+              <a:rPr lang="en-US" sz="1100" b="1" kern="0" spc="50" dirty="0">
                 <a:solidFill>
                   <a:srgbClr val="BE123C"/>
                 </a:solidFill>
               </a:rPr>
-              <a:t>OPEN</a:t>
-            </a:r>
-            <a:endParaRPr lang="en-US" sz="1200" dirty="0"/>
-          </a:p>
-        </p:txBody>
-      </p:sp>
-      <p:sp>
-        <p:nvSpPr>
-          <p:cNvPr id="16" name="Text 13"/>
-          <p:cNvSpPr/>
-          <p:nvPr/>
-        </p:nvSpPr>
-        <p:spPr>
-          <a:xfrm>
-            <a:off x="2468880" y="5687568"/>
-            <a:ext cx="9052560" cy="384048"/>
+              <a:t>OPEN  (a residual survives)</a:t>
+            </a:r>
+            <a:endParaRPr lang="en-US" sz="1100" dirty="0"/>
+          </a:p>
+        </p:txBody>
+      </p:sp>
+      <p:sp>
+        <p:nvSpPr>
+          <p:cNvPr id="18" name="Text 15"/>
+          <p:cNvSpPr/>
+          <p:nvPr/>
+        </p:nvSpPr>
+        <p:spPr>
+          <a:xfrm>
+            <a:off x="3474720" y="5358384"/>
+            <a:ext cx="8138160" cy="603504"/>
           </a:xfrm>
           <a:prstGeom prst="rect">
             <a:avLst/>
@@ -7802,86 +7830,64 @@
               <a:buNone/>
             </a:pPr>
             <a:r>
-              <a:rPr lang="en-US" sz="1300" dirty="0">
+              <a:rPr lang="en-US" sz="1100" dirty="0">
                 <a:solidFill>
                   <a:srgbClr val="1B2B31"/>
                 </a:solidFill>
               </a:rPr>
-              <a:t>EPCAM / SPINT2 / B3GNT3 biliary genes stay significant — a rare intrinsic state not excluded; CXCL10 a separate inflammatory lead</a:t>
-            </a:r>
-            <a:endParaRPr lang="en-US" sz="1300" dirty="0"/>
-          </a:p>
-        </p:txBody>
-      </p:sp>
-      <p:sp>
-        <p:nvSpPr>
-          <p:cNvPr id="17" name="Shape 14"/>
-          <p:cNvSpPr/>
-          <p:nvPr/>
-        </p:nvSpPr>
-        <p:spPr>
-          <a:xfrm>
-            <a:off x="457200" y="6199632"/>
-            <a:ext cx="2926080" cy="0"/>
-          </a:xfrm>
-          <a:prstGeom prst="line">
+              <a:t>decontX removes about half the hits (64 → 34), but EPCAM / SPINT2 / B3GNT3 survive decontamination — ambient can’t explain all of it, so a rare intrinsic state is not excluded.</a:t>
+            </a:r>
+            <a:endParaRPr lang="en-US" sz="1100" dirty="0"/>
+          </a:p>
+        </p:txBody>
+      </p:sp>
+      <p:sp>
+        <p:nvSpPr>
+          <p:cNvPr id="19" name="Text 16"/>
+          <p:cNvSpPr/>
+          <p:nvPr/>
+        </p:nvSpPr>
+        <p:spPr>
+          <a:xfrm>
+            <a:off x="548640" y="6089904"/>
+            <a:ext cx="11247120" cy="320040"/>
+          </a:xfrm>
+          <a:prstGeom prst="rect">
             <a:avLst/>
           </a:prstGeom>
           <a:noFill/>
-          <a:ln w="9525">
-            <a:solidFill>
-              <a:srgbClr val="C9C0B2"/>
-            </a:solidFill>
-            <a:prstDash val="solid"/>
-          </a:ln>
-        </p:spPr>
-        <p:txBody>
-          <a:bodyPr/>
-          <a:lstStyle/>
-          <a:p>
-            <a:endParaRPr lang="en-US"/>
-          </a:p>
-        </p:txBody>
-      </p:sp>
-      <p:sp>
-        <p:nvSpPr>
-          <p:cNvPr id="18" name="Text 15"/>
-          <p:cNvSpPr/>
-          <p:nvPr/>
-        </p:nvSpPr>
-        <p:spPr>
-          <a:xfrm>
-            <a:off x="457200" y="6254496"/>
-            <a:ext cx="10607040" cy="237744"/>
-          </a:xfrm>
-          <a:prstGeom prst="rect">
-            <a:avLst/>
-          </a:prstGeom>
-          <a:noFill/>
-          <a:ln/>
-        </p:spPr>
-        <p:txBody>
-          <a:bodyPr wrap="square" lIns="0" tIns="0" rIns="0" bIns="0" rtlCol="0" anchor="ctr"/>
+          <a:ln/>
+        </p:spPr>
+        <p:txBody>
+          <a:bodyPr wrap="square" rtlCol="0" anchor="ctr"/>
           <a:lstStyle/>
           <a:p>
             <a:pPr marL="0" indent="0" algn="l">
               <a:buNone/>
             </a:pPr>
             <a:r>
-              <a:rPr lang="en-US" sz="1000" i="1" dirty="0">
-                <a:solidFill>
-                  <a:srgbClr val="6B6256"/>
-                </a:solidFill>
-              </a:rPr>
-              <a:t>¹ Ambient-RNA removal: decontX — Yang et al., Genome Biol. 2020.    Source attribution is a lead, not a closed verdict.</a:t>
-            </a:r>
-            <a:endParaRPr lang="en-US" sz="1000" dirty="0"/>
-          </a:p>
-        </p:txBody>
-      </p:sp>
-      <p:sp>
-        <p:nvSpPr>
-          <p:cNvPr id="19" name="Text 16"/>
+              <a:rPr lang="en-US" sz="1300" b="1" dirty="0">
+                <a:solidFill>
+                  <a:srgbClr val="123F47"/>
+                </a:solidFill>
+              </a:rPr>
+              <a:t>Verdict:  </a:t>
+            </a:r>
+            <a:r>
+              <a:rPr lang="en-US" sz="1300" i="1" dirty="0">
+                <a:solidFill>
+                  <a:srgbClr val="1B2B31"/>
+                </a:solidFill>
+              </a:rPr>
+              <a:t>most consistent with composition / ambient (the ductular reaction) — a lead, not a closed verdict.</a:t>
+            </a:r>
+            <a:endParaRPr lang="en-US" sz="1300" dirty="0"/>
+          </a:p>
+        </p:txBody>
+      </p:sp>
+      <p:sp>
+        <p:nvSpPr>
+          <p:cNvPr id="20" name="Text 17"/>
           <p:cNvSpPr/>
           <p:nvPr/>
         </p:nvSpPr>
@@ -7910,42 +7916,6 @@
                 </a:solidFill>
               </a:rPr>
               <a:t>Computational Genomics 76553  ·  HUJI  ·  MASLD snRNA-seq hackathon</a:t>
-            </a:r>
-            <a:endParaRPr lang="en-US" sz="1050" dirty="0"/>
-          </a:p>
-        </p:txBody>
-      </p:sp>
-      <p:sp>
-        <p:nvSpPr>
-          <p:cNvPr id="20" name="Text 17"/>
-          <p:cNvSpPr/>
-          <p:nvPr/>
-        </p:nvSpPr>
-        <p:spPr>
-          <a:xfrm>
-            <a:off x="11155680" y="6510528"/>
-            <a:ext cx="548640" cy="274320"/>
-          </a:xfrm>
-          <a:prstGeom prst="rect">
-            <a:avLst/>
-          </a:prstGeom>
-          <a:noFill/>
-          <a:ln/>
-        </p:spPr>
-        <p:txBody>
-          <a:bodyPr wrap="square" lIns="0" tIns="0" rIns="0" bIns="0" rtlCol="0" anchor="ctr"/>
-          <a:lstStyle/>
-          <a:p>
-            <a:pPr marL="0" indent="0" algn="r">
-              <a:buNone/>
-            </a:pPr>
-            <a:r>
-              <a:rPr lang="en-US" sz="1050" dirty="0">
-                <a:solidFill>
-                  <a:srgbClr val="5C6E73"/>
-                </a:solidFill>
-              </a:rPr>
-              <a:t>12</a:t>
             </a:r>
             <a:endParaRPr lang="en-US" sz="1050" dirty="0"/>
           </a:p>

</xml_diff>

<commit_message>
Result figures: per-donor dots + mean ± SEM; reconcile slide text + stamp equivalence
- make_figures.py: replace box-and-whisker with per-donor dots + stage mean ± SEM
  (donor = the replicate; SEM = SD/sqrt(n)); regenerate figures.
- Swap fig_result3 / fig_secondary into the canonical deck IN PLACE (manual layout
  preserved); reconcile slide 12 & 20 numbers to the donor means; clarify dual as
  "~0.4% per cell"; spell the TOST equivalence result out on the result slide
  (>±19 pp F4-F1 shift excluded; ≤10 pp drift not, F4 n=4); soften slide 20 headline
  to "Null is flat; the PP:PC ratio shows no stage trend".
- Cheat-sheet HTML: add page 2 — figure display choices + the honest claim ladder
  (never "intact"; no detectable signal; large shift excluded; subtle drift not).

Co-Authored-By: Claude Opus 4.8 <noreply@anthropic.com>
</commit_message>
<xml_diff>
--- a/presentation/MASLD_stages_computational_analysis_roee_shira.pptx
+++ b/presentation/MASLD_stages_computational_analysis_roee_shira.pptx
@@ -6039,7 +6039,7 @@
                   <a:srgbClr val="5C6E73"/>
                 </a:solidFill>
               </a:rPr>
-              <a:t>(box = per-donor spread; F0 n=2 omitted — in backup).</a:t>
+              <a:t>(each point = one donor; bar = stage mean ± SEM; F0 n=2 omitted — in backup).</a:t>
             </a:r>
             <a:endParaRPr lang="en-US" sz="1200" dirty="0"/>
           </a:p>
@@ -6132,7 +6132,7 @@
                   <a:srgbClr val="1B2B31"/>
                 </a:solidFill>
               </a:rPr>
-              <a:t>Dual stays ~0.4% (vs 2.9% in explants).
+              <a:t>Dual stays ~0.4% per cell (vs 2.9% in explants).
 </a:t>
             </a:r>
             <a:endParaRPr lang="en-US" sz="1400" dirty="0"/>
@@ -6168,7 +6168,7 @@
                   <a:srgbClr val="1B2B31"/>
                 </a:solidFill>
               </a:rPr>
-              <a:t>44/36/39/39%;  ratio ≈ 1.1.
+              <a:t>40/40/40/41%;  ratio ≈ 1.1–1.7.
 </a:t>
             </a:r>
             <a:endParaRPr lang="en-US" sz="1400" dirty="0"/>
@@ -6222,7 +6222,7 @@
                   <a:srgbClr val="5C6E73"/>
                 </a:solidFill>
               </a:rPr>
-              <a:t>Spread, the equivalence bound (&gt; ±19 pp excluded) and the 10-confounder audit — all in backup.</a:t>
+              <a:t>Equivalence (TOST): a &gt; ±19 pp F4–F1 shift is excluded; a ≤10 pp drift is not (F4 n=4). Spread + 10-confounder audit in backup.</a:t>
             </a:r>
             <a:endParaRPr lang="en-US" sz="1100" dirty="0"/>
           </a:p>
@@ -11903,7 +11903,7 @@
                 <a:ea typeface="Georgia" pitchFamily="34" charset="-122"/>
                 <a:cs typeface="Georgia" pitchFamily="34" charset="-120"/>
               </a:rPr>
-              <a:t>Null and the PP : PC ratio are flat too</a:t>
+              <a:t>Null is flat; the PP : PC ratio shows no stage trend</a:t>
             </a:r>
             <a:endParaRPr lang="en-US" sz="2600" dirty="0"/>
           </a:p>
@@ -11963,7 +11963,7 @@
                   <a:srgbClr val="5C6E73"/>
                 </a:solidFill>
               </a:rPr>
-              <a:t>Figure 7.  Null (double-negative) fraction and the periportal : pericentral anchor ratio across biopsy F1–F4 (box = per-donor spread; each point = one donor).</a:t>
+              <a:t>Figure 7.  Null (double-negative) fraction and the periportal : pericentral anchor ratio across biopsy F1–F4 (each point = one donor; bar = stage mean ± SEM).</a:t>
             </a:r>
             <a:endParaRPr lang="en-US" sz="1200" dirty="0"/>
           </a:p>
@@ -12007,7 +12007,7 @@
                   <a:srgbClr val="1B2B31"/>
                 </a:solidFill>
               </a:rPr>
-              <a:t>≈ 44 / 36 / 39 / 39% — no rise across stages.
+              <a:t>≈ 40 / 40 / 40 / 41% — no rise across stages.
 </a:t>
             </a:r>
             <a:endParaRPr lang="en-US" sz="1350" dirty="0"/>
@@ -12030,7 +12030,7 @@
                   <a:srgbClr val="1B2B31"/>
                 </a:solidFill>
               </a:rPr>
-              <a:t>≈ 1.16 / 1.01 / 1.10 / 1.18 — hovers around the balanced 1 : 1 line.
+              <a:t>≈ 1.20 / 1.25 / 1.67 / 1.07 — near the 1 : 1 line (F3 pulled by one high donor).
 </a:t>
             </a:r>
             <a:endParaRPr lang="en-US" sz="1350" dirty="0"/>

</xml_diff>

<commit_message>
Deck: rename appendix to QA; add "Thank you — now QA" closing slide
- Relabel the 13 appendix slides BACKUP -> QA (kickers); "in backup" -> "in QA"
  on the result slide.
- Add a closing "Thank you — now QA" slide after the conclusion, in the deck's
  dark separator style, with a liver-lobule zonation motif and a one-line joke
  ("No hepatocytes lost their identity in the making of this talk").
  Inserted via PowerPoint InsertFromFile; thankyou_qa.js + assets/thankyou_art.png
  are the sources.

Co-Authored-By: Claude Opus 4.8 <noreply@anthropic.com>
</commit_message>
<xml_diff>
--- a/presentation/MASLD_stages_computational_analysis_roee_shira.pptx
+++ b/presentation/MASLD_stages_computational_analysis_roee_shira.pptx
@@ -5,7 +5,7 @@
     <p:sldMasterId id="2147483648" r:id="rId1"/>
   </p:sldMasterIdLst>
   <p:notesMasterIdLst>
-    <p:notesMasterId r:id="rId32"/>
+    <p:notesMasterId r:id="rId33"/>
   </p:notesMasterIdLst>
   <p:sldIdLst>
     <p:sldId id="256" r:id="rId2"/>
@@ -25,19 +25,20 @@
     <p:sldId id="287" r:id="rId16"/>
     <p:sldId id="269" r:id="rId17"/>
     <p:sldId id="271" r:id="rId18"/>
-    <p:sldId id="272" r:id="rId19"/>
-    <p:sldId id="286" r:id="rId20"/>
-    <p:sldId id="273" r:id="rId21"/>
-    <p:sldId id="274" r:id="rId22"/>
-    <p:sldId id="275" r:id="rId23"/>
-    <p:sldId id="276" r:id="rId24"/>
-    <p:sldId id="277" r:id="rId25"/>
-    <p:sldId id="278" r:id="rId26"/>
-    <p:sldId id="279" r:id="rId27"/>
-    <p:sldId id="280" r:id="rId28"/>
-    <p:sldId id="281" r:id="rId29"/>
-    <p:sldId id="282" r:id="rId30"/>
-    <p:sldId id="283" r:id="rId31"/>
+    <p:sldId id="288" r:id="rId19"/>
+    <p:sldId id="272" r:id="rId20"/>
+    <p:sldId id="286" r:id="rId21"/>
+    <p:sldId id="273" r:id="rId22"/>
+    <p:sldId id="274" r:id="rId23"/>
+    <p:sldId id="275" r:id="rId24"/>
+    <p:sldId id="276" r:id="rId25"/>
+    <p:sldId id="277" r:id="rId26"/>
+    <p:sldId id="278" r:id="rId27"/>
+    <p:sldId id="279" r:id="rId28"/>
+    <p:sldId id="280" r:id="rId29"/>
+    <p:sldId id="281" r:id="rId30"/>
+    <p:sldId id="282" r:id="rId31"/>
+    <p:sldId id="283" r:id="rId32"/>
   </p:sldIdLst>
   <p:sldSz cx="12192000" cy="6858000"/>
   <p:notesSz cx="6858000" cy="12192000"/>
@@ -1177,13 +1178,6 @@
           </p:nvPr>
         </p:nvSpPr>
         <p:spPr/>
-        <p:txBody>
-          <a:bodyPr/>
-          <a:lstStyle/>
-          <a:p>
-            <a:endParaRPr lang="en-US"/>
-          </a:p>
-        </p:txBody>
       </p:sp>
       <p:sp>
         <p:nvSpPr>
@@ -1230,7 +1224,7 @@
     </p:spTree>
     <p:extLst>
       <p:ext uri="{BB962C8B-B14F-4D97-AF65-F5344CB8AC3E}">
-        <p14:creationId xmlns:p14="http://schemas.microsoft.com/office/powerpoint/2010/main" val="1024086991"/>
+        <p14:creationId xmlns:p14="http://schemas.microsoft.com/office/powerpoint/2010/main" val="1343514524"/>
       </p:ext>
     </p:extLst>
   </p:cSld>
@@ -1268,6 +1262,13 @@
           </p:nvPr>
         </p:nvSpPr>
         <p:spPr/>
+        <p:txBody>
+          <a:bodyPr/>
+          <a:lstStyle/>
+          <a:p>
+            <a:endParaRPr lang="en-US"/>
+          </a:p>
+        </p:txBody>
       </p:sp>
       <p:sp>
         <p:nvSpPr>
@@ -1303,71 +1304,11 @@
           <a:bodyPr/>
           <a:lstStyle/>
           <a:p>
-            <a:pPr marL="0" marR="0" lvl="0" indent="0" algn="l" defTabSz="914400" rtl="0" eaLnBrk="1" fontAlgn="auto" latinLnBrk="0" hangingPunct="1">
-              <a:lnSpc>
-                <a:spcPct val="100000"/>
-              </a:lnSpc>
-              <a:spcBef>
-                <a:spcPts val="0"/>
-              </a:spcBef>
-              <a:spcAft>
-                <a:spcPts val="0"/>
-              </a:spcAft>
-              <a:buClrTx/>
-              <a:buSzTx/>
-              <a:buFontTx/>
-              <a:buNone/>
-              <a:tabLst/>
-              <a:defRPr/>
-            </a:pPr>
             <a:fld id="{F7021451-1387-4CA6-816F-3879F97B5CBC}" type="slidenum">
-              <a:rPr kumimoji="0" lang="en-US" sz="1800" b="0" i="0" u="none" strike="noStrike" kern="1200" cap="none" spc="0" normalizeH="0" baseline="0" noProof="0">
-                <a:ln>
-                  <a:noFill/>
-                </a:ln>
-                <a:solidFill>
-                  <a:prstClr val="black"/>
-                </a:solidFill>
-                <a:effectLst/>
-                <a:uLnTx/>
-                <a:uFillTx/>
-                <a:latin typeface="Calibri" panose="020F0502020204030204"/>
-                <a:ea typeface="+mn-ea"/>
-                <a:cs typeface="+mn-cs"/>
-              </a:rPr>
-              <a:pPr marL="0" marR="0" lvl="0" indent="0" algn="l" defTabSz="914400" rtl="0" eaLnBrk="1" fontAlgn="auto" latinLnBrk="0" hangingPunct="1">
-                <a:lnSpc>
-                  <a:spcPct val="100000"/>
-                </a:lnSpc>
-                <a:spcBef>
-                  <a:spcPts val="0"/>
-                </a:spcBef>
-                <a:spcAft>
-                  <a:spcPts val="0"/>
-                </a:spcAft>
-                <a:buClrTx/>
-                <a:buSzTx/>
-                <a:buFontTx/>
-                <a:buNone/>
-                <a:tabLst/>
-                <a:defRPr/>
-              </a:pPr>
+              <a:rPr lang="en-US"/>
               <a:t>19</a:t>
             </a:fld>
-            <a:endParaRPr kumimoji="0" lang="en-US" sz="1800" b="0" i="0" u="none" strike="noStrike" kern="1200" cap="none" spc="0" normalizeH="0" baseline="0" noProof="0">
-              <a:ln>
-                <a:noFill/>
-              </a:ln>
-              <a:solidFill>
-                <a:prstClr val="black"/>
-              </a:solidFill>
-              <a:effectLst/>
-              <a:uLnTx/>
-              <a:uFillTx/>
-              <a:latin typeface="Calibri" panose="020F0502020204030204"/>
-              <a:ea typeface="+mn-ea"/>
-              <a:cs typeface="+mn-cs"/>
-            </a:endParaRPr>
+            <a:endParaRPr lang="en-US"/>
           </a:p>
         </p:txBody>
       </p:sp>
@@ -1506,13 +1447,6 @@
           </p:nvPr>
         </p:nvSpPr>
         <p:spPr/>
-        <p:txBody>
-          <a:bodyPr/>
-          <a:lstStyle/>
-          <a:p>
-            <a:endParaRPr lang="en-US"/>
-          </a:p>
-        </p:txBody>
       </p:sp>
       <p:sp>
         <p:nvSpPr>
@@ -1548,11 +1482,71 @@
           <a:bodyPr/>
           <a:lstStyle/>
           <a:p>
+            <a:pPr marL="0" marR="0" lvl="0" indent="0" algn="l" defTabSz="914400" rtl="0" eaLnBrk="1" fontAlgn="auto" latinLnBrk="0" hangingPunct="1">
+              <a:lnSpc>
+                <a:spcPct val="100000"/>
+              </a:lnSpc>
+              <a:spcBef>
+                <a:spcPts val="0"/>
+              </a:spcBef>
+              <a:spcAft>
+                <a:spcPts val="0"/>
+              </a:spcAft>
+              <a:buClrTx/>
+              <a:buSzTx/>
+              <a:buFontTx/>
+              <a:buNone/>
+              <a:tabLst/>
+              <a:defRPr/>
+            </a:pPr>
             <a:fld id="{F7021451-1387-4CA6-816F-3879F97B5CBC}" type="slidenum">
-              <a:rPr lang="en-US"/>
+              <a:rPr kumimoji="0" lang="en-US" sz="1800" b="0" i="0" u="none" strike="noStrike" kern="1200" cap="none" spc="0" normalizeH="0" baseline="0" noProof="0">
+                <a:ln>
+                  <a:noFill/>
+                </a:ln>
+                <a:solidFill>
+                  <a:prstClr val="black"/>
+                </a:solidFill>
+                <a:effectLst/>
+                <a:uLnTx/>
+                <a:uFillTx/>
+                <a:latin typeface="Calibri" panose="020F0502020204030204"/>
+                <a:ea typeface="+mn-ea"/>
+                <a:cs typeface="+mn-cs"/>
+              </a:rPr>
+              <a:pPr marL="0" marR="0" lvl="0" indent="0" algn="l" defTabSz="914400" rtl="0" eaLnBrk="1" fontAlgn="auto" latinLnBrk="0" hangingPunct="1">
+                <a:lnSpc>
+                  <a:spcPct val="100000"/>
+                </a:lnSpc>
+                <a:spcBef>
+                  <a:spcPts val="0"/>
+                </a:spcBef>
+                <a:spcAft>
+                  <a:spcPts val="0"/>
+                </a:spcAft>
+                <a:buClrTx/>
+                <a:buSzTx/>
+                <a:buFontTx/>
+                <a:buNone/>
+                <a:tabLst/>
+                <a:defRPr/>
+              </a:pPr>
               <a:t>20</a:t>
             </a:fld>
-            <a:endParaRPr lang="en-US"/>
+            <a:endParaRPr kumimoji="0" lang="en-US" sz="1800" b="0" i="0" u="none" strike="noStrike" kern="1200" cap="none" spc="0" normalizeH="0" baseline="0" noProof="0">
+              <a:ln>
+                <a:noFill/>
+              </a:ln>
+              <a:solidFill>
+                <a:prstClr val="black"/>
+              </a:solidFill>
+              <a:effectLst/>
+              <a:uLnTx/>
+              <a:uFillTx/>
+              <a:latin typeface="Calibri" panose="020F0502020204030204"/>
+              <a:ea typeface="+mn-ea"/>
+              <a:cs typeface="+mn-cs"/>
+            </a:endParaRPr>
           </a:p>
         </p:txBody>
       </p:sp>
@@ -2552,6 +2546,97 @@
             <a:fld id="{F7021451-1387-4CA6-816F-3879F97B5CBC}" type="slidenum">
               <a:rPr lang="en-US"/>
               <a:t>30</a:t>
+            </a:fld>
+            <a:endParaRPr lang="en-US"/>
+          </a:p>
+        </p:txBody>
+      </p:sp>
+    </p:spTree>
+    <p:extLst>
+      <p:ext uri="{BB962C8B-B14F-4D97-AF65-F5344CB8AC3E}">
+        <p14:creationId xmlns:p14="http://schemas.microsoft.com/office/powerpoint/2010/main" val="1024086991"/>
+      </p:ext>
+    </p:extLst>
+  </p:cSld>
+  <p:clrMapOvr>
+    <a:masterClrMapping/>
+  </p:clrMapOvr>
+</p:notes>
+</file>
+
+<file path=ppt/notesSlides/notesSlide31.xml><?xml version="1.0" encoding="utf-8"?>
+<p:notes xmlns:a="http://schemas.openxmlformats.org/drawingml/2006/main" xmlns:r="http://schemas.openxmlformats.org/officeDocument/2006/relationships" xmlns:p="http://schemas.openxmlformats.org/presentationml/2006/main">
+  <p:cSld>
+    <p:spTree>
+      <p:nvGrpSpPr>
+        <p:cNvPr id="1" name=""/>
+        <p:cNvGrpSpPr/>
+        <p:nvPr/>
+      </p:nvGrpSpPr>
+      <p:grpSpPr>
+        <a:xfrm>
+          <a:off x="0" y="0"/>
+          <a:ext cx="0" cy="0"/>
+          <a:chOff x="0" y="0"/>
+          <a:chExt cx="0" cy="0"/>
+        </a:xfrm>
+      </p:grpSpPr>
+      <p:sp>
+        <p:nvSpPr>
+          <p:cNvPr id="2" name="Slide Image Placeholder 1"/>
+          <p:cNvSpPr>
+            <a:spLocks noGrp="1" noRot="1" noChangeAspect="1"/>
+          </p:cNvSpPr>
+          <p:nvPr>
+            <p:ph type="sldImg"/>
+          </p:nvPr>
+        </p:nvSpPr>
+        <p:spPr/>
+        <p:txBody>
+          <a:bodyPr/>
+          <a:lstStyle/>
+          <a:p>
+            <a:endParaRPr lang="en-US"/>
+          </a:p>
+        </p:txBody>
+      </p:sp>
+      <p:sp>
+        <p:nvSpPr>
+          <p:cNvPr id="3" name="Notes Placeholder 2"/>
+          <p:cNvSpPr>
+            <a:spLocks noGrp="1"/>
+          </p:cNvSpPr>
+          <p:nvPr>
+            <p:ph type="body" idx="1"/>
+          </p:nvPr>
+        </p:nvSpPr>
+        <p:spPr/>
+        <p:txBody>
+          <a:bodyPr/>
+          <a:lstStyle/>
+          <a:p>
+            <a:endParaRPr lang="en-US" dirty="0"/>
+          </a:p>
+        </p:txBody>
+      </p:sp>
+      <p:sp>
+        <p:nvSpPr>
+          <p:cNvPr id="4" name="Slide Number Placeholder 3"/>
+          <p:cNvSpPr>
+            <a:spLocks noGrp="1"/>
+          </p:cNvSpPr>
+          <p:nvPr>
+            <p:ph type="sldNum" sz="quarter" idx="10"/>
+          </p:nvPr>
+        </p:nvSpPr>
+        <p:spPr/>
+        <p:txBody>
+          <a:bodyPr/>
+          <a:lstStyle/>
+          <a:p>
+            <a:fld id="{F7021451-1387-4CA6-816F-3879F97B5CBC}" type="slidenum">
+              <a:rPr lang="en-US"/>
+              <a:t>31</a:t>
             </a:fld>
             <a:endParaRPr lang="en-US"/>
           </a:p>
@@ -6039,7 +6124,7 @@
                   <a:srgbClr val="5C6E73"/>
                 </a:solidFill>
               </a:rPr>
-              <a:t>(each point = one donor; bar = stage mean ± SEM; F0 n=2 omitted — in backup).</a:t>
+              <a:t>(each point = one donor; bar = stage mean ± SEM; F0 n=2 omitted — in QA).</a:t>
             </a:r>
             <a:endParaRPr lang="en-US" sz="1200" dirty="0"/>
           </a:p>
@@ -6222,7 +6307,7 @@
                   <a:srgbClr val="5C6E73"/>
                 </a:solidFill>
               </a:rPr>
-              <a:t>Equivalence (TOST): a &gt; ±19 pp F4–F1 shift is excluded; a ≤10 pp drift is not (F4 n=4). Spread + 10-confounder audit in backup.</a:t>
+              <a:t>Equivalence (TOST): a &gt; ±19 pp F4–F1 shift is excluded; a ≤10 pp drift is not (F4 n=4). Spread + 10-confounder audit in QA.</a:t>
             </a:r>
             <a:endParaRPr lang="en-US" sz="1100" dirty="0"/>
           </a:p>
@@ -9013,6 +9098,267 @@
 
 <file path=ppt/slides/slide18.xml><?xml version="1.0" encoding="utf-8"?>
 <p:sld xmlns:a="http://schemas.openxmlformats.org/drawingml/2006/main" xmlns:r="http://schemas.openxmlformats.org/officeDocument/2006/relationships" xmlns:p="http://schemas.openxmlformats.org/presentationml/2006/main">
+  <p:cSld>
+    <p:spTree>
+      <p:nvGrpSpPr>
+        <p:cNvPr id="1" name=""/>
+        <p:cNvGrpSpPr/>
+        <p:nvPr/>
+      </p:nvGrpSpPr>
+      <p:grpSpPr>
+        <a:xfrm>
+          <a:off x="0" y="0"/>
+          <a:ext cx="0" cy="0"/>
+          <a:chOff x="0" y="0"/>
+          <a:chExt cx="0" cy="0"/>
+        </a:xfrm>
+      </p:grpSpPr>
+      <p:sp>
+        <p:nvSpPr>
+          <p:cNvPr id="2" name="Shape 0"/>
+          <p:cNvSpPr/>
+          <p:nvPr/>
+        </p:nvSpPr>
+        <p:spPr>
+          <a:xfrm>
+            <a:off x="0" y="0"/>
+            <a:ext cx="12191695" cy="6858000"/>
+          </a:xfrm>
+          <a:prstGeom prst="rect">
+            <a:avLst/>
+          </a:prstGeom>
+          <a:solidFill>
+            <a:srgbClr val="16242B"/>
+          </a:solidFill>
+          <a:ln/>
+        </p:spPr>
+      </p:sp>
+      <p:sp>
+        <p:nvSpPr>
+          <p:cNvPr id="3" name="Shape 1"/>
+          <p:cNvSpPr/>
+          <p:nvPr/>
+        </p:nvSpPr>
+        <p:spPr>
+          <a:xfrm>
+            <a:off x="0" y="0"/>
+            <a:ext cx="256032" cy="6858000"/>
+          </a:xfrm>
+          <a:prstGeom prst="rect">
+            <a:avLst/>
+          </a:prstGeom>
+          <a:solidFill>
+            <a:srgbClr val="1B6E78"/>
+          </a:solidFill>
+          <a:ln/>
+        </p:spPr>
+      </p:sp>
+      <p:sp>
+        <p:nvSpPr>
+          <p:cNvPr id="4" name="Shape 2"/>
+          <p:cNvSpPr/>
+          <p:nvPr/>
+        </p:nvSpPr>
+        <p:spPr>
+          <a:xfrm>
+            <a:off x="256032" y="0"/>
+            <a:ext cx="109728" cy="6858000"/>
+          </a:xfrm>
+          <a:prstGeom prst="rect">
+            <a:avLst/>
+          </a:prstGeom>
+          <a:solidFill>
+            <a:srgbClr val="C0561B"/>
+          </a:solidFill>
+          <a:ln/>
+        </p:spPr>
+      </p:sp>
+      <p:pic>
+        <p:nvPicPr>
+          <p:cNvPr id="5" name="Image 0" descr="D:\CS\Genomics\Hackathon\presentation/assets/thankyou_art.png"/>
+          <p:cNvPicPr>
+            <a:picLocks noChangeAspect="1"/>
+          </p:cNvPicPr>
+          <p:nvPr/>
+        </p:nvPicPr>
+        <p:blipFill>
+          <a:blip r:embed="rId3"/>
+          <a:stretch>
+            <a:fillRect/>
+          </a:stretch>
+        </p:blipFill>
+        <p:spPr>
+          <a:xfrm>
+            <a:off x="7863840" y="1463040"/>
+            <a:ext cx="4023360" cy="4023360"/>
+          </a:xfrm>
+          <a:prstGeom prst="rect">
+            <a:avLst/>
+          </a:prstGeom>
+        </p:spPr>
+      </p:pic>
+      <p:sp>
+        <p:nvSpPr>
+          <p:cNvPr id="6" name="Text 3"/>
+          <p:cNvSpPr/>
+          <p:nvPr/>
+        </p:nvSpPr>
+        <p:spPr>
+          <a:xfrm>
+            <a:off x="868680" y="2148840"/>
+            <a:ext cx="6858000" cy="1188720"/>
+          </a:xfrm>
+          <a:prstGeom prst="rect">
+            <a:avLst/>
+          </a:prstGeom>
+          <a:noFill/>
+          <a:ln/>
+        </p:spPr>
+        <p:txBody>
+          <a:bodyPr wrap="square" rtlCol="0" anchor="ctr"/>
+          <a:lstStyle/>
+          <a:p>
+            <a:pPr marL="0" indent="0" algn="l">
+              <a:buNone/>
+            </a:pPr>
+            <a:r>
+              <a:rPr lang="en-US" sz="5200" b="1" dirty="0">
+                <a:solidFill>
+                  <a:srgbClr val="FFFFFF"/>
+                </a:solidFill>
+                <a:latin typeface="Georgia" pitchFamily="34" charset="0"/>
+                <a:ea typeface="Georgia" pitchFamily="34" charset="-122"/>
+                <a:cs typeface="Georgia" pitchFamily="34" charset="-120"/>
+              </a:rPr>
+              <a:t>Thank you</a:t>
+            </a:r>
+            <a:endParaRPr lang="en-US" sz="5200" dirty="0"/>
+          </a:p>
+        </p:txBody>
+      </p:sp>
+      <p:sp>
+        <p:nvSpPr>
+          <p:cNvPr id="7" name="Text 4"/>
+          <p:cNvSpPr/>
+          <p:nvPr/>
+        </p:nvSpPr>
+        <p:spPr>
+          <a:xfrm>
+            <a:off x="896112" y="3493008"/>
+            <a:ext cx="6858000" cy="502920"/>
+          </a:xfrm>
+          <a:prstGeom prst="rect">
+            <a:avLst/>
+          </a:prstGeom>
+          <a:noFill/>
+          <a:ln/>
+        </p:spPr>
+        <p:txBody>
+          <a:bodyPr wrap="square" rtlCol="0" anchor="ctr"/>
+          <a:lstStyle/>
+          <a:p>
+            <a:pPr marL="0" indent="0" algn="l">
+              <a:buNone/>
+            </a:pPr>
+            <a:r>
+              <a:rPr lang="en-US" sz="1800" i="1" dirty="0">
+                <a:solidFill>
+                  <a:srgbClr val="9FC0C4"/>
+                </a:solidFill>
+              </a:rPr>
+              <a:t>now — QA:  your questions</a:t>
+            </a:r>
+            <a:endParaRPr lang="en-US" sz="1800" dirty="0"/>
+          </a:p>
+        </p:txBody>
+      </p:sp>
+      <p:sp>
+        <p:nvSpPr>
+          <p:cNvPr id="8" name="Text 5"/>
+          <p:cNvSpPr/>
+          <p:nvPr/>
+        </p:nvSpPr>
+        <p:spPr>
+          <a:xfrm>
+            <a:off x="896112" y="4187952"/>
+            <a:ext cx="6858000" cy="457200"/>
+          </a:xfrm>
+          <a:prstGeom prst="rect">
+            <a:avLst/>
+          </a:prstGeom>
+          <a:noFill/>
+          <a:ln/>
+        </p:spPr>
+        <p:txBody>
+          <a:bodyPr wrap="square" rtlCol="0" anchor="ctr"/>
+          <a:lstStyle/>
+          <a:p>
+            <a:pPr marL="0" indent="0" algn="l">
+              <a:buNone/>
+            </a:pPr>
+            <a:r>
+              <a:rPr lang="en-US" sz="1350" i="1" dirty="0">
+                <a:solidFill>
+                  <a:srgbClr val="C0561B"/>
+                </a:solidFill>
+              </a:rPr>
+              <a:t>No hepatocytes lost their identity in the making of this talk.</a:t>
+            </a:r>
+            <a:endParaRPr lang="en-US" sz="1350" dirty="0"/>
+          </a:p>
+        </p:txBody>
+      </p:sp>
+      <p:sp>
+        <p:nvSpPr>
+          <p:cNvPr id="9" name="Text 6"/>
+          <p:cNvSpPr/>
+          <p:nvPr/>
+        </p:nvSpPr>
+        <p:spPr>
+          <a:xfrm>
+            <a:off x="896112" y="6126480"/>
+            <a:ext cx="10607040" cy="365760"/>
+          </a:xfrm>
+          <a:prstGeom prst="rect">
+            <a:avLst/>
+          </a:prstGeom>
+          <a:noFill/>
+          <a:ln/>
+        </p:spPr>
+        <p:txBody>
+          <a:bodyPr wrap="square" rtlCol="0" anchor="ctr"/>
+          <a:lstStyle/>
+          <a:p>
+            <a:pPr marL="0" indent="0" algn="l">
+              <a:buNone/>
+            </a:pPr>
+            <a:r>
+              <a:rPr lang="en-US" sz="1300" dirty="0">
+                <a:solidFill>
+                  <a:srgbClr val="7E8F8B"/>
+                </a:solidFill>
+              </a:rPr>
+              <a:t>Roee Tekoah  ·  Shira Gelbstein  ·  Computational Genomics 76553 · HUJI</a:t>
+            </a:r>
+            <a:endParaRPr lang="en-US" sz="1300" dirty="0"/>
+          </a:p>
+        </p:txBody>
+      </p:sp>
+    </p:spTree>
+    <p:extLst>
+      <p:ext uri="{BB962C8B-B14F-4D97-AF65-F5344CB8AC3E}">
+        <p14:creationId xmlns:p14="http://schemas.microsoft.com/office/powerpoint/2010/main" val="2103298401"/>
+      </p:ext>
+    </p:extLst>
+  </p:cSld>
+  <p:clrMapOvr>
+    <a:masterClrMapping/>
+  </p:clrMapOvr>
+</p:sld>
+</file>
+
+<file path=ppt/slides/slide19.xml><?xml version="1.0" encoding="utf-8"?>
+<p:sld xmlns:a="http://schemas.openxmlformats.org/drawingml/2006/main" xmlns:r="http://schemas.openxmlformats.org/officeDocument/2006/relationships" xmlns:p="http://schemas.openxmlformats.org/presentationml/2006/main">
   <p:cSld name="Slide 17">
     <p:bg>
       <p:bgPr>
@@ -9093,7 +9439,7 @@
                   <a:srgbClr val="C0561B"/>
                 </a:solidFill>
               </a:rPr>
-              <a:t>BACKUP  ·  SCOPE</a:t>
+              <a:t>QA  ·  SCOPE</a:t>
             </a:r>
             <a:endParaRPr lang="en-US" sz="1300" dirty="0"/>
           </a:p>
@@ -9229,1685 +9575,6 @@
               <a:t>We agree the strong signal is an end-stage phenomenon.</a:t>
             </a:r>
             <a:endParaRPr lang="en-US" sz="2000" dirty="0"/>
-          </a:p>
-        </p:txBody>
-      </p:sp>
-    </p:spTree>
-  </p:cSld>
-  <p:clrMapOvr>
-    <a:masterClrMapping/>
-  </p:clrMapOvr>
-</p:sld>
-</file>
-
-<file path=ppt/slides/slide19.xml><?xml version="1.0" encoding="utf-8"?>
-<p:sld xmlns:a="http://schemas.openxmlformats.org/drawingml/2006/main" xmlns:r="http://schemas.openxmlformats.org/officeDocument/2006/relationships" xmlns:p="http://schemas.openxmlformats.org/presentationml/2006/main">
-  <p:cSld>
-    <p:bg>
-      <p:bgPr>
-        <a:solidFill>
-          <a:srgbClr val="F7F5F1"/>
-        </a:solidFill>
-        <a:effectLst/>
-      </p:bgPr>
-    </p:bg>
-    <p:spTree>
-      <p:nvGrpSpPr>
-        <p:cNvPr id="1" name=""/>
-        <p:cNvGrpSpPr/>
-        <p:nvPr/>
-      </p:nvGrpSpPr>
-      <p:grpSpPr>
-        <a:xfrm>
-          <a:off x="0" y="0"/>
-          <a:ext cx="0" cy="0"/>
-          <a:chOff x="0" y="0"/>
-          <a:chExt cx="0" cy="0"/>
-        </a:xfrm>
-      </p:grpSpPr>
-      <p:sp>
-        <p:nvSpPr>
-          <p:cNvPr id="2" name="Shape 0"/>
-          <p:cNvSpPr/>
-          <p:nvPr/>
-        </p:nvSpPr>
-        <p:spPr>
-          <a:xfrm>
-            <a:off x="457200" y="310896"/>
-            <a:ext cx="146304" cy="237744"/>
-          </a:xfrm>
-          <a:prstGeom prst="rect">
-            <a:avLst/>
-          </a:prstGeom>
-          <a:solidFill>
-            <a:srgbClr val="C0561B"/>
-          </a:solidFill>
-          <a:ln/>
-        </p:spPr>
-      </p:sp>
-      <p:sp>
-        <p:nvSpPr>
-          <p:cNvPr id="3" name="Text 1"/>
-          <p:cNvSpPr/>
-          <p:nvPr/>
-        </p:nvSpPr>
-        <p:spPr>
-          <a:xfrm>
-            <a:off x="676656" y="274320"/>
-            <a:ext cx="7863840" cy="320040"/>
-          </a:xfrm>
-          <a:prstGeom prst="rect">
-            <a:avLst/>
-          </a:prstGeom>
-          <a:noFill/>
-          <a:ln/>
-        </p:spPr>
-        <p:txBody>
-          <a:bodyPr wrap="square" lIns="0" tIns="0" rIns="0" bIns="0" rtlCol="0" anchor="ctr"/>
-          <a:lstStyle/>
-          <a:p>
-            <a:pPr marL="0" marR="0" lvl="0" indent="0" algn="l" defTabSz="914400" rtl="0" eaLnBrk="1" fontAlgn="auto" latinLnBrk="0" hangingPunct="1">
-              <a:lnSpc>
-                <a:spcPct val="100000"/>
-              </a:lnSpc>
-              <a:spcBef>
-                <a:spcPts val="0"/>
-              </a:spcBef>
-              <a:spcAft>
-                <a:spcPts val="0"/>
-              </a:spcAft>
-              <a:buClrTx/>
-              <a:buSzTx/>
-              <a:buFontTx/>
-              <a:buNone/>
-              <a:tabLst/>
-              <a:defRPr/>
-            </a:pPr>
-            <a:r>
-              <a:rPr kumimoji="0" lang="en-US" sz="1300" b="1" i="0" u="none" strike="noStrike" kern="0" cap="none" spc="300" normalizeH="0" baseline="0" noProof="0" dirty="0">
-                <a:ln>
-                  <a:noFill/>
-                </a:ln>
-                <a:solidFill>
-                  <a:srgbClr val="C0561B"/>
-                </a:solidFill>
-                <a:effectLst/>
-                <a:uLnTx/>
-                <a:uFillTx/>
-                <a:latin typeface="Calibri" panose="020F0502020204030204"/>
-                <a:ea typeface="+mn-ea"/>
-                <a:cs typeface="+mn-cs"/>
-              </a:rPr>
-              <a:t>DONOR VARIANCE</a:t>
-            </a:r>
-            <a:endParaRPr kumimoji="0" lang="en-US" sz="1300" b="0" i="0" u="none" strike="noStrike" kern="1200" cap="none" spc="0" normalizeH="0" baseline="0" noProof="0" dirty="0">
-              <a:ln>
-                <a:noFill/>
-              </a:ln>
-              <a:solidFill>
-                <a:prstClr val="black"/>
-              </a:solidFill>
-              <a:effectLst/>
-              <a:uLnTx/>
-              <a:uFillTx/>
-              <a:latin typeface="Calibri" panose="020F0502020204030204"/>
-              <a:ea typeface="+mn-ea"/>
-              <a:cs typeface="+mn-cs"/>
-            </a:endParaRPr>
-          </a:p>
-        </p:txBody>
-      </p:sp>
-      <p:sp>
-        <p:nvSpPr>
-          <p:cNvPr id="4" name="Text 2"/>
-          <p:cNvSpPr/>
-          <p:nvPr/>
-        </p:nvSpPr>
-        <p:spPr>
-          <a:xfrm>
-            <a:off x="8595360" y="292608"/>
-            <a:ext cx="3154680" cy="274320"/>
-          </a:xfrm>
-          <a:prstGeom prst="rect">
-            <a:avLst/>
-          </a:prstGeom>
-          <a:noFill/>
-          <a:ln/>
-        </p:spPr>
-        <p:txBody>
-          <a:bodyPr wrap="square" lIns="0" tIns="0" rIns="0" bIns="0" rtlCol="0" anchor="ctr"/>
-          <a:lstStyle/>
-          <a:p>
-            <a:pPr marL="0" marR="0" lvl="0" indent="0" algn="r" defTabSz="914400" rtl="0" eaLnBrk="1" fontAlgn="auto" latinLnBrk="0" hangingPunct="1">
-              <a:lnSpc>
-                <a:spcPct val="100000"/>
-              </a:lnSpc>
-              <a:spcBef>
-                <a:spcPts val="0"/>
-              </a:spcBef>
-              <a:spcAft>
-                <a:spcPts val="0"/>
-              </a:spcAft>
-              <a:buClrTx/>
-              <a:buSzTx/>
-              <a:buFontTx/>
-              <a:buNone/>
-              <a:tabLst/>
-              <a:defRPr/>
-            </a:pPr>
-            <a:r>
-              <a:rPr kumimoji="0" lang="en-US" sz="1100" b="1" i="0" u="none" strike="noStrike" kern="0" cap="none" spc="200" normalizeH="0" baseline="0" noProof="0" dirty="0">
-                <a:ln>
-                  <a:noFill/>
-                </a:ln>
-                <a:solidFill>
-                  <a:srgbClr val="1B6E78"/>
-                </a:solidFill>
-                <a:effectLst/>
-                <a:uLnTx/>
-                <a:uFillTx/>
-                <a:latin typeface="Calibri" panose="020F0502020204030204"/>
-                <a:ea typeface="+mn-ea"/>
-                <a:cs typeface="+mn-cs"/>
-              </a:rPr>
-              <a:t>BACKUP</a:t>
-            </a:r>
-            <a:endParaRPr kumimoji="0" lang="en-US" sz="1100" b="0" i="0" u="none" strike="noStrike" kern="1200" cap="none" spc="0" normalizeH="0" baseline="0" noProof="0" dirty="0">
-              <a:ln>
-                <a:noFill/>
-              </a:ln>
-              <a:solidFill>
-                <a:prstClr val="black"/>
-              </a:solidFill>
-              <a:effectLst/>
-              <a:uLnTx/>
-              <a:uFillTx/>
-              <a:latin typeface="Calibri" panose="020F0502020204030204"/>
-              <a:ea typeface="+mn-ea"/>
-              <a:cs typeface="+mn-cs"/>
-            </a:endParaRPr>
-          </a:p>
-        </p:txBody>
-      </p:sp>
-      <p:sp>
-        <p:nvSpPr>
-          <p:cNvPr id="5" name="Text 3"/>
-          <p:cNvSpPr/>
-          <p:nvPr/>
-        </p:nvSpPr>
-        <p:spPr>
-          <a:xfrm>
-            <a:off x="438912" y="585216"/>
-            <a:ext cx="11338560" cy="777240"/>
-          </a:xfrm>
-          <a:prstGeom prst="rect">
-            <a:avLst/>
-          </a:prstGeom>
-          <a:noFill/>
-          <a:ln/>
-        </p:spPr>
-        <p:txBody>
-          <a:bodyPr wrap="square" lIns="0" tIns="0" rIns="0" bIns="0" rtlCol="0" anchor="t"/>
-          <a:lstStyle/>
-          <a:p>
-            <a:pPr marL="0" marR="0" lvl="0" indent="0" algn="l" defTabSz="914400" rtl="0" eaLnBrk="1" fontAlgn="auto" latinLnBrk="0" hangingPunct="1">
-              <a:lnSpc>
-                <a:spcPct val="100000"/>
-              </a:lnSpc>
-              <a:spcBef>
-                <a:spcPts val="0"/>
-              </a:spcBef>
-              <a:spcAft>
-                <a:spcPts val="0"/>
-              </a:spcAft>
-              <a:buClrTx/>
-              <a:buSzTx/>
-              <a:buFontTx/>
-              <a:buNone/>
-              <a:tabLst/>
-              <a:defRPr/>
-            </a:pPr>
-            <a:r>
-              <a:rPr kumimoji="0" lang="en-US" sz="2800" b="1" i="0" u="none" strike="noStrike" kern="1200" cap="none" spc="0" normalizeH="0" baseline="0" noProof="0" dirty="0">
-                <a:ln>
-                  <a:noFill/>
-                </a:ln>
-                <a:solidFill>
-                  <a:srgbClr val="1B2B31"/>
-                </a:solidFill>
-                <a:effectLst/>
-                <a:uLnTx/>
-                <a:uFillTx/>
-                <a:latin typeface="Georgia" pitchFamily="34" charset="0"/>
-                <a:ea typeface="Georgia" pitchFamily="34" charset="-122"/>
-                <a:cs typeface="Georgia" pitchFamily="34" charset="-120"/>
-              </a:rPr>
-              <a:t>Why a flat result is readable despite huge donor spread</a:t>
-            </a:r>
-            <a:endParaRPr kumimoji="0" lang="en-US" sz="2800" b="0" i="0" u="none" strike="noStrike" kern="1200" cap="none" spc="0" normalizeH="0" baseline="0" noProof="0" dirty="0">
-              <a:ln>
-                <a:noFill/>
-              </a:ln>
-              <a:solidFill>
-                <a:prstClr val="black"/>
-              </a:solidFill>
-              <a:effectLst/>
-              <a:uLnTx/>
-              <a:uFillTx/>
-              <a:latin typeface="Calibri" panose="020F0502020204030204"/>
-              <a:ea typeface="+mn-ea"/>
-              <a:cs typeface="+mn-cs"/>
-            </a:endParaRPr>
-          </a:p>
-        </p:txBody>
-      </p:sp>
-      <p:sp>
-        <p:nvSpPr>
-          <p:cNvPr id="6" name="Text 4"/>
-          <p:cNvSpPr/>
-          <p:nvPr/>
-        </p:nvSpPr>
-        <p:spPr>
-          <a:xfrm>
-            <a:off x="640080" y="1371600"/>
-            <a:ext cx="11247120" cy="457200"/>
-          </a:xfrm>
-          <a:prstGeom prst="rect">
-            <a:avLst/>
-          </a:prstGeom>
-          <a:noFill/>
-          <a:ln/>
-        </p:spPr>
-        <p:txBody>
-          <a:bodyPr wrap="square" rtlCol="0" anchor="ctr"/>
-          <a:lstStyle/>
-          <a:p>
-            <a:pPr marL="0" marR="0" lvl="0" indent="0" algn="l" defTabSz="914400" rtl="0" eaLnBrk="1" fontAlgn="auto" latinLnBrk="0" hangingPunct="1">
-              <a:lnSpc>
-                <a:spcPct val="100000"/>
-              </a:lnSpc>
-              <a:spcBef>
-                <a:spcPts val="0"/>
-              </a:spcBef>
-              <a:spcAft>
-                <a:spcPts val="0"/>
-              </a:spcAft>
-              <a:buClrTx/>
-              <a:buSzTx/>
-              <a:buFontTx/>
-              <a:buNone/>
-              <a:tabLst/>
-              <a:defRPr/>
-            </a:pPr>
-            <a:r>
-              <a:rPr kumimoji="0" lang="en-US" sz="1500" b="0" i="0" u="none" strike="noStrike" kern="1200" cap="none" spc="0" normalizeH="0" baseline="0" noProof="0" dirty="0">
-                <a:ln>
-                  <a:noFill/>
-                </a:ln>
-                <a:solidFill>
-                  <a:srgbClr val="1B2B31"/>
-                </a:solidFill>
-                <a:effectLst/>
-                <a:uLnTx/>
-                <a:uFillTx/>
-                <a:latin typeface="Calibri" panose="020F0502020204030204"/>
-                <a:ea typeface="+mn-ea"/>
-                <a:cs typeface="+mn-cs"/>
-              </a:rPr>
-              <a:t>Within each fibrosis stage the per-donor pericentral-anchor fraction spans ~25–35 pp (SD ≈ 12 pp). </a:t>
-            </a:r>
-          </a:p>
-          <a:p>
-            <a:pPr marL="0" marR="0" lvl="0" indent="0" algn="l" defTabSz="914400" rtl="0" eaLnBrk="1" fontAlgn="auto" latinLnBrk="0" hangingPunct="1">
-              <a:lnSpc>
-                <a:spcPct val="100000"/>
-              </a:lnSpc>
-              <a:spcBef>
-                <a:spcPts val="0"/>
-              </a:spcBef>
-              <a:spcAft>
-                <a:spcPts val="0"/>
-              </a:spcAft>
-              <a:buClrTx/>
-              <a:buSzTx/>
-              <a:buFontTx/>
-              <a:buNone/>
-              <a:tabLst/>
-              <a:defRPr/>
-            </a:pPr>
-            <a:r>
-              <a:rPr kumimoji="0" lang="en-US" sz="1500" b="1" i="0" u="none" strike="noStrike" kern="1200" cap="none" spc="0" normalizeH="0" baseline="0" noProof="0" dirty="0">
-                <a:ln>
-                  <a:noFill/>
-                </a:ln>
-                <a:solidFill>
-                  <a:srgbClr val="1B2B31"/>
-                </a:solidFill>
-                <a:effectLst/>
-                <a:uLnTx/>
-                <a:uFillTx/>
-                <a:latin typeface="Calibri" panose="020F0502020204030204"/>
-                <a:ea typeface="+mn-ea"/>
-                <a:cs typeface="+mn-cs"/>
-              </a:rPr>
-              <a:t>Could that scatter be hiding a real trend? No — four reasons:</a:t>
-            </a:r>
-            <a:endParaRPr kumimoji="0" lang="en-US" sz="1500" b="0" i="0" u="none" strike="noStrike" kern="1200" cap="none" spc="0" normalizeH="0" baseline="0" noProof="0" dirty="0">
-              <a:ln>
-                <a:noFill/>
-              </a:ln>
-              <a:solidFill>
-                <a:prstClr val="black"/>
-              </a:solidFill>
-              <a:effectLst/>
-              <a:uLnTx/>
-              <a:uFillTx/>
-              <a:latin typeface="Calibri" panose="020F0502020204030204"/>
-              <a:ea typeface="+mn-ea"/>
-              <a:cs typeface="+mn-cs"/>
-            </a:endParaRPr>
-          </a:p>
-        </p:txBody>
-      </p:sp>
-      <p:sp>
-        <p:nvSpPr>
-          <p:cNvPr id="7" name="Shape 5"/>
-          <p:cNvSpPr/>
-          <p:nvPr/>
-        </p:nvSpPr>
-        <p:spPr>
-          <a:xfrm>
-            <a:off x="640080" y="2011680"/>
-            <a:ext cx="5394960" cy="1417320"/>
-          </a:xfrm>
-          <a:prstGeom prst="roundRect">
-            <a:avLst>
-              <a:gd name="adj" fmla="val 3871"/>
-            </a:avLst>
-          </a:prstGeom>
-          <a:solidFill>
-            <a:srgbClr val="FFFFFF"/>
-          </a:solidFill>
-          <a:ln w="12700">
-            <a:solidFill>
-              <a:srgbClr val="E2DCCF"/>
-            </a:solidFill>
-            <a:prstDash val="solid"/>
-          </a:ln>
-          <a:effectLst>
-            <a:outerShdw blurRad="88900" dist="38100" dir="5400000" algn="bl" rotWithShape="0">
-              <a:srgbClr val="000000">
-                <a:alpha val="12000"/>
-              </a:srgbClr>
-            </a:outerShdw>
-          </a:effectLst>
-        </p:spPr>
-      </p:sp>
-      <p:sp>
-        <p:nvSpPr>
-          <p:cNvPr id="8" name="Shape 6"/>
-          <p:cNvSpPr/>
-          <p:nvPr/>
-        </p:nvSpPr>
-        <p:spPr>
-          <a:xfrm>
-            <a:off x="640080" y="2011680"/>
-            <a:ext cx="91440" cy="1417320"/>
-          </a:xfrm>
-          <a:prstGeom prst="rect">
-            <a:avLst/>
-          </a:prstGeom>
-          <a:solidFill>
-            <a:srgbClr val="1D4ED8"/>
-          </a:solidFill>
-          <a:ln/>
-        </p:spPr>
-      </p:sp>
-      <p:sp>
-        <p:nvSpPr>
-          <p:cNvPr id="9" name="Text 7"/>
-          <p:cNvSpPr/>
-          <p:nvPr/>
-        </p:nvSpPr>
-        <p:spPr>
-          <a:xfrm>
-            <a:off x="896112" y="2121408"/>
-            <a:ext cx="548640" cy="548640"/>
-          </a:xfrm>
-          <a:prstGeom prst="rect">
-            <a:avLst/>
-          </a:prstGeom>
-          <a:noFill/>
-          <a:ln/>
-        </p:spPr>
-        <p:txBody>
-          <a:bodyPr wrap="square" lIns="0" tIns="0" rIns="0" bIns="0" rtlCol="0" anchor="t"/>
-          <a:lstStyle/>
-          <a:p>
-            <a:pPr marL="0" marR="0" lvl="0" indent="0" algn="l" defTabSz="914400" rtl="0" eaLnBrk="1" fontAlgn="auto" latinLnBrk="0" hangingPunct="1">
-              <a:lnSpc>
-                <a:spcPct val="100000"/>
-              </a:lnSpc>
-              <a:spcBef>
-                <a:spcPts val="0"/>
-              </a:spcBef>
-              <a:spcAft>
-                <a:spcPts val="0"/>
-              </a:spcAft>
-              <a:buClrTx/>
-              <a:buSzTx/>
-              <a:buFontTx/>
-              <a:buNone/>
-              <a:tabLst/>
-              <a:defRPr/>
-            </a:pPr>
-            <a:r>
-              <a:rPr kumimoji="0" lang="en-US" sz="2600" b="1" i="0" u="none" strike="noStrike" kern="1200" cap="none" spc="0" normalizeH="0" baseline="0" noProof="0" dirty="0">
-                <a:ln>
-                  <a:noFill/>
-                </a:ln>
-                <a:solidFill>
-                  <a:srgbClr val="1D4ED8"/>
-                </a:solidFill>
-                <a:effectLst/>
-                <a:uLnTx/>
-                <a:uFillTx/>
-                <a:latin typeface="Georgia" pitchFamily="34" charset="0"/>
-                <a:ea typeface="Georgia" pitchFamily="34" charset="-122"/>
-                <a:cs typeface="Georgia" pitchFamily="34" charset="-120"/>
-              </a:rPr>
-              <a:t>1</a:t>
-            </a:r>
-            <a:endParaRPr kumimoji="0" lang="en-US" sz="2600" b="0" i="0" u="none" strike="noStrike" kern="1200" cap="none" spc="0" normalizeH="0" baseline="0" noProof="0" dirty="0">
-              <a:ln>
-                <a:noFill/>
-              </a:ln>
-              <a:solidFill>
-                <a:prstClr val="black"/>
-              </a:solidFill>
-              <a:effectLst/>
-              <a:uLnTx/>
-              <a:uFillTx/>
-              <a:latin typeface="Calibri" panose="020F0502020204030204"/>
-              <a:ea typeface="+mn-ea"/>
-              <a:cs typeface="+mn-cs"/>
-            </a:endParaRPr>
-          </a:p>
-        </p:txBody>
-      </p:sp>
-      <p:sp>
-        <p:nvSpPr>
-          <p:cNvPr id="10" name="Text 8"/>
-          <p:cNvSpPr/>
-          <p:nvPr/>
-        </p:nvSpPr>
-        <p:spPr>
-          <a:xfrm>
-            <a:off x="1463040" y="2157984"/>
-            <a:ext cx="4434840" cy="457200"/>
-          </a:xfrm>
-          <a:prstGeom prst="rect">
-            <a:avLst/>
-          </a:prstGeom>
-          <a:noFill/>
-          <a:ln/>
-        </p:spPr>
-        <p:txBody>
-          <a:bodyPr wrap="square" lIns="0" tIns="0" rIns="0" bIns="0" rtlCol="0" anchor="t"/>
-          <a:lstStyle/>
-          <a:p>
-            <a:pPr marL="0" marR="0" lvl="0" indent="0" algn="l" defTabSz="914400" rtl="0" eaLnBrk="1" fontAlgn="auto" latinLnBrk="0" hangingPunct="1">
-              <a:lnSpc>
-                <a:spcPct val="100000"/>
-              </a:lnSpc>
-              <a:spcBef>
-                <a:spcPts val="0"/>
-              </a:spcBef>
-              <a:spcAft>
-                <a:spcPts val="0"/>
-              </a:spcAft>
-              <a:buClrTx/>
-              <a:buSzTx/>
-              <a:buFontTx/>
-              <a:buNone/>
-              <a:tabLst/>
-              <a:defRPr/>
-            </a:pPr>
-            <a:r>
-              <a:rPr kumimoji="0" lang="en-US" sz="1450" b="1" i="0" u="none" strike="noStrike" kern="1200" cap="none" spc="0" normalizeH="0" baseline="0" noProof="0" dirty="0">
-                <a:ln>
-                  <a:noFill/>
-                </a:ln>
-                <a:solidFill>
-                  <a:srgbClr val="1B2B31"/>
-                </a:solidFill>
-                <a:effectLst/>
-                <a:uLnTx/>
-                <a:uFillTx/>
-                <a:latin typeface="Calibri" panose="020F0502020204030204"/>
-                <a:ea typeface="+mn-ea"/>
-                <a:cs typeface="+mn-cs"/>
-              </a:rPr>
-              <a:t>The donor is the replicate — not the cell</a:t>
-            </a:r>
-            <a:endParaRPr kumimoji="0" lang="en-US" sz="1450" b="0" i="0" u="none" strike="noStrike" kern="1200" cap="none" spc="0" normalizeH="0" baseline="0" noProof="0" dirty="0">
-              <a:ln>
-                <a:noFill/>
-              </a:ln>
-              <a:solidFill>
-                <a:prstClr val="black"/>
-              </a:solidFill>
-              <a:effectLst/>
-              <a:uLnTx/>
-              <a:uFillTx/>
-              <a:latin typeface="Calibri" panose="020F0502020204030204"/>
-              <a:ea typeface="+mn-ea"/>
-              <a:cs typeface="+mn-cs"/>
-            </a:endParaRPr>
-          </a:p>
-        </p:txBody>
-      </p:sp>
-      <p:sp>
-        <p:nvSpPr>
-          <p:cNvPr id="11" name="Text 9"/>
-          <p:cNvSpPr/>
-          <p:nvPr/>
-        </p:nvSpPr>
-        <p:spPr>
-          <a:xfrm>
-            <a:off x="1463040" y="2578608"/>
-            <a:ext cx="4434840" cy="777240"/>
-          </a:xfrm>
-          <a:prstGeom prst="rect">
-            <a:avLst/>
-          </a:prstGeom>
-          <a:noFill/>
-          <a:ln/>
-        </p:spPr>
-        <p:txBody>
-          <a:bodyPr wrap="square" lIns="0" tIns="0" rIns="0" bIns="0" rtlCol="0" anchor="t"/>
-          <a:lstStyle/>
-          <a:p>
-            <a:pPr marL="0" marR="0" lvl="0" indent="0" algn="l" defTabSz="914400" rtl="0" eaLnBrk="1" fontAlgn="auto" latinLnBrk="0" hangingPunct="1">
-              <a:lnSpc>
-                <a:spcPct val="100000"/>
-              </a:lnSpc>
-              <a:spcBef>
-                <a:spcPts val="0"/>
-              </a:spcBef>
-              <a:spcAft>
-                <a:spcPts val="0"/>
-              </a:spcAft>
-              <a:buClrTx/>
-              <a:buSzTx/>
-              <a:buFontTx/>
-              <a:buNone/>
-              <a:tabLst/>
-              <a:defRPr/>
-            </a:pPr>
-            <a:r>
-              <a:rPr kumimoji="0" lang="en-US" sz="1150" b="0" i="0" u="none" strike="noStrike" kern="1200" cap="none" spc="0" normalizeH="0" baseline="0" noProof="0" dirty="0">
-                <a:ln>
-                  <a:noFill/>
-                </a:ln>
-                <a:solidFill>
-                  <a:srgbClr val="334155"/>
-                </a:solidFill>
-                <a:effectLst/>
-                <a:uLnTx/>
-                <a:uFillTx/>
-                <a:latin typeface="Calibri" panose="020F0502020204030204"/>
-                <a:ea typeface="+mn-ea"/>
-                <a:cs typeface="+mn-cs"/>
-              </a:rPr>
-              <a:t>Inference is donor-level (F1–F4 = 8 / 12 / 12 / 4). A stage MEAN has standard error SE ≈ SD/√n ≈ 12/√10 ≈ 4 pp — we compare stage means (± 4 pp), not individual donors (± 12 pp).</a:t>
-            </a:r>
-            <a:endParaRPr kumimoji="0" lang="en-US" sz="1150" b="0" i="0" u="none" strike="noStrike" kern="1200" cap="none" spc="0" normalizeH="0" baseline="0" noProof="0" dirty="0">
-              <a:ln>
-                <a:noFill/>
-              </a:ln>
-              <a:solidFill>
-                <a:prstClr val="black"/>
-              </a:solidFill>
-              <a:effectLst/>
-              <a:uLnTx/>
-              <a:uFillTx/>
-              <a:latin typeface="Calibri" panose="020F0502020204030204"/>
-              <a:ea typeface="+mn-ea"/>
-              <a:cs typeface="+mn-cs"/>
-            </a:endParaRPr>
-          </a:p>
-        </p:txBody>
-      </p:sp>
-      <p:sp>
-        <p:nvSpPr>
-          <p:cNvPr id="12" name="Shape 10"/>
-          <p:cNvSpPr/>
-          <p:nvPr/>
-        </p:nvSpPr>
-        <p:spPr>
-          <a:xfrm>
-            <a:off x="6172200" y="2011680"/>
-            <a:ext cx="5394960" cy="1417320"/>
-          </a:xfrm>
-          <a:prstGeom prst="roundRect">
-            <a:avLst>
-              <a:gd name="adj" fmla="val 3871"/>
-            </a:avLst>
-          </a:prstGeom>
-          <a:solidFill>
-            <a:srgbClr val="FFFFFF"/>
-          </a:solidFill>
-          <a:ln w="12700">
-            <a:solidFill>
-              <a:srgbClr val="E2DCCF"/>
-            </a:solidFill>
-            <a:prstDash val="solid"/>
-          </a:ln>
-          <a:effectLst>
-            <a:outerShdw blurRad="88900" dist="38100" dir="5400000" algn="bl" rotWithShape="0">
-              <a:srgbClr val="000000">
-                <a:alpha val="12000"/>
-              </a:srgbClr>
-            </a:outerShdw>
-          </a:effectLst>
-        </p:spPr>
-      </p:sp>
-      <p:sp>
-        <p:nvSpPr>
-          <p:cNvPr id="13" name="Shape 11"/>
-          <p:cNvSpPr/>
-          <p:nvPr/>
-        </p:nvSpPr>
-        <p:spPr>
-          <a:xfrm>
-            <a:off x="6172200" y="2011680"/>
-            <a:ext cx="91440" cy="1417320"/>
-          </a:xfrm>
-          <a:prstGeom prst="rect">
-            <a:avLst/>
-          </a:prstGeom>
-          <a:solidFill>
-            <a:srgbClr val="0D9488"/>
-          </a:solidFill>
-          <a:ln/>
-        </p:spPr>
-      </p:sp>
-      <p:sp>
-        <p:nvSpPr>
-          <p:cNvPr id="14" name="Text 12"/>
-          <p:cNvSpPr/>
-          <p:nvPr/>
-        </p:nvSpPr>
-        <p:spPr>
-          <a:xfrm>
-            <a:off x="6428232" y="2121408"/>
-            <a:ext cx="548640" cy="548640"/>
-          </a:xfrm>
-          <a:prstGeom prst="rect">
-            <a:avLst/>
-          </a:prstGeom>
-          <a:noFill/>
-          <a:ln/>
-        </p:spPr>
-        <p:txBody>
-          <a:bodyPr wrap="square" lIns="0" tIns="0" rIns="0" bIns="0" rtlCol="0" anchor="t"/>
-          <a:lstStyle/>
-          <a:p>
-            <a:pPr marL="0" marR="0" lvl="0" indent="0" algn="l" defTabSz="914400" rtl="0" eaLnBrk="1" fontAlgn="auto" latinLnBrk="0" hangingPunct="1">
-              <a:lnSpc>
-                <a:spcPct val="100000"/>
-              </a:lnSpc>
-              <a:spcBef>
-                <a:spcPts val="0"/>
-              </a:spcBef>
-              <a:spcAft>
-                <a:spcPts val="0"/>
-              </a:spcAft>
-              <a:buClrTx/>
-              <a:buSzTx/>
-              <a:buFontTx/>
-              <a:buNone/>
-              <a:tabLst/>
-              <a:defRPr/>
-            </a:pPr>
-            <a:r>
-              <a:rPr kumimoji="0" lang="en-US" sz="2600" b="1" i="0" u="none" strike="noStrike" kern="1200" cap="none" spc="0" normalizeH="0" baseline="0" noProof="0" dirty="0">
-                <a:ln>
-                  <a:noFill/>
-                </a:ln>
-                <a:solidFill>
-                  <a:srgbClr val="0D9488"/>
-                </a:solidFill>
-                <a:effectLst/>
-                <a:uLnTx/>
-                <a:uFillTx/>
-                <a:latin typeface="Georgia" pitchFamily="34" charset="0"/>
-                <a:ea typeface="Georgia" pitchFamily="34" charset="-122"/>
-                <a:cs typeface="Georgia" pitchFamily="34" charset="-120"/>
-              </a:rPr>
-              <a:t>2</a:t>
-            </a:r>
-            <a:endParaRPr kumimoji="0" lang="en-US" sz="2600" b="0" i="0" u="none" strike="noStrike" kern="1200" cap="none" spc="0" normalizeH="0" baseline="0" noProof="0" dirty="0">
-              <a:ln>
-                <a:noFill/>
-              </a:ln>
-              <a:solidFill>
-                <a:prstClr val="black"/>
-              </a:solidFill>
-              <a:effectLst/>
-              <a:uLnTx/>
-              <a:uFillTx/>
-              <a:latin typeface="Calibri" panose="020F0502020204030204"/>
-              <a:ea typeface="+mn-ea"/>
-              <a:cs typeface="+mn-cs"/>
-            </a:endParaRPr>
-          </a:p>
-        </p:txBody>
-      </p:sp>
-      <p:sp>
-        <p:nvSpPr>
-          <p:cNvPr id="15" name="Text 13"/>
-          <p:cNvSpPr/>
-          <p:nvPr/>
-        </p:nvSpPr>
-        <p:spPr>
-          <a:xfrm>
-            <a:off x="6995160" y="2157984"/>
-            <a:ext cx="4434840" cy="457200"/>
-          </a:xfrm>
-          <a:prstGeom prst="rect">
-            <a:avLst/>
-          </a:prstGeom>
-          <a:noFill/>
-          <a:ln/>
-        </p:spPr>
-        <p:txBody>
-          <a:bodyPr wrap="square" lIns="0" tIns="0" rIns="0" bIns="0" rtlCol="0" anchor="t"/>
-          <a:lstStyle/>
-          <a:p>
-            <a:pPr marL="0" marR="0" lvl="0" indent="0" algn="l" defTabSz="914400" rtl="0" eaLnBrk="1" fontAlgn="auto" latinLnBrk="0" hangingPunct="1">
-              <a:lnSpc>
-                <a:spcPct val="100000"/>
-              </a:lnSpc>
-              <a:spcBef>
-                <a:spcPts val="0"/>
-              </a:spcBef>
-              <a:spcAft>
-                <a:spcPts val="0"/>
-              </a:spcAft>
-              <a:buClrTx/>
-              <a:buSzTx/>
-              <a:buFontTx/>
-              <a:buNone/>
-              <a:tabLst/>
-              <a:defRPr/>
-            </a:pPr>
-            <a:r>
-              <a:rPr kumimoji="0" lang="en-US" sz="1450" b="1" i="0" u="none" strike="noStrike" kern="1200" cap="none" spc="0" normalizeH="0" baseline="0" noProof="0" dirty="0">
-                <a:ln>
-                  <a:noFill/>
-                </a:ln>
-                <a:solidFill>
-                  <a:srgbClr val="1B2B31"/>
-                </a:solidFill>
-                <a:effectLst/>
-                <a:uLnTx/>
-                <a:uFillTx/>
-                <a:latin typeface="Calibri" panose="020F0502020204030204"/>
-                <a:ea typeface="+mn-ea"/>
-                <a:cs typeface="+mn-cs"/>
-              </a:rPr>
-              <a:t>The spread is the same at every stage</a:t>
-            </a:r>
-            <a:endParaRPr kumimoji="0" lang="en-US" sz="1450" b="0" i="0" u="none" strike="noStrike" kern="1200" cap="none" spc="0" normalizeH="0" baseline="0" noProof="0" dirty="0">
-              <a:ln>
-                <a:noFill/>
-              </a:ln>
-              <a:solidFill>
-                <a:prstClr val="black"/>
-              </a:solidFill>
-              <a:effectLst/>
-              <a:uLnTx/>
-              <a:uFillTx/>
-              <a:latin typeface="Calibri" panose="020F0502020204030204"/>
-              <a:ea typeface="+mn-ea"/>
-              <a:cs typeface="+mn-cs"/>
-            </a:endParaRPr>
-          </a:p>
-        </p:txBody>
-      </p:sp>
-      <p:sp>
-        <p:nvSpPr>
-          <p:cNvPr id="16" name="Text 14"/>
-          <p:cNvSpPr/>
-          <p:nvPr/>
-        </p:nvSpPr>
-        <p:spPr>
-          <a:xfrm>
-            <a:off x="6995160" y="2578608"/>
-            <a:ext cx="4434840" cy="777240"/>
-          </a:xfrm>
-          <a:prstGeom prst="rect">
-            <a:avLst/>
-          </a:prstGeom>
-          <a:noFill/>
-          <a:ln/>
-        </p:spPr>
-        <p:txBody>
-          <a:bodyPr wrap="square" lIns="0" tIns="0" rIns="0" bIns="0" rtlCol="0" anchor="t"/>
-          <a:lstStyle/>
-          <a:p>
-            <a:pPr marL="0" marR="0" lvl="0" indent="0" algn="l" defTabSz="914400" rtl="0" eaLnBrk="1" fontAlgn="auto" latinLnBrk="0" hangingPunct="1">
-              <a:lnSpc>
-                <a:spcPct val="100000"/>
-              </a:lnSpc>
-              <a:spcBef>
-                <a:spcPts val="0"/>
-              </a:spcBef>
-              <a:spcAft>
-                <a:spcPts val="0"/>
-              </a:spcAft>
-              <a:buClrTx/>
-              <a:buSzTx/>
-              <a:buFontTx/>
-              <a:buNone/>
-              <a:tabLst/>
-              <a:defRPr/>
-            </a:pPr>
-            <a:r>
-              <a:rPr kumimoji="0" lang="en-US" sz="1150" b="0" i="0" u="none" strike="noStrike" kern="1200" cap="none" spc="0" normalizeH="0" baseline="0" noProof="0" dirty="0">
-                <a:ln>
-                  <a:noFill/>
-                </a:ln>
-                <a:solidFill>
-                  <a:srgbClr val="334155"/>
-                </a:solidFill>
-                <a:effectLst/>
-                <a:uLnTx/>
-                <a:uFillTx/>
-                <a:latin typeface="Calibri" panose="020F0502020204030204"/>
-                <a:ea typeface="+mn-ea"/>
-                <a:cs typeface="+mn-cs"/>
-              </a:rPr>
-              <a:t>Variance is homoscedastic — as wide at F1 as at F4. A real progression would shift the mean monotonically beyond ± 4 pp; it doesn’t. This is noise around a flat line, not a trend buried in noise.</a:t>
-            </a:r>
-            <a:endParaRPr kumimoji="0" lang="en-US" sz="1150" b="0" i="0" u="none" strike="noStrike" kern="1200" cap="none" spc="0" normalizeH="0" baseline="0" noProof="0" dirty="0">
-              <a:ln>
-                <a:noFill/>
-              </a:ln>
-              <a:solidFill>
-                <a:prstClr val="black"/>
-              </a:solidFill>
-              <a:effectLst/>
-              <a:uLnTx/>
-              <a:uFillTx/>
-              <a:latin typeface="Calibri" panose="020F0502020204030204"/>
-              <a:ea typeface="+mn-ea"/>
-              <a:cs typeface="+mn-cs"/>
-            </a:endParaRPr>
-          </a:p>
-        </p:txBody>
-      </p:sp>
-      <p:sp>
-        <p:nvSpPr>
-          <p:cNvPr id="17" name="Shape 15"/>
-          <p:cNvSpPr/>
-          <p:nvPr/>
-        </p:nvSpPr>
-        <p:spPr>
-          <a:xfrm>
-            <a:off x="640080" y="3584448"/>
-            <a:ext cx="5394960" cy="1417320"/>
-          </a:xfrm>
-          <a:prstGeom prst="roundRect">
-            <a:avLst>
-              <a:gd name="adj" fmla="val 3871"/>
-            </a:avLst>
-          </a:prstGeom>
-          <a:solidFill>
-            <a:srgbClr val="FFFFFF"/>
-          </a:solidFill>
-          <a:ln w="12700">
-            <a:solidFill>
-              <a:srgbClr val="E2DCCF"/>
-            </a:solidFill>
-            <a:prstDash val="solid"/>
-          </a:ln>
-          <a:effectLst>
-            <a:outerShdw blurRad="88900" dist="38100" dir="5400000" algn="bl" rotWithShape="0">
-              <a:srgbClr val="000000">
-                <a:alpha val="12000"/>
-              </a:srgbClr>
-            </a:outerShdw>
-          </a:effectLst>
-        </p:spPr>
-      </p:sp>
-      <p:sp>
-        <p:nvSpPr>
-          <p:cNvPr id="18" name="Shape 16"/>
-          <p:cNvSpPr/>
-          <p:nvPr/>
-        </p:nvSpPr>
-        <p:spPr>
-          <a:xfrm>
-            <a:off x="640080" y="3584448"/>
-            <a:ext cx="91440" cy="1417320"/>
-          </a:xfrm>
-          <a:prstGeom prst="rect">
-            <a:avLst/>
-          </a:prstGeom>
-          <a:solidFill>
-            <a:srgbClr val="7C3AED"/>
-          </a:solidFill>
-          <a:ln/>
-        </p:spPr>
-      </p:sp>
-      <p:sp>
-        <p:nvSpPr>
-          <p:cNvPr id="19" name="Text 17"/>
-          <p:cNvSpPr/>
-          <p:nvPr/>
-        </p:nvSpPr>
-        <p:spPr>
-          <a:xfrm>
-            <a:off x="896112" y="3694176"/>
-            <a:ext cx="548640" cy="548640"/>
-          </a:xfrm>
-          <a:prstGeom prst="rect">
-            <a:avLst/>
-          </a:prstGeom>
-          <a:noFill/>
-          <a:ln/>
-        </p:spPr>
-        <p:txBody>
-          <a:bodyPr wrap="square" lIns="0" tIns="0" rIns="0" bIns="0" rtlCol="0" anchor="t"/>
-          <a:lstStyle/>
-          <a:p>
-            <a:pPr marL="0" marR="0" lvl="0" indent="0" algn="l" defTabSz="914400" rtl="0" eaLnBrk="1" fontAlgn="auto" latinLnBrk="0" hangingPunct="1">
-              <a:lnSpc>
-                <a:spcPct val="100000"/>
-              </a:lnSpc>
-              <a:spcBef>
-                <a:spcPts val="0"/>
-              </a:spcBef>
-              <a:spcAft>
-                <a:spcPts val="0"/>
-              </a:spcAft>
-              <a:buClrTx/>
-              <a:buSzTx/>
-              <a:buFontTx/>
-              <a:buNone/>
-              <a:tabLst/>
-              <a:defRPr/>
-            </a:pPr>
-            <a:r>
-              <a:rPr kumimoji="0" lang="en-US" sz="2600" b="1" i="0" u="none" strike="noStrike" kern="1200" cap="none" spc="0" normalizeH="0" baseline="0" noProof="0" dirty="0">
-                <a:ln>
-                  <a:noFill/>
-                </a:ln>
-                <a:solidFill>
-                  <a:srgbClr val="7C3AED"/>
-                </a:solidFill>
-                <a:effectLst/>
-                <a:uLnTx/>
-                <a:uFillTx/>
-                <a:latin typeface="Georgia" pitchFamily="34" charset="0"/>
-                <a:ea typeface="Georgia" pitchFamily="34" charset="-122"/>
-                <a:cs typeface="Georgia" pitchFamily="34" charset="-120"/>
-              </a:rPr>
-              <a:t>3</a:t>
-            </a:r>
-            <a:endParaRPr kumimoji="0" lang="en-US" sz="2600" b="0" i="0" u="none" strike="noStrike" kern="1200" cap="none" spc="0" normalizeH="0" baseline="0" noProof="0" dirty="0">
-              <a:ln>
-                <a:noFill/>
-              </a:ln>
-              <a:solidFill>
-                <a:prstClr val="black"/>
-              </a:solidFill>
-              <a:effectLst/>
-              <a:uLnTx/>
-              <a:uFillTx/>
-              <a:latin typeface="Calibri" panose="020F0502020204030204"/>
-              <a:ea typeface="+mn-ea"/>
-              <a:cs typeface="+mn-cs"/>
-            </a:endParaRPr>
-          </a:p>
-        </p:txBody>
-      </p:sp>
-      <p:sp>
-        <p:nvSpPr>
-          <p:cNvPr id="20" name="Text 18"/>
-          <p:cNvSpPr/>
-          <p:nvPr/>
-        </p:nvSpPr>
-        <p:spPr>
-          <a:xfrm>
-            <a:off x="1463040" y="3730752"/>
-            <a:ext cx="4434840" cy="457200"/>
-          </a:xfrm>
-          <a:prstGeom prst="rect">
-            <a:avLst/>
-          </a:prstGeom>
-          <a:noFill/>
-          <a:ln/>
-        </p:spPr>
-        <p:txBody>
-          <a:bodyPr wrap="square" lIns="0" tIns="0" rIns="0" bIns="0" rtlCol="0" anchor="t"/>
-          <a:lstStyle/>
-          <a:p>
-            <a:pPr marL="0" marR="0" lvl="0" indent="0" algn="l" defTabSz="914400" rtl="0" eaLnBrk="1" fontAlgn="auto" latinLnBrk="0" hangingPunct="1">
-              <a:lnSpc>
-                <a:spcPct val="100000"/>
-              </a:lnSpc>
-              <a:spcBef>
-                <a:spcPts val="0"/>
-              </a:spcBef>
-              <a:spcAft>
-                <a:spcPts val="0"/>
-              </a:spcAft>
-              <a:buClrTx/>
-              <a:buSzTx/>
-              <a:buFontTx/>
-              <a:buNone/>
-              <a:tabLst/>
-              <a:defRPr/>
-            </a:pPr>
-            <a:r>
-              <a:rPr kumimoji="0" lang="en-US" sz="1450" b="1" i="0" u="none" strike="noStrike" kern="1200" cap="none" spc="0" normalizeH="0" baseline="0" noProof="0" dirty="0">
-                <a:ln>
-                  <a:noFill/>
-                </a:ln>
-                <a:solidFill>
-                  <a:srgbClr val="1B2B31"/>
-                </a:solidFill>
-                <a:effectLst/>
-                <a:uLnTx/>
-                <a:uFillTx/>
-                <a:latin typeface="Calibri" panose="020F0502020204030204"/>
-                <a:ea typeface="+mn-ea"/>
-                <a:cs typeface="+mn-cs"/>
-              </a:rPr>
-              <a:t>We bound what is excluded (TOST)</a:t>
-            </a:r>
-            <a:endParaRPr kumimoji="0" lang="en-US" sz="1450" b="0" i="0" u="none" strike="noStrike" kern="1200" cap="none" spc="0" normalizeH="0" baseline="0" noProof="0" dirty="0">
-              <a:ln>
-                <a:noFill/>
-              </a:ln>
-              <a:solidFill>
-                <a:prstClr val="black"/>
-              </a:solidFill>
-              <a:effectLst/>
-              <a:uLnTx/>
-              <a:uFillTx/>
-              <a:latin typeface="Calibri" panose="020F0502020204030204"/>
-              <a:ea typeface="+mn-ea"/>
-              <a:cs typeface="+mn-cs"/>
-            </a:endParaRPr>
-          </a:p>
-        </p:txBody>
-      </p:sp>
-      <p:sp>
-        <p:nvSpPr>
-          <p:cNvPr id="21" name="Text 19"/>
-          <p:cNvSpPr/>
-          <p:nvPr/>
-        </p:nvSpPr>
-        <p:spPr>
-          <a:xfrm>
-            <a:off x="1463040" y="4151376"/>
-            <a:ext cx="4434840" cy="777240"/>
-          </a:xfrm>
-          <a:prstGeom prst="rect">
-            <a:avLst/>
-          </a:prstGeom>
-          <a:noFill/>
-          <a:ln/>
-        </p:spPr>
-        <p:txBody>
-          <a:bodyPr wrap="square" lIns="0" tIns="0" rIns="0" bIns="0" rtlCol="0" anchor="t"/>
-          <a:lstStyle/>
-          <a:p>
-            <a:pPr marL="0" marR="0" lvl="0" indent="0" algn="l" defTabSz="914400" rtl="0" eaLnBrk="1" fontAlgn="auto" latinLnBrk="0" hangingPunct="1">
-              <a:lnSpc>
-                <a:spcPct val="100000"/>
-              </a:lnSpc>
-              <a:spcBef>
-                <a:spcPts val="0"/>
-              </a:spcBef>
-              <a:spcAft>
-                <a:spcPts val="0"/>
-              </a:spcAft>
-              <a:buClrTx/>
-              <a:buSzTx/>
-              <a:buFontTx/>
-              <a:buNone/>
-              <a:tabLst/>
-              <a:defRPr/>
-            </a:pPr>
-            <a:r>
-              <a:rPr kumimoji="0" lang="en-US" sz="1150" b="0" i="0" u="none" strike="noStrike" kern="1200" cap="none" spc="0" normalizeH="0" baseline="0" noProof="0" dirty="0">
-                <a:ln>
-                  <a:noFill/>
-                </a:ln>
-                <a:solidFill>
-                  <a:srgbClr val="334155"/>
-                </a:solidFill>
-                <a:effectLst/>
-                <a:uLnTx/>
-                <a:uFillTx/>
-                <a:latin typeface="Calibri" panose="020F0502020204030204"/>
-                <a:ea typeface="+mn-ea"/>
-                <a:cs typeface="+mn-cs"/>
-              </a:rPr>
-              <a:t>Not merely “no trend found”: a shift &gt; ± 19 pp between F1 and F4 is positively rejected at the donor level. Only a subtle drift (≤ 10 pp) remains possible — limited by F4’s n = 4.</a:t>
-            </a:r>
-            <a:endParaRPr kumimoji="0" lang="en-US" sz="1150" b="0" i="0" u="none" strike="noStrike" kern="1200" cap="none" spc="0" normalizeH="0" baseline="0" noProof="0" dirty="0">
-              <a:ln>
-                <a:noFill/>
-              </a:ln>
-              <a:solidFill>
-                <a:prstClr val="black"/>
-              </a:solidFill>
-              <a:effectLst/>
-              <a:uLnTx/>
-              <a:uFillTx/>
-              <a:latin typeface="Calibri" panose="020F0502020204030204"/>
-              <a:ea typeface="+mn-ea"/>
-              <a:cs typeface="+mn-cs"/>
-            </a:endParaRPr>
-          </a:p>
-        </p:txBody>
-      </p:sp>
-      <p:sp>
-        <p:nvSpPr>
-          <p:cNvPr id="22" name="Shape 20"/>
-          <p:cNvSpPr/>
-          <p:nvPr/>
-        </p:nvSpPr>
-        <p:spPr>
-          <a:xfrm>
-            <a:off x="6172200" y="3584448"/>
-            <a:ext cx="5394960" cy="1417320"/>
-          </a:xfrm>
-          <a:prstGeom prst="roundRect">
-            <a:avLst>
-              <a:gd name="adj" fmla="val 3871"/>
-            </a:avLst>
-          </a:prstGeom>
-          <a:solidFill>
-            <a:srgbClr val="FFFFFF"/>
-          </a:solidFill>
-          <a:ln w="12700">
-            <a:solidFill>
-              <a:srgbClr val="E2DCCF"/>
-            </a:solidFill>
-            <a:prstDash val="solid"/>
-          </a:ln>
-          <a:effectLst>
-            <a:outerShdw blurRad="88900" dist="38100" dir="5400000" algn="bl" rotWithShape="0">
-              <a:srgbClr val="000000">
-                <a:alpha val="12000"/>
-              </a:srgbClr>
-            </a:outerShdw>
-          </a:effectLst>
-        </p:spPr>
-      </p:sp>
-      <p:sp>
-        <p:nvSpPr>
-          <p:cNvPr id="23" name="Shape 21"/>
-          <p:cNvSpPr/>
-          <p:nvPr/>
-        </p:nvSpPr>
-        <p:spPr>
-          <a:xfrm>
-            <a:off x="6172200" y="3584448"/>
-            <a:ext cx="91440" cy="1417320"/>
-          </a:xfrm>
-          <a:prstGeom prst="rect">
-            <a:avLst/>
-          </a:prstGeom>
-          <a:solidFill>
-            <a:srgbClr val="C0561B"/>
-          </a:solidFill>
-          <a:ln/>
-        </p:spPr>
-      </p:sp>
-      <p:sp>
-        <p:nvSpPr>
-          <p:cNvPr id="24" name="Text 22"/>
-          <p:cNvSpPr/>
-          <p:nvPr/>
-        </p:nvSpPr>
-        <p:spPr>
-          <a:xfrm>
-            <a:off x="6428232" y="3694176"/>
-            <a:ext cx="548640" cy="548640"/>
-          </a:xfrm>
-          <a:prstGeom prst="rect">
-            <a:avLst/>
-          </a:prstGeom>
-          <a:noFill/>
-          <a:ln/>
-        </p:spPr>
-        <p:txBody>
-          <a:bodyPr wrap="square" lIns="0" tIns="0" rIns="0" bIns="0" rtlCol="0" anchor="t"/>
-          <a:lstStyle/>
-          <a:p>
-            <a:pPr marL="0" marR="0" lvl="0" indent="0" algn="l" defTabSz="914400" rtl="0" eaLnBrk="1" fontAlgn="auto" latinLnBrk="0" hangingPunct="1">
-              <a:lnSpc>
-                <a:spcPct val="100000"/>
-              </a:lnSpc>
-              <a:spcBef>
-                <a:spcPts val="0"/>
-              </a:spcBef>
-              <a:spcAft>
-                <a:spcPts val="0"/>
-              </a:spcAft>
-              <a:buClrTx/>
-              <a:buSzTx/>
-              <a:buFontTx/>
-              <a:buNone/>
-              <a:tabLst/>
-              <a:defRPr/>
-            </a:pPr>
-            <a:r>
-              <a:rPr kumimoji="0" lang="en-US" sz="2600" b="1" i="0" u="none" strike="noStrike" kern="1200" cap="none" spc="0" normalizeH="0" baseline="0" noProof="0" dirty="0">
-                <a:ln>
-                  <a:noFill/>
-                </a:ln>
-                <a:solidFill>
-                  <a:srgbClr val="C0561B"/>
-                </a:solidFill>
-                <a:effectLst/>
-                <a:uLnTx/>
-                <a:uFillTx/>
-                <a:latin typeface="Georgia" pitchFamily="34" charset="0"/>
-                <a:ea typeface="Georgia" pitchFamily="34" charset="-122"/>
-                <a:cs typeface="Georgia" pitchFamily="34" charset="-120"/>
-              </a:rPr>
-              <a:t>4</a:t>
-            </a:r>
-            <a:endParaRPr kumimoji="0" lang="en-US" sz="2600" b="0" i="0" u="none" strike="noStrike" kern="1200" cap="none" spc="0" normalizeH="0" baseline="0" noProof="0" dirty="0">
-              <a:ln>
-                <a:noFill/>
-              </a:ln>
-              <a:solidFill>
-                <a:prstClr val="black"/>
-              </a:solidFill>
-              <a:effectLst/>
-              <a:uLnTx/>
-              <a:uFillTx/>
-              <a:latin typeface="Calibri" panose="020F0502020204030204"/>
-              <a:ea typeface="+mn-ea"/>
-              <a:cs typeface="+mn-cs"/>
-            </a:endParaRPr>
-          </a:p>
-        </p:txBody>
-      </p:sp>
-      <p:sp>
-        <p:nvSpPr>
-          <p:cNvPr id="25" name="Text 23"/>
-          <p:cNvSpPr/>
-          <p:nvPr/>
-        </p:nvSpPr>
-        <p:spPr>
-          <a:xfrm>
-            <a:off x="6995160" y="3730752"/>
-            <a:ext cx="4434840" cy="457200"/>
-          </a:xfrm>
-          <a:prstGeom prst="rect">
-            <a:avLst/>
-          </a:prstGeom>
-          <a:noFill/>
-          <a:ln/>
-        </p:spPr>
-        <p:txBody>
-          <a:bodyPr wrap="square" lIns="0" tIns="0" rIns="0" bIns="0" rtlCol="0" anchor="t"/>
-          <a:lstStyle/>
-          <a:p>
-            <a:pPr marL="0" marR="0" lvl="0" indent="0" algn="l" defTabSz="914400" rtl="0" eaLnBrk="1" fontAlgn="auto" latinLnBrk="0" hangingPunct="1">
-              <a:lnSpc>
-                <a:spcPct val="100000"/>
-              </a:lnSpc>
-              <a:spcBef>
-                <a:spcPts val="0"/>
-              </a:spcBef>
-              <a:spcAft>
-                <a:spcPts val="0"/>
-              </a:spcAft>
-              <a:buClrTx/>
-              <a:buSzTx/>
-              <a:buFontTx/>
-              <a:buNone/>
-              <a:tabLst/>
-              <a:defRPr/>
-            </a:pPr>
-            <a:r>
-              <a:rPr kumimoji="0" lang="en-US" sz="1450" b="1" i="0" u="none" strike="noStrike" kern="1200" cap="none" spc="0" normalizeH="0" baseline="0" noProof="0" dirty="0">
-                <a:ln>
-                  <a:noFill/>
-                </a:ln>
-                <a:solidFill>
-                  <a:srgbClr val="1B2B31"/>
-                </a:solidFill>
-                <a:effectLst/>
-                <a:uLnTx/>
-                <a:uFillTx/>
-                <a:latin typeface="Calibri" panose="020F0502020204030204"/>
-                <a:ea typeface="+mn-ea"/>
-                <a:cs typeface="+mn-cs"/>
-              </a:rPr>
-              <a:t>Stable across marker sets &amp; thresholds</a:t>
-            </a:r>
-            <a:endParaRPr kumimoji="0" lang="en-US" sz="1450" b="0" i="0" u="none" strike="noStrike" kern="1200" cap="none" spc="0" normalizeH="0" baseline="0" noProof="0" dirty="0">
-              <a:ln>
-                <a:noFill/>
-              </a:ln>
-              <a:solidFill>
-                <a:prstClr val="black"/>
-              </a:solidFill>
-              <a:effectLst/>
-              <a:uLnTx/>
-              <a:uFillTx/>
-              <a:latin typeface="Calibri" panose="020F0502020204030204"/>
-              <a:ea typeface="+mn-ea"/>
-              <a:cs typeface="+mn-cs"/>
-            </a:endParaRPr>
-          </a:p>
-        </p:txBody>
-      </p:sp>
-      <p:sp>
-        <p:nvSpPr>
-          <p:cNvPr id="26" name="Text 24"/>
-          <p:cNvSpPr/>
-          <p:nvPr/>
-        </p:nvSpPr>
-        <p:spPr>
-          <a:xfrm>
-            <a:off x="6995160" y="4151376"/>
-            <a:ext cx="4434840" cy="777240"/>
-          </a:xfrm>
-          <a:prstGeom prst="rect">
-            <a:avLst/>
-          </a:prstGeom>
-          <a:noFill/>
-          <a:ln/>
-        </p:spPr>
-        <p:txBody>
-          <a:bodyPr wrap="square" lIns="0" tIns="0" rIns="0" bIns="0" rtlCol="0" anchor="t"/>
-          <a:lstStyle/>
-          <a:p>
-            <a:pPr marL="0" marR="0" lvl="0" indent="0" algn="l" defTabSz="914400" rtl="0" eaLnBrk="1" fontAlgn="auto" latinLnBrk="0" hangingPunct="1">
-              <a:lnSpc>
-                <a:spcPct val="100000"/>
-              </a:lnSpc>
-              <a:spcBef>
-                <a:spcPts val="0"/>
-              </a:spcBef>
-              <a:spcAft>
-                <a:spcPts val="0"/>
-              </a:spcAft>
-              <a:buClrTx/>
-              <a:buSzTx/>
-              <a:buFontTx/>
-              <a:buNone/>
-              <a:tabLst/>
-              <a:defRPr/>
-            </a:pPr>
-            <a:r>
-              <a:rPr kumimoji="0" lang="en-US" sz="1150" b="0" i="0" u="none" strike="noStrike" kern="1200" cap="none" spc="0" normalizeH="0" baseline="0" noProof="0" dirty="0">
-                <a:ln>
-                  <a:noFill/>
-                </a:ln>
-                <a:solidFill>
-                  <a:srgbClr val="334155"/>
-                </a:solidFill>
-                <a:effectLst/>
-                <a:uLnTx/>
-                <a:uFillTx/>
-                <a:latin typeface="Calibri" panose="020F0502020204030204"/>
-                <a:ea typeface="+mn-ea"/>
-                <a:cs typeface="+mn-cs"/>
-              </a:rPr>
-              <a:t>The flat result holds on 6 marker sets (2–1,637 genes, incl. Paper 2’s own) and the full ≥1 / ≥2 / ≥3-UMI grid — no setting-dependent signal hiding in the variance.</a:t>
-            </a:r>
-            <a:endParaRPr kumimoji="0" lang="en-US" sz="1150" b="0" i="0" u="none" strike="noStrike" kern="1200" cap="none" spc="0" normalizeH="0" baseline="0" noProof="0" dirty="0">
-              <a:ln>
-                <a:noFill/>
-              </a:ln>
-              <a:solidFill>
-                <a:prstClr val="black"/>
-              </a:solidFill>
-              <a:effectLst/>
-              <a:uLnTx/>
-              <a:uFillTx/>
-              <a:latin typeface="Calibri" panose="020F0502020204030204"/>
-              <a:ea typeface="+mn-ea"/>
-              <a:cs typeface="+mn-cs"/>
-            </a:endParaRPr>
-          </a:p>
-        </p:txBody>
-      </p:sp>
-      <p:sp>
-        <p:nvSpPr>
-          <p:cNvPr id="27" name="Shape 25"/>
-          <p:cNvSpPr/>
-          <p:nvPr/>
-        </p:nvSpPr>
-        <p:spPr>
-          <a:xfrm>
-            <a:off x="640080" y="5257800"/>
-            <a:ext cx="10927080" cy="658368"/>
-          </a:xfrm>
-          <a:prstGeom prst="roundRect">
-            <a:avLst>
-              <a:gd name="adj" fmla="val 8333"/>
-            </a:avLst>
-          </a:prstGeom>
-          <a:solidFill>
-            <a:srgbClr val="E7F0EE"/>
-          </a:solidFill>
-          <a:ln w="12700">
-            <a:solidFill>
-              <a:srgbClr val="1B6E78"/>
-            </a:solidFill>
-            <a:prstDash val="solid"/>
-          </a:ln>
-        </p:spPr>
-      </p:sp>
-      <p:sp>
-        <p:nvSpPr>
-          <p:cNvPr id="28" name="Text 26"/>
-          <p:cNvSpPr/>
-          <p:nvPr/>
-        </p:nvSpPr>
-        <p:spPr>
-          <a:xfrm>
-            <a:off x="868680" y="5257800"/>
-            <a:ext cx="10515600" cy="658368"/>
-          </a:xfrm>
-          <a:prstGeom prst="rect">
-            <a:avLst/>
-          </a:prstGeom>
-          <a:noFill/>
-          <a:ln/>
-        </p:spPr>
-        <p:txBody>
-          <a:bodyPr wrap="square" rtlCol="0" anchor="ctr"/>
-          <a:lstStyle/>
-          <a:p>
-            <a:pPr marL="0" marR="0" lvl="0" indent="0" algn="l" defTabSz="914400" rtl="0" eaLnBrk="1" fontAlgn="auto" latinLnBrk="0" hangingPunct="1">
-              <a:lnSpc>
-                <a:spcPct val="100000"/>
-              </a:lnSpc>
-              <a:spcBef>
-                <a:spcPts val="0"/>
-              </a:spcBef>
-              <a:spcAft>
-                <a:spcPts val="0"/>
-              </a:spcAft>
-              <a:buClrTx/>
-              <a:buSzTx/>
-              <a:buFontTx/>
-              <a:buNone/>
-              <a:tabLst/>
-              <a:defRPr/>
-            </a:pPr>
-            <a:r>
-              <a:rPr kumimoji="0" lang="en-US" sz="1350" b="1" i="0" u="none" strike="noStrike" kern="1200" cap="none" spc="0" normalizeH="0" baseline="0" noProof="0" dirty="0">
-                <a:ln>
-                  <a:noFill/>
-                </a:ln>
-                <a:solidFill>
-                  <a:srgbClr val="123F47"/>
-                </a:solidFill>
-                <a:effectLst/>
-                <a:uLnTx/>
-                <a:uFillTx/>
-                <a:latin typeface="Calibri" panose="020F0502020204030204"/>
-                <a:ea typeface="+mn-ea"/>
-                <a:cs typeface="+mn-cs"/>
-              </a:rPr>
-              <a:t>Bottom line:  </a:t>
-            </a:r>
-            <a:r>
-              <a:rPr kumimoji="0" lang="en-US" sz="1350" b="0" i="0" u="none" strike="noStrike" kern="1200" cap="none" spc="0" normalizeH="0" baseline="0" noProof="0" dirty="0">
-                <a:ln>
-                  <a:noFill/>
-                </a:ln>
-                <a:solidFill>
-                  <a:srgbClr val="1B2B31"/>
-                </a:solidFill>
-                <a:effectLst/>
-                <a:uLnTx/>
-                <a:uFillTx/>
-                <a:latin typeface="Calibri" panose="020F0502020204030204"/>
-                <a:ea typeface="+mn-ea"/>
-                <a:cs typeface="+mn-cs"/>
-              </a:rPr>
-              <a:t>large person-to-person variance ≠ an undetectable signal. With donor-level inference and an equivalence bound, a large progressive de-zonation is </a:t>
-            </a:r>
-            <a:r>
-              <a:rPr kumimoji="0" lang="en-US" sz="1350" b="1" i="0" u="none" strike="noStrike" kern="1200" cap="none" spc="0" normalizeH="0" baseline="0" noProof="0" dirty="0">
-                <a:ln>
-                  <a:noFill/>
-                </a:ln>
-                <a:solidFill>
-                  <a:srgbClr val="123F47"/>
-                </a:solidFill>
-                <a:effectLst/>
-                <a:uLnTx/>
-                <a:uFillTx/>
-                <a:latin typeface="Calibri" panose="020F0502020204030204"/>
-                <a:ea typeface="+mn-ea"/>
-                <a:cs typeface="+mn-cs"/>
-              </a:rPr>
-              <a:t>excluded</a:t>
-            </a:r>
-            <a:r>
-              <a:rPr kumimoji="0" lang="en-US" sz="1350" b="0" i="0" u="none" strike="noStrike" kern="1200" cap="none" spc="0" normalizeH="0" baseline="0" noProof="0" dirty="0">
-                <a:ln>
-                  <a:noFill/>
-                </a:ln>
-                <a:solidFill>
-                  <a:srgbClr val="1B2B31"/>
-                </a:solidFill>
-                <a:effectLst/>
-                <a:uLnTx/>
-                <a:uFillTx/>
-                <a:latin typeface="Calibri" panose="020F0502020204030204"/>
-                <a:ea typeface="+mn-ea"/>
-                <a:cs typeface="+mn-cs"/>
-              </a:rPr>
-              <a:t> (a subtle ≤10-pp drift is not).</a:t>
-            </a:r>
-            <a:endParaRPr kumimoji="0" lang="en-US" sz="1350" b="0" i="0" u="none" strike="noStrike" kern="1200" cap="none" spc="0" normalizeH="0" baseline="0" noProof="0" dirty="0">
-              <a:ln>
-                <a:noFill/>
-              </a:ln>
-              <a:solidFill>
-                <a:prstClr val="black"/>
-              </a:solidFill>
-              <a:effectLst/>
-              <a:uLnTx/>
-              <a:uFillTx/>
-              <a:latin typeface="Calibri" panose="020F0502020204030204"/>
-              <a:ea typeface="+mn-ea"/>
-              <a:cs typeface="+mn-cs"/>
-            </a:endParaRPr>
-          </a:p>
-        </p:txBody>
-      </p:sp>
-      <p:sp>
-        <p:nvSpPr>
-          <p:cNvPr id="29" name="Text 27"/>
-          <p:cNvSpPr/>
-          <p:nvPr/>
-        </p:nvSpPr>
-        <p:spPr>
-          <a:xfrm>
-            <a:off x="457200" y="6510528"/>
-            <a:ext cx="9601200" cy="274320"/>
-          </a:xfrm>
-          <a:prstGeom prst="rect">
-            <a:avLst/>
-          </a:prstGeom>
-          <a:noFill/>
-          <a:ln/>
-        </p:spPr>
-        <p:txBody>
-          <a:bodyPr wrap="square" lIns="0" tIns="0" rIns="0" bIns="0" rtlCol="0" anchor="ctr"/>
-          <a:lstStyle/>
-          <a:p>
-            <a:pPr marL="0" marR="0" lvl="0" indent="0" algn="l" defTabSz="914400" rtl="0" eaLnBrk="1" fontAlgn="auto" latinLnBrk="0" hangingPunct="1">
-              <a:lnSpc>
-                <a:spcPct val="100000"/>
-              </a:lnSpc>
-              <a:spcBef>
-                <a:spcPts val="0"/>
-              </a:spcBef>
-              <a:spcAft>
-                <a:spcPts val="0"/>
-              </a:spcAft>
-              <a:buClrTx/>
-              <a:buSzTx/>
-              <a:buFontTx/>
-              <a:buNone/>
-              <a:tabLst/>
-              <a:defRPr/>
-            </a:pPr>
-            <a:r>
-              <a:rPr kumimoji="0" lang="en-US" sz="1050" b="0" i="0" u="none" strike="noStrike" kern="1200" cap="none" spc="0" normalizeH="0" baseline="0" noProof="0" dirty="0">
-                <a:ln>
-                  <a:noFill/>
-                </a:ln>
-                <a:solidFill>
-                  <a:srgbClr val="5C6E73"/>
-                </a:solidFill>
-                <a:effectLst/>
-                <a:uLnTx/>
-                <a:uFillTx/>
-                <a:latin typeface="Calibri" panose="020F0502020204030204"/>
-                <a:ea typeface="+mn-ea"/>
-                <a:cs typeface="+mn-cs"/>
-              </a:rPr>
-              <a:t>Computational Genomics 76553  ·  HUJI  ·  MASLD snRNA-seq hackathon</a:t>
-            </a:r>
-            <a:endParaRPr kumimoji="0" lang="en-US" sz="1050" b="0" i="0" u="none" strike="noStrike" kern="1200" cap="none" spc="0" normalizeH="0" baseline="0" noProof="0" dirty="0">
-              <a:ln>
-                <a:noFill/>
-              </a:ln>
-              <a:solidFill>
-                <a:prstClr val="black"/>
-              </a:solidFill>
-              <a:effectLst/>
-              <a:uLnTx/>
-              <a:uFillTx/>
-              <a:latin typeface="Calibri" panose="020F0502020204030204"/>
-              <a:ea typeface="+mn-ea"/>
-              <a:cs typeface="+mn-cs"/>
-            </a:endParaRPr>
           </a:p>
         </p:txBody>
       </p:sp>
@@ -11784,6 +10451,1685 @@
 
 <file path=ppt/slides/slide20.xml><?xml version="1.0" encoding="utf-8"?>
 <p:sld xmlns:a="http://schemas.openxmlformats.org/drawingml/2006/main" xmlns:r="http://schemas.openxmlformats.org/officeDocument/2006/relationships" xmlns:p="http://schemas.openxmlformats.org/presentationml/2006/main">
+  <p:cSld>
+    <p:bg>
+      <p:bgPr>
+        <a:solidFill>
+          <a:srgbClr val="F7F5F1"/>
+        </a:solidFill>
+        <a:effectLst/>
+      </p:bgPr>
+    </p:bg>
+    <p:spTree>
+      <p:nvGrpSpPr>
+        <p:cNvPr id="1" name=""/>
+        <p:cNvGrpSpPr/>
+        <p:nvPr/>
+      </p:nvGrpSpPr>
+      <p:grpSpPr>
+        <a:xfrm>
+          <a:off x="0" y="0"/>
+          <a:ext cx="0" cy="0"/>
+          <a:chOff x="0" y="0"/>
+          <a:chExt cx="0" cy="0"/>
+        </a:xfrm>
+      </p:grpSpPr>
+      <p:sp>
+        <p:nvSpPr>
+          <p:cNvPr id="2" name="Shape 0"/>
+          <p:cNvSpPr/>
+          <p:nvPr/>
+        </p:nvSpPr>
+        <p:spPr>
+          <a:xfrm>
+            <a:off x="457200" y="310896"/>
+            <a:ext cx="146304" cy="237744"/>
+          </a:xfrm>
+          <a:prstGeom prst="rect">
+            <a:avLst/>
+          </a:prstGeom>
+          <a:solidFill>
+            <a:srgbClr val="C0561B"/>
+          </a:solidFill>
+          <a:ln/>
+        </p:spPr>
+      </p:sp>
+      <p:sp>
+        <p:nvSpPr>
+          <p:cNvPr id="3" name="Text 1"/>
+          <p:cNvSpPr/>
+          <p:nvPr/>
+        </p:nvSpPr>
+        <p:spPr>
+          <a:xfrm>
+            <a:off x="676656" y="274320"/>
+            <a:ext cx="7863840" cy="320040"/>
+          </a:xfrm>
+          <a:prstGeom prst="rect">
+            <a:avLst/>
+          </a:prstGeom>
+          <a:noFill/>
+          <a:ln/>
+        </p:spPr>
+        <p:txBody>
+          <a:bodyPr wrap="square" lIns="0" tIns="0" rIns="0" bIns="0" rtlCol="0" anchor="ctr"/>
+          <a:lstStyle/>
+          <a:p>
+            <a:pPr marL="0" marR="0" lvl="0" indent="0" algn="l" defTabSz="914400" rtl="0" eaLnBrk="1" fontAlgn="auto" latinLnBrk="0" hangingPunct="1">
+              <a:lnSpc>
+                <a:spcPct val="100000"/>
+              </a:lnSpc>
+              <a:spcBef>
+                <a:spcPts val="0"/>
+              </a:spcBef>
+              <a:spcAft>
+                <a:spcPts val="0"/>
+              </a:spcAft>
+              <a:buClrTx/>
+              <a:buSzTx/>
+              <a:buFontTx/>
+              <a:buNone/>
+              <a:tabLst/>
+              <a:defRPr/>
+            </a:pPr>
+            <a:r>
+              <a:rPr kumimoji="0" lang="en-US" sz="1300" b="1" i="0" u="none" strike="noStrike" kern="0" cap="none" spc="300" normalizeH="0" baseline="0" noProof="0" dirty="0">
+                <a:ln>
+                  <a:noFill/>
+                </a:ln>
+                <a:solidFill>
+                  <a:srgbClr val="C0561B"/>
+                </a:solidFill>
+                <a:effectLst/>
+                <a:uLnTx/>
+                <a:uFillTx/>
+                <a:latin typeface="Calibri" panose="020F0502020204030204"/>
+                <a:ea typeface="+mn-ea"/>
+                <a:cs typeface="+mn-cs"/>
+              </a:rPr>
+              <a:t>DONOR VARIANCE</a:t>
+            </a:r>
+            <a:endParaRPr kumimoji="0" lang="en-US" sz="1300" b="0" i="0" u="none" strike="noStrike" kern="1200" cap="none" spc="0" normalizeH="0" baseline="0" noProof="0" dirty="0">
+              <a:ln>
+                <a:noFill/>
+              </a:ln>
+              <a:solidFill>
+                <a:prstClr val="black"/>
+              </a:solidFill>
+              <a:effectLst/>
+              <a:uLnTx/>
+              <a:uFillTx/>
+              <a:latin typeface="Calibri" panose="020F0502020204030204"/>
+              <a:ea typeface="+mn-ea"/>
+              <a:cs typeface="+mn-cs"/>
+            </a:endParaRPr>
+          </a:p>
+        </p:txBody>
+      </p:sp>
+      <p:sp>
+        <p:nvSpPr>
+          <p:cNvPr id="4" name="Text 2"/>
+          <p:cNvSpPr/>
+          <p:nvPr/>
+        </p:nvSpPr>
+        <p:spPr>
+          <a:xfrm>
+            <a:off x="8595360" y="292608"/>
+            <a:ext cx="3154680" cy="274320"/>
+          </a:xfrm>
+          <a:prstGeom prst="rect">
+            <a:avLst/>
+          </a:prstGeom>
+          <a:noFill/>
+          <a:ln/>
+        </p:spPr>
+        <p:txBody>
+          <a:bodyPr wrap="square" lIns="0" tIns="0" rIns="0" bIns="0" rtlCol="0" anchor="ctr"/>
+          <a:lstStyle/>
+          <a:p>
+            <a:pPr marL="0" marR="0" lvl="0" indent="0" algn="r" defTabSz="914400" rtl="0" eaLnBrk="1" fontAlgn="auto" latinLnBrk="0" hangingPunct="1">
+              <a:lnSpc>
+                <a:spcPct val="100000"/>
+              </a:lnSpc>
+              <a:spcBef>
+                <a:spcPts val="0"/>
+              </a:spcBef>
+              <a:spcAft>
+                <a:spcPts val="0"/>
+              </a:spcAft>
+              <a:buClrTx/>
+              <a:buSzTx/>
+              <a:buFontTx/>
+              <a:buNone/>
+              <a:tabLst/>
+              <a:defRPr/>
+            </a:pPr>
+            <a:r>
+              <a:rPr kumimoji="0" lang="en-US" sz="1100" b="1" i="0" u="none" strike="noStrike" kern="0" cap="none" spc="200" normalizeH="0" baseline="0" noProof="0" dirty="0">
+                <a:ln>
+                  <a:noFill/>
+                </a:ln>
+                <a:solidFill>
+                  <a:srgbClr val="1B6E78"/>
+                </a:solidFill>
+                <a:effectLst/>
+                <a:uLnTx/>
+                <a:uFillTx/>
+                <a:latin typeface="Calibri" panose="020F0502020204030204"/>
+                <a:ea typeface="+mn-ea"/>
+                <a:cs typeface="+mn-cs"/>
+              </a:rPr>
+              <a:t>QA</a:t>
+            </a:r>
+            <a:endParaRPr kumimoji="0" lang="en-US" sz="1100" b="0" i="0" u="none" strike="noStrike" kern="1200" cap="none" spc="0" normalizeH="0" baseline="0" noProof="0" dirty="0">
+              <a:ln>
+                <a:noFill/>
+              </a:ln>
+              <a:solidFill>
+                <a:prstClr val="black"/>
+              </a:solidFill>
+              <a:effectLst/>
+              <a:uLnTx/>
+              <a:uFillTx/>
+              <a:latin typeface="Calibri" panose="020F0502020204030204"/>
+              <a:ea typeface="+mn-ea"/>
+              <a:cs typeface="+mn-cs"/>
+            </a:endParaRPr>
+          </a:p>
+        </p:txBody>
+      </p:sp>
+      <p:sp>
+        <p:nvSpPr>
+          <p:cNvPr id="5" name="Text 3"/>
+          <p:cNvSpPr/>
+          <p:nvPr/>
+        </p:nvSpPr>
+        <p:spPr>
+          <a:xfrm>
+            <a:off x="438912" y="585216"/>
+            <a:ext cx="11338560" cy="777240"/>
+          </a:xfrm>
+          <a:prstGeom prst="rect">
+            <a:avLst/>
+          </a:prstGeom>
+          <a:noFill/>
+          <a:ln/>
+        </p:spPr>
+        <p:txBody>
+          <a:bodyPr wrap="square" lIns="0" tIns="0" rIns="0" bIns="0" rtlCol="0" anchor="t"/>
+          <a:lstStyle/>
+          <a:p>
+            <a:pPr marL="0" marR="0" lvl="0" indent="0" algn="l" defTabSz="914400" rtl="0" eaLnBrk="1" fontAlgn="auto" latinLnBrk="0" hangingPunct="1">
+              <a:lnSpc>
+                <a:spcPct val="100000"/>
+              </a:lnSpc>
+              <a:spcBef>
+                <a:spcPts val="0"/>
+              </a:spcBef>
+              <a:spcAft>
+                <a:spcPts val="0"/>
+              </a:spcAft>
+              <a:buClrTx/>
+              <a:buSzTx/>
+              <a:buFontTx/>
+              <a:buNone/>
+              <a:tabLst/>
+              <a:defRPr/>
+            </a:pPr>
+            <a:r>
+              <a:rPr kumimoji="0" lang="en-US" sz="2800" b="1" i="0" u="none" strike="noStrike" kern="1200" cap="none" spc="0" normalizeH="0" baseline="0" noProof="0" dirty="0">
+                <a:ln>
+                  <a:noFill/>
+                </a:ln>
+                <a:solidFill>
+                  <a:srgbClr val="1B2B31"/>
+                </a:solidFill>
+                <a:effectLst/>
+                <a:uLnTx/>
+                <a:uFillTx/>
+                <a:latin typeface="Georgia" pitchFamily="34" charset="0"/>
+                <a:ea typeface="Georgia" pitchFamily="34" charset="-122"/>
+                <a:cs typeface="Georgia" pitchFamily="34" charset="-120"/>
+              </a:rPr>
+              <a:t>Why a flat result is readable despite huge donor spread</a:t>
+            </a:r>
+            <a:endParaRPr kumimoji="0" lang="en-US" sz="2800" b="0" i="0" u="none" strike="noStrike" kern="1200" cap="none" spc="0" normalizeH="0" baseline="0" noProof="0" dirty="0">
+              <a:ln>
+                <a:noFill/>
+              </a:ln>
+              <a:solidFill>
+                <a:prstClr val="black"/>
+              </a:solidFill>
+              <a:effectLst/>
+              <a:uLnTx/>
+              <a:uFillTx/>
+              <a:latin typeface="Calibri" panose="020F0502020204030204"/>
+              <a:ea typeface="+mn-ea"/>
+              <a:cs typeface="+mn-cs"/>
+            </a:endParaRPr>
+          </a:p>
+        </p:txBody>
+      </p:sp>
+      <p:sp>
+        <p:nvSpPr>
+          <p:cNvPr id="6" name="Text 4"/>
+          <p:cNvSpPr/>
+          <p:nvPr/>
+        </p:nvSpPr>
+        <p:spPr>
+          <a:xfrm>
+            <a:off x="640080" y="1371600"/>
+            <a:ext cx="11247120" cy="457200"/>
+          </a:xfrm>
+          <a:prstGeom prst="rect">
+            <a:avLst/>
+          </a:prstGeom>
+          <a:noFill/>
+          <a:ln/>
+        </p:spPr>
+        <p:txBody>
+          <a:bodyPr wrap="square" rtlCol="0" anchor="ctr"/>
+          <a:lstStyle/>
+          <a:p>
+            <a:pPr marL="0" marR="0" lvl="0" indent="0" algn="l" defTabSz="914400" rtl="0" eaLnBrk="1" fontAlgn="auto" latinLnBrk="0" hangingPunct="1">
+              <a:lnSpc>
+                <a:spcPct val="100000"/>
+              </a:lnSpc>
+              <a:spcBef>
+                <a:spcPts val="0"/>
+              </a:spcBef>
+              <a:spcAft>
+                <a:spcPts val="0"/>
+              </a:spcAft>
+              <a:buClrTx/>
+              <a:buSzTx/>
+              <a:buFontTx/>
+              <a:buNone/>
+              <a:tabLst/>
+              <a:defRPr/>
+            </a:pPr>
+            <a:r>
+              <a:rPr kumimoji="0" lang="en-US" sz="1500" b="0" i="0" u="none" strike="noStrike" kern="1200" cap="none" spc="0" normalizeH="0" baseline="0" noProof="0" dirty="0">
+                <a:ln>
+                  <a:noFill/>
+                </a:ln>
+                <a:solidFill>
+                  <a:srgbClr val="1B2B31"/>
+                </a:solidFill>
+                <a:effectLst/>
+                <a:uLnTx/>
+                <a:uFillTx/>
+                <a:latin typeface="Calibri" panose="020F0502020204030204"/>
+                <a:ea typeface="+mn-ea"/>
+                <a:cs typeface="+mn-cs"/>
+              </a:rPr>
+              <a:t>Within each fibrosis stage the per-donor pericentral-anchor fraction spans ~25–35 pp (SD ≈ 12 pp). </a:t>
+            </a:r>
+          </a:p>
+          <a:p>
+            <a:pPr marL="0" marR="0" lvl="0" indent="0" algn="l" defTabSz="914400" rtl="0" eaLnBrk="1" fontAlgn="auto" latinLnBrk="0" hangingPunct="1">
+              <a:lnSpc>
+                <a:spcPct val="100000"/>
+              </a:lnSpc>
+              <a:spcBef>
+                <a:spcPts val="0"/>
+              </a:spcBef>
+              <a:spcAft>
+                <a:spcPts val="0"/>
+              </a:spcAft>
+              <a:buClrTx/>
+              <a:buSzTx/>
+              <a:buFontTx/>
+              <a:buNone/>
+              <a:tabLst/>
+              <a:defRPr/>
+            </a:pPr>
+            <a:r>
+              <a:rPr kumimoji="0" lang="en-US" sz="1500" b="1" i="0" u="none" strike="noStrike" kern="1200" cap="none" spc="0" normalizeH="0" baseline="0" noProof="0" dirty="0">
+                <a:ln>
+                  <a:noFill/>
+                </a:ln>
+                <a:solidFill>
+                  <a:srgbClr val="1B2B31"/>
+                </a:solidFill>
+                <a:effectLst/>
+                <a:uLnTx/>
+                <a:uFillTx/>
+                <a:latin typeface="Calibri" panose="020F0502020204030204"/>
+                <a:ea typeface="+mn-ea"/>
+                <a:cs typeface="+mn-cs"/>
+              </a:rPr>
+              <a:t>Could that scatter be hiding a real trend? No — four reasons:</a:t>
+            </a:r>
+            <a:endParaRPr kumimoji="0" lang="en-US" sz="1500" b="0" i="0" u="none" strike="noStrike" kern="1200" cap="none" spc="0" normalizeH="0" baseline="0" noProof="0" dirty="0">
+              <a:ln>
+                <a:noFill/>
+              </a:ln>
+              <a:solidFill>
+                <a:prstClr val="black"/>
+              </a:solidFill>
+              <a:effectLst/>
+              <a:uLnTx/>
+              <a:uFillTx/>
+              <a:latin typeface="Calibri" panose="020F0502020204030204"/>
+              <a:ea typeface="+mn-ea"/>
+              <a:cs typeface="+mn-cs"/>
+            </a:endParaRPr>
+          </a:p>
+        </p:txBody>
+      </p:sp>
+      <p:sp>
+        <p:nvSpPr>
+          <p:cNvPr id="7" name="Shape 5"/>
+          <p:cNvSpPr/>
+          <p:nvPr/>
+        </p:nvSpPr>
+        <p:spPr>
+          <a:xfrm>
+            <a:off x="640080" y="2011680"/>
+            <a:ext cx="5394960" cy="1417320"/>
+          </a:xfrm>
+          <a:prstGeom prst="roundRect">
+            <a:avLst>
+              <a:gd name="adj" fmla="val 3871"/>
+            </a:avLst>
+          </a:prstGeom>
+          <a:solidFill>
+            <a:srgbClr val="FFFFFF"/>
+          </a:solidFill>
+          <a:ln w="12700">
+            <a:solidFill>
+              <a:srgbClr val="E2DCCF"/>
+            </a:solidFill>
+            <a:prstDash val="solid"/>
+          </a:ln>
+          <a:effectLst>
+            <a:outerShdw blurRad="88900" dist="38100" dir="5400000" algn="bl" rotWithShape="0">
+              <a:srgbClr val="000000">
+                <a:alpha val="12000"/>
+              </a:srgbClr>
+            </a:outerShdw>
+          </a:effectLst>
+        </p:spPr>
+      </p:sp>
+      <p:sp>
+        <p:nvSpPr>
+          <p:cNvPr id="8" name="Shape 6"/>
+          <p:cNvSpPr/>
+          <p:nvPr/>
+        </p:nvSpPr>
+        <p:spPr>
+          <a:xfrm>
+            <a:off x="640080" y="2011680"/>
+            <a:ext cx="91440" cy="1417320"/>
+          </a:xfrm>
+          <a:prstGeom prst="rect">
+            <a:avLst/>
+          </a:prstGeom>
+          <a:solidFill>
+            <a:srgbClr val="1D4ED8"/>
+          </a:solidFill>
+          <a:ln/>
+        </p:spPr>
+      </p:sp>
+      <p:sp>
+        <p:nvSpPr>
+          <p:cNvPr id="9" name="Text 7"/>
+          <p:cNvSpPr/>
+          <p:nvPr/>
+        </p:nvSpPr>
+        <p:spPr>
+          <a:xfrm>
+            <a:off x="896112" y="2121408"/>
+            <a:ext cx="548640" cy="548640"/>
+          </a:xfrm>
+          <a:prstGeom prst="rect">
+            <a:avLst/>
+          </a:prstGeom>
+          <a:noFill/>
+          <a:ln/>
+        </p:spPr>
+        <p:txBody>
+          <a:bodyPr wrap="square" lIns="0" tIns="0" rIns="0" bIns="0" rtlCol="0" anchor="t"/>
+          <a:lstStyle/>
+          <a:p>
+            <a:pPr marL="0" marR="0" lvl="0" indent="0" algn="l" defTabSz="914400" rtl="0" eaLnBrk="1" fontAlgn="auto" latinLnBrk="0" hangingPunct="1">
+              <a:lnSpc>
+                <a:spcPct val="100000"/>
+              </a:lnSpc>
+              <a:spcBef>
+                <a:spcPts val="0"/>
+              </a:spcBef>
+              <a:spcAft>
+                <a:spcPts val="0"/>
+              </a:spcAft>
+              <a:buClrTx/>
+              <a:buSzTx/>
+              <a:buFontTx/>
+              <a:buNone/>
+              <a:tabLst/>
+              <a:defRPr/>
+            </a:pPr>
+            <a:r>
+              <a:rPr kumimoji="0" lang="en-US" sz="2600" b="1" i="0" u="none" strike="noStrike" kern="1200" cap="none" spc="0" normalizeH="0" baseline="0" noProof="0" dirty="0">
+                <a:ln>
+                  <a:noFill/>
+                </a:ln>
+                <a:solidFill>
+                  <a:srgbClr val="1D4ED8"/>
+                </a:solidFill>
+                <a:effectLst/>
+                <a:uLnTx/>
+                <a:uFillTx/>
+                <a:latin typeface="Georgia" pitchFamily="34" charset="0"/>
+                <a:ea typeface="Georgia" pitchFamily="34" charset="-122"/>
+                <a:cs typeface="Georgia" pitchFamily="34" charset="-120"/>
+              </a:rPr>
+              <a:t>1</a:t>
+            </a:r>
+            <a:endParaRPr kumimoji="0" lang="en-US" sz="2600" b="0" i="0" u="none" strike="noStrike" kern="1200" cap="none" spc="0" normalizeH="0" baseline="0" noProof="0" dirty="0">
+              <a:ln>
+                <a:noFill/>
+              </a:ln>
+              <a:solidFill>
+                <a:prstClr val="black"/>
+              </a:solidFill>
+              <a:effectLst/>
+              <a:uLnTx/>
+              <a:uFillTx/>
+              <a:latin typeface="Calibri" panose="020F0502020204030204"/>
+              <a:ea typeface="+mn-ea"/>
+              <a:cs typeface="+mn-cs"/>
+            </a:endParaRPr>
+          </a:p>
+        </p:txBody>
+      </p:sp>
+      <p:sp>
+        <p:nvSpPr>
+          <p:cNvPr id="10" name="Text 8"/>
+          <p:cNvSpPr/>
+          <p:nvPr/>
+        </p:nvSpPr>
+        <p:spPr>
+          <a:xfrm>
+            <a:off x="1463040" y="2157984"/>
+            <a:ext cx="4434840" cy="457200"/>
+          </a:xfrm>
+          <a:prstGeom prst="rect">
+            <a:avLst/>
+          </a:prstGeom>
+          <a:noFill/>
+          <a:ln/>
+        </p:spPr>
+        <p:txBody>
+          <a:bodyPr wrap="square" lIns="0" tIns="0" rIns="0" bIns="0" rtlCol="0" anchor="t"/>
+          <a:lstStyle/>
+          <a:p>
+            <a:pPr marL="0" marR="0" lvl="0" indent="0" algn="l" defTabSz="914400" rtl="0" eaLnBrk="1" fontAlgn="auto" latinLnBrk="0" hangingPunct="1">
+              <a:lnSpc>
+                <a:spcPct val="100000"/>
+              </a:lnSpc>
+              <a:spcBef>
+                <a:spcPts val="0"/>
+              </a:spcBef>
+              <a:spcAft>
+                <a:spcPts val="0"/>
+              </a:spcAft>
+              <a:buClrTx/>
+              <a:buSzTx/>
+              <a:buFontTx/>
+              <a:buNone/>
+              <a:tabLst/>
+              <a:defRPr/>
+            </a:pPr>
+            <a:r>
+              <a:rPr kumimoji="0" lang="en-US" sz="1450" b="1" i="0" u="none" strike="noStrike" kern="1200" cap="none" spc="0" normalizeH="0" baseline="0" noProof="0" dirty="0">
+                <a:ln>
+                  <a:noFill/>
+                </a:ln>
+                <a:solidFill>
+                  <a:srgbClr val="1B2B31"/>
+                </a:solidFill>
+                <a:effectLst/>
+                <a:uLnTx/>
+                <a:uFillTx/>
+                <a:latin typeface="Calibri" panose="020F0502020204030204"/>
+                <a:ea typeface="+mn-ea"/>
+                <a:cs typeface="+mn-cs"/>
+              </a:rPr>
+              <a:t>The donor is the replicate — not the cell</a:t>
+            </a:r>
+            <a:endParaRPr kumimoji="0" lang="en-US" sz="1450" b="0" i="0" u="none" strike="noStrike" kern="1200" cap="none" spc="0" normalizeH="0" baseline="0" noProof="0" dirty="0">
+              <a:ln>
+                <a:noFill/>
+              </a:ln>
+              <a:solidFill>
+                <a:prstClr val="black"/>
+              </a:solidFill>
+              <a:effectLst/>
+              <a:uLnTx/>
+              <a:uFillTx/>
+              <a:latin typeface="Calibri" panose="020F0502020204030204"/>
+              <a:ea typeface="+mn-ea"/>
+              <a:cs typeface="+mn-cs"/>
+            </a:endParaRPr>
+          </a:p>
+        </p:txBody>
+      </p:sp>
+      <p:sp>
+        <p:nvSpPr>
+          <p:cNvPr id="11" name="Text 9"/>
+          <p:cNvSpPr/>
+          <p:nvPr/>
+        </p:nvSpPr>
+        <p:spPr>
+          <a:xfrm>
+            <a:off x="1463040" y="2578608"/>
+            <a:ext cx="4434840" cy="777240"/>
+          </a:xfrm>
+          <a:prstGeom prst="rect">
+            <a:avLst/>
+          </a:prstGeom>
+          <a:noFill/>
+          <a:ln/>
+        </p:spPr>
+        <p:txBody>
+          <a:bodyPr wrap="square" lIns="0" tIns="0" rIns="0" bIns="0" rtlCol="0" anchor="t"/>
+          <a:lstStyle/>
+          <a:p>
+            <a:pPr marL="0" marR="0" lvl="0" indent="0" algn="l" defTabSz="914400" rtl="0" eaLnBrk="1" fontAlgn="auto" latinLnBrk="0" hangingPunct="1">
+              <a:lnSpc>
+                <a:spcPct val="100000"/>
+              </a:lnSpc>
+              <a:spcBef>
+                <a:spcPts val="0"/>
+              </a:spcBef>
+              <a:spcAft>
+                <a:spcPts val="0"/>
+              </a:spcAft>
+              <a:buClrTx/>
+              <a:buSzTx/>
+              <a:buFontTx/>
+              <a:buNone/>
+              <a:tabLst/>
+              <a:defRPr/>
+            </a:pPr>
+            <a:r>
+              <a:rPr kumimoji="0" lang="en-US" sz="1150" b="0" i="0" u="none" strike="noStrike" kern="1200" cap="none" spc="0" normalizeH="0" baseline="0" noProof="0" dirty="0">
+                <a:ln>
+                  <a:noFill/>
+                </a:ln>
+                <a:solidFill>
+                  <a:srgbClr val="334155"/>
+                </a:solidFill>
+                <a:effectLst/>
+                <a:uLnTx/>
+                <a:uFillTx/>
+                <a:latin typeface="Calibri" panose="020F0502020204030204"/>
+                <a:ea typeface="+mn-ea"/>
+                <a:cs typeface="+mn-cs"/>
+              </a:rPr>
+              <a:t>Inference is donor-level (F1–F4 = 8 / 12 / 12 / 4). A stage MEAN has standard error SE ≈ SD/√n ≈ 12/√10 ≈ 4 pp — we compare stage means (± 4 pp), not individual donors (± 12 pp).</a:t>
+            </a:r>
+            <a:endParaRPr kumimoji="0" lang="en-US" sz="1150" b="0" i="0" u="none" strike="noStrike" kern="1200" cap="none" spc="0" normalizeH="0" baseline="0" noProof="0" dirty="0">
+              <a:ln>
+                <a:noFill/>
+              </a:ln>
+              <a:solidFill>
+                <a:prstClr val="black"/>
+              </a:solidFill>
+              <a:effectLst/>
+              <a:uLnTx/>
+              <a:uFillTx/>
+              <a:latin typeface="Calibri" panose="020F0502020204030204"/>
+              <a:ea typeface="+mn-ea"/>
+              <a:cs typeface="+mn-cs"/>
+            </a:endParaRPr>
+          </a:p>
+        </p:txBody>
+      </p:sp>
+      <p:sp>
+        <p:nvSpPr>
+          <p:cNvPr id="12" name="Shape 10"/>
+          <p:cNvSpPr/>
+          <p:nvPr/>
+        </p:nvSpPr>
+        <p:spPr>
+          <a:xfrm>
+            <a:off x="6172200" y="2011680"/>
+            <a:ext cx="5394960" cy="1417320"/>
+          </a:xfrm>
+          <a:prstGeom prst="roundRect">
+            <a:avLst>
+              <a:gd name="adj" fmla="val 3871"/>
+            </a:avLst>
+          </a:prstGeom>
+          <a:solidFill>
+            <a:srgbClr val="FFFFFF"/>
+          </a:solidFill>
+          <a:ln w="12700">
+            <a:solidFill>
+              <a:srgbClr val="E2DCCF"/>
+            </a:solidFill>
+            <a:prstDash val="solid"/>
+          </a:ln>
+          <a:effectLst>
+            <a:outerShdw blurRad="88900" dist="38100" dir="5400000" algn="bl" rotWithShape="0">
+              <a:srgbClr val="000000">
+                <a:alpha val="12000"/>
+              </a:srgbClr>
+            </a:outerShdw>
+          </a:effectLst>
+        </p:spPr>
+      </p:sp>
+      <p:sp>
+        <p:nvSpPr>
+          <p:cNvPr id="13" name="Shape 11"/>
+          <p:cNvSpPr/>
+          <p:nvPr/>
+        </p:nvSpPr>
+        <p:spPr>
+          <a:xfrm>
+            <a:off x="6172200" y="2011680"/>
+            <a:ext cx="91440" cy="1417320"/>
+          </a:xfrm>
+          <a:prstGeom prst="rect">
+            <a:avLst/>
+          </a:prstGeom>
+          <a:solidFill>
+            <a:srgbClr val="0D9488"/>
+          </a:solidFill>
+          <a:ln/>
+        </p:spPr>
+      </p:sp>
+      <p:sp>
+        <p:nvSpPr>
+          <p:cNvPr id="14" name="Text 12"/>
+          <p:cNvSpPr/>
+          <p:nvPr/>
+        </p:nvSpPr>
+        <p:spPr>
+          <a:xfrm>
+            <a:off x="6428232" y="2121408"/>
+            <a:ext cx="548640" cy="548640"/>
+          </a:xfrm>
+          <a:prstGeom prst="rect">
+            <a:avLst/>
+          </a:prstGeom>
+          <a:noFill/>
+          <a:ln/>
+        </p:spPr>
+        <p:txBody>
+          <a:bodyPr wrap="square" lIns="0" tIns="0" rIns="0" bIns="0" rtlCol="0" anchor="t"/>
+          <a:lstStyle/>
+          <a:p>
+            <a:pPr marL="0" marR="0" lvl="0" indent="0" algn="l" defTabSz="914400" rtl="0" eaLnBrk="1" fontAlgn="auto" latinLnBrk="0" hangingPunct="1">
+              <a:lnSpc>
+                <a:spcPct val="100000"/>
+              </a:lnSpc>
+              <a:spcBef>
+                <a:spcPts val="0"/>
+              </a:spcBef>
+              <a:spcAft>
+                <a:spcPts val="0"/>
+              </a:spcAft>
+              <a:buClrTx/>
+              <a:buSzTx/>
+              <a:buFontTx/>
+              <a:buNone/>
+              <a:tabLst/>
+              <a:defRPr/>
+            </a:pPr>
+            <a:r>
+              <a:rPr kumimoji="0" lang="en-US" sz="2600" b="1" i="0" u="none" strike="noStrike" kern="1200" cap="none" spc="0" normalizeH="0" baseline="0" noProof="0" dirty="0">
+                <a:ln>
+                  <a:noFill/>
+                </a:ln>
+                <a:solidFill>
+                  <a:srgbClr val="0D9488"/>
+                </a:solidFill>
+                <a:effectLst/>
+                <a:uLnTx/>
+                <a:uFillTx/>
+                <a:latin typeface="Georgia" pitchFamily="34" charset="0"/>
+                <a:ea typeface="Georgia" pitchFamily="34" charset="-122"/>
+                <a:cs typeface="Georgia" pitchFamily="34" charset="-120"/>
+              </a:rPr>
+              <a:t>2</a:t>
+            </a:r>
+            <a:endParaRPr kumimoji="0" lang="en-US" sz="2600" b="0" i="0" u="none" strike="noStrike" kern="1200" cap="none" spc="0" normalizeH="0" baseline="0" noProof="0" dirty="0">
+              <a:ln>
+                <a:noFill/>
+              </a:ln>
+              <a:solidFill>
+                <a:prstClr val="black"/>
+              </a:solidFill>
+              <a:effectLst/>
+              <a:uLnTx/>
+              <a:uFillTx/>
+              <a:latin typeface="Calibri" panose="020F0502020204030204"/>
+              <a:ea typeface="+mn-ea"/>
+              <a:cs typeface="+mn-cs"/>
+            </a:endParaRPr>
+          </a:p>
+        </p:txBody>
+      </p:sp>
+      <p:sp>
+        <p:nvSpPr>
+          <p:cNvPr id="15" name="Text 13"/>
+          <p:cNvSpPr/>
+          <p:nvPr/>
+        </p:nvSpPr>
+        <p:spPr>
+          <a:xfrm>
+            <a:off x="6995160" y="2157984"/>
+            <a:ext cx="4434840" cy="457200"/>
+          </a:xfrm>
+          <a:prstGeom prst="rect">
+            <a:avLst/>
+          </a:prstGeom>
+          <a:noFill/>
+          <a:ln/>
+        </p:spPr>
+        <p:txBody>
+          <a:bodyPr wrap="square" lIns="0" tIns="0" rIns="0" bIns="0" rtlCol="0" anchor="t"/>
+          <a:lstStyle/>
+          <a:p>
+            <a:pPr marL="0" marR="0" lvl="0" indent="0" algn="l" defTabSz="914400" rtl="0" eaLnBrk="1" fontAlgn="auto" latinLnBrk="0" hangingPunct="1">
+              <a:lnSpc>
+                <a:spcPct val="100000"/>
+              </a:lnSpc>
+              <a:spcBef>
+                <a:spcPts val="0"/>
+              </a:spcBef>
+              <a:spcAft>
+                <a:spcPts val="0"/>
+              </a:spcAft>
+              <a:buClrTx/>
+              <a:buSzTx/>
+              <a:buFontTx/>
+              <a:buNone/>
+              <a:tabLst/>
+              <a:defRPr/>
+            </a:pPr>
+            <a:r>
+              <a:rPr kumimoji="0" lang="en-US" sz="1450" b="1" i="0" u="none" strike="noStrike" kern="1200" cap="none" spc="0" normalizeH="0" baseline="0" noProof="0" dirty="0">
+                <a:ln>
+                  <a:noFill/>
+                </a:ln>
+                <a:solidFill>
+                  <a:srgbClr val="1B2B31"/>
+                </a:solidFill>
+                <a:effectLst/>
+                <a:uLnTx/>
+                <a:uFillTx/>
+                <a:latin typeface="Calibri" panose="020F0502020204030204"/>
+                <a:ea typeface="+mn-ea"/>
+                <a:cs typeface="+mn-cs"/>
+              </a:rPr>
+              <a:t>The spread is the same at every stage</a:t>
+            </a:r>
+            <a:endParaRPr kumimoji="0" lang="en-US" sz="1450" b="0" i="0" u="none" strike="noStrike" kern="1200" cap="none" spc="0" normalizeH="0" baseline="0" noProof="0" dirty="0">
+              <a:ln>
+                <a:noFill/>
+              </a:ln>
+              <a:solidFill>
+                <a:prstClr val="black"/>
+              </a:solidFill>
+              <a:effectLst/>
+              <a:uLnTx/>
+              <a:uFillTx/>
+              <a:latin typeface="Calibri" panose="020F0502020204030204"/>
+              <a:ea typeface="+mn-ea"/>
+              <a:cs typeface="+mn-cs"/>
+            </a:endParaRPr>
+          </a:p>
+        </p:txBody>
+      </p:sp>
+      <p:sp>
+        <p:nvSpPr>
+          <p:cNvPr id="16" name="Text 14"/>
+          <p:cNvSpPr/>
+          <p:nvPr/>
+        </p:nvSpPr>
+        <p:spPr>
+          <a:xfrm>
+            <a:off x="6995160" y="2578608"/>
+            <a:ext cx="4434840" cy="777240"/>
+          </a:xfrm>
+          <a:prstGeom prst="rect">
+            <a:avLst/>
+          </a:prstGeom>
+          <a:noFill/>
+          <a:ln/>
+        </p:spPr>
+        <p:txBody>
+          <a:bodyPr wrap="square" lIns="0" tIns="0" rIns="0" bIns="0" rtlCol="0" anchor="t"/>
+          <a:lstStyle/>
+          <a:p>
+            <a:pPr marL="0" marR="0" lvl="0" indent="0" algn="l" defTabSz="914400" rtl="0" eaLnBrk="1" fontAlgn="auto" latinLnBrk="0" hangingPunct="1">
+              <a:lnSpc>
+                <a:spcPct val="100000"/>
+              </a:lnSpc>
+              <a:spcBef>
+                <a:spcPts val="0"/>
+              </a:spcBef>
+              <a:spcAft>
+                <a:spcPts val="0"/>
+              </a:spcAft>
+              <a:buClrTx/>
+              <a:buSzTx/>
+              <a:buFontTx/>
+              <a:buNone/>
+              <a:tabLst/>
+              <a:defRPr/>
+            </a:pPr>
+            <a:r>
+              <a:rPr kumimoji="0" lang="en-US" sz="1150" b="0" i="0" u="none" strike="noStrike" kern="1200" cap="none" spc="0" normalizeH="0" baseline="0" noProof="0" dirty="0">
+                <a:ln>
+                  <a:noFill/>
+                </a:ln>
+                <a:solidFill>
+                  <a:srgbClr val="334155"/>
+                </a:solidFill>
+                <a:effectLst/>
+                <a:uLnTx/>
+                <a:uFillTx/>
+                <a:latin typeface="Calibri" panose="020F0502020204030204"/>
+                <a:ea typeface="+mn-ea"/>
+                <a:cs typeface="+mn-cs"/>
+              </a:rPr>
+              <a:t>Variance is homoscedastic — as wide at F1 as at F4. A real progression would shift the mean monotonically beyond ± 4 pp; it doesn’t. This is noise around a flat line, not a trend buried in noise.</a:t>
+            </a:r>
+            <a:endParaRPr kumimoji="0" lang="en-US" sz="1150" b="0" i="0" u="none" strike="noStrike" kern="1200" cap="none" spc="0" normalizeH="0" baseline="0" noProof="0" dirty="0">
+              <a:ln>
+                <a:noFill/>
+              </a:ln>
+              <a:solidFill>
+                <a:prstClr val="black"/>
+              </a:solidFill>
+              <a:effectLst/>
+              <a:uLnTx/>
+              <a:uFillTx/>
+              <a:latin typeface="Calibri" panose="020F0502020204030204"/>
+              <a:ea typeface="+mn-ea"/>
+              <a:cs typeface="+mn-cs"/>
+            </a:endParaRPr>
+          </a:p>
+        </p:txBody>
+      </p:sp>
+      <p:sp>
+        <p:nvSpPr>
+          <p:cNvPr id="17" name="Shape 15"/>
+          <p:cNvSpPr/>
+          <p:nvPr/>
+        </p:nvSpPr>
+        <p:spPr>
+          <a:xfrm>
+            <a:off x="640080" y="3584448"/>
+            <a:ext cx="5394960" cy="1417320"/>
+          </a:xfrm>
+          <a:prstGeom prst="roundRect">
+            <a:avLst>
+              <a:gd name="adj" fmla="val 3871"/>
+            </a:avLst>
+          </a:prstGeom>
+          <a:solidFill>
+            <a:srgbClr val="FFFFFF"/>
+          </a:solidFill>
+          <a:ln w="12700">
+            <a:solidFill>
+              <a:srgbClr val="E2DCCF"/>
+            </a:solidFill>
+            <a:prstDash val="solid"/>
+          </a:ln>
+          <a:effectLst>
+            <a:outerShdw blurRad="88900" dist="38100" dir="5400000" algn="bl" rotWithShape="0">
+              <a:srgbClr val="000000">
+                <a:alpha val="12000"/>
+              </a:srgbClr>
+            </a:outerShdw>
+          </a:effectLst>
+        </p:spPr>
+      </p:sp>
+      <p:sp>
+        <p:nvSpPr>
+          <p:cNvPr id="18" name="Shape 16"/>
+          <p:cNvSpPr/>
+          <p:nvPr/>
+        </p:nvSpPr>
+        <p:spPr>
+          <a:xfrm>
+            <a:off x="640080" y="3584448"/>
+            <a:ext cx="91440" cy="1417320"/>
+          </a:xfrm>
+          <a:prstGeom prst="rect">
+            <a:avLst/>
+          </a:prstGeom>
+          <a:solidFill>
+            <a:srgbClr val="7C3AED"/>
+          </a:solidFill>
+          <a:ln/>
+        </p:spPr>
+      </p:sp>
+      <p:sp>
+        <p:nvSpPr>
+          <p:cNvPr id="19" name="Text 17"/>
+          <p:cNvSpPr/>
+          <p:nvPr/>
+        </p:nvSpPr>
+        <p:spPr>
+          <a:xfrm>
+            <a:off x="896112" y="3694176"/>
+            <a:ext cx="548640" cy="548640"/>
+          </a:xfrm>
+          <a:prstGeom prst="rect">
+            <a:avLst/>
+          </a:prstGeom>
+          <a:noFill/>
+          <a:ln/>
+        </p:spPr>
+        <p:txBody>
+          <a:bodyPr wrap="square" lIns="0" tIns="0" rIns="0" bIns="0" rtlCol="0" anchor="t"/>
+          <a:lstStyle/>
+          <a:p>
+            <a:pPr marL="0" marR="0" lvl="0" indent="0" algn="l" defTabSz="914400" rtl="0" eaLnBrk="1" fontAlgn="auto" latinLnBrk="0" hangingPunct="1">
+              <a:lnSpc>
+                <a:spcPct val="100000"/>
+              </a:lnSpc>
+              <a:spcBef>
+                <a:spcPts val="0"/>
+              </a:spcBef>
+              <a:spcAft>
+                <a:spcPts val="0"/>
+              </a:spcAft>
+              <a:buClrTx/>
+              <a:buSzTx/>
+              <a:buFontTx/>
+              <a:buNone/>
+              <a:tabLst/>
+              <a:defRPr/>
+            </a:pPr>
+            <a:r>
+              <a:rPr kumimoji="0" lang="en-US" sz="2600" b="1" i="0" u="none" strike="noStrike" kern="1200" cap="none" spc="0" normalizeH="0" baseline="0" noProof="0" dirty="0">
+                <a:ln>
+                  <a:noFill/>
+                </a:ln>
+                <a:solidFill>
+                  <a:srgbClr val="7C3AED"/>
+                </a:solidFill>
+                <a:effectLst/>
+                <a:uLnTx/>
+                <a:uFillTx/>
+                <a:latin typeface="Georgia" pitchFamily="34" charset="0"/>
+                <a:ea typeface="Georgia" pitchFamily="34" charset="-122"/>
+                <a:cs typeface="Georgia" pitchFamily="34" charset="-120"/>
+              </a:rPr>
+              <a:t>3</a:t>
+            </a:r>
+            <a:endParaRPr kumimoji="0" lang="en-US" sz="2600" b="0" i="0" u="none" strike="noStrike" kern="1200" cap="none" spc="0" normalizeH="0" baseline="0" noProof="0" dirty="0">
+              <a:ln>
+                <a:noFill/>
+              </a:ln>
+              <a:solidFill>
+                <a:prstClr val="black"/>
+              </a:solidFill>
+              <a:effectLst/>
+              <a:uLnTx/>
+              <a:uFillTx/>
+              <a:latin typeface="Calibri" panose="020F0502020204030204"/>
+              <a:ea typeface="+mn-ea"/>
+              <a:cs typeface="+mn-cs"/>
+            </a:endParaRPr>
+          </a:p>
+        </p:txBody>
+      </p:sp>
+      <p:sp>
+        <p:nvSpPr>
+          <p:cNvPr id="20" name="Text 18"/>
+          <p:cNvSpPr/>
+          <p:nvPr/>
+        </p:nvSpPr>
+        <p:spPr>
+          <a:xfrm>
+            <a:off x="1463040" y="3730752"/>
+            <a:ext cx="4434840" cy="457200"/>
+          </a:xfrm>
+          <a:prstGeom prst="rect">
+            <a:avLst/>
+          </a:prstGeom>
+          <a:noFill/>
+          <a:ln/>
+        </p:spPr>
+        <p:txBody>
+          <a:bodyPr wrap="square" lIns="0" tIns="0" rIns="0" bIns="0" rtlCol="0" anchor="t"/>
+          <a:lstStyle/>
+          <a:p>
+            <a:pPr marL="0" marR="0" lvl="0" indent="0" algn="l" defTabSz="914400" rtl="0" eaLnBrk="1" fontAlgn="auto" latinLnBrk="0" hangingPunct="1">
+              <a:lnSpc>
+                <a:spcPct val="100000"/>
+              </a:lnSpc>
+              <a:spcBef>
+                <a:spcPts val="0"/>
+              </a:spcBef>
+              <a:spcAft>
+                <a:spcPts val="0"/>
+              </a:spcAft>
+              <a:buClrTx/>
+              <a:buSzTx/>
+              <a:buFontTx/>
+              <a:buNone/>
+              <a:tabLst/>
+              <a:defRPr/>
+            </a:pPr>
+            <a:r>
+              <a:rPr kumimoji="0" lang="en-US" sz="1450" b="1" i="0" u="none" strike="noStrike" kern="1200" cap="none" spc="0" normalizeH="0" baseline="0" noProof="0" dirty="0">
+                <a:ln>
+                  <a:noFill/>
+                </a:ln>
+                <a:solidFill>
+                  <a:srgbClr val="1B2B31"/>
+                </a:solidFill>
+                <a:effectLst/>
+                <a:uLnTx/>
+                <a:uFillTx/>
+                <a:latin typeface="Calibri" panose="020F0502020204030204"/>
+                <a:ea typeface="+mn-ea"/>
+                <a:cs typeface="+mn-cs"/>
+              </a:rPr>
+              <a:t>We bound what is excluded (TOST)</a:t>
+            </a:r>
+            <a:endParaRPr kumimoji="0" lang="en-US" sz="1450" b="0" i="0" u="none" strike="noStrike" kern="1200" cap="none" spc="0" normalizeH="0" baseline="0" noProof="0" dirty="0">
+              <a:ln>
+                <a:noFill/>
+              </a:ln>
+              <a:solidFill>
+                <a:prstClr val="black"/>
+              </a:solidFill>
+              <a:effectLst/>
+              <a:uLnTx/>
+              <a:uFillTx/>
+              <a:latin typeface="Calibri" panose="020F0502020204030204"/>
+              <a:ea typeface="+mn-ea"/>
+              <a:cs typeface="+mn-cs"/>
+            </a:endParaRPr>
+          </a:p>
+        </p:txBody>
+      </p:sp>
+      <p:sp>
+        <p:nvSpPr>
+          <p:cNvPr id="21" name="Text 19"/>
+          <p:cNvSpPr/>
+          <p:nvPr/>
+        </p:nvSpPr>
+        <p:spPr>
+          <a:xfrm>
+            <a:off x="1463040" y="4151376"/>
+            <a:ext cx="4434840" cy="777240"/>
+          </a:xfrm>
+          <a:prstGeom prst="rect">
+            <a:avLst/>
+          </a:prstGeom>
+          <a:noFill/>
+          <a:ln/>
+        </p:spPr>
+        <p:txBody>
+          <a:bodyPr wrap="square" lIns="0" tIns="0" rIns="0" bIns="0" rtlCol="0" anchor="t"/>
+          <a:lstStyle/>
+          <a:p>
+            <a:pPr marL="0" marR="0" lvl="0" indent="0" algn="l" defTabSz="914400" rtl="0" eaLnBrk="1" fontAlgn="auto" latinLnBrk="0" hangingPunct="1">
+              <a:lnSpc>
+                <a:spcPct val="100000"/>
+              </a:lnSpc>
+              <a:spcBef>
+                <a:spcPts val="0"/>
+              </a:spcBef>
+              <a:spcAft>
+                <a:spcPts val="0"/>
+              </a:spcAft>
+              <a:buClrTx/>
+              <a:buSzTx/>
+              <a:buFontTx/>
+              <a:buNone/>
+              <a:tabLst/>
+              <a:defRPr/>
+            </a:pPr>
+            <a:r>
+              <a:rPr kumimoji="0" lang="en-US" sz="1150" b="0" i="0" u="none" strike="noStrike" kern="1200" cap="none" spc="0" normalizeH="0" baseline="0" noProof="0" dirty="0">
+                <a:ln>
+                  <a:noFill/>
+                </a:ln>
+                <a:solidFill>
+                  <a:srgbClr val="334155"/>
+                </a:solidFill>
+                <a:effectLst/>
+                <a:uLnTx/>
+                <a:uFillTx/>
+                <a:latin typeface="Calibri" panose="020F0502020204030204"/>
+                <a:ea typeface="+mn-ea"/>
+                <a:cs typeface="+mn-cs"/>
+              </a:rPr>
+              <a:t>Not merely “no trend found”: a shift &gt; ± 19 pp between F1 and F4 is positively rejected at the donor level. Only a subtle drift (≤ 10 pp) remains possible — limited by F4’s n = 4.</a:t>
+            </a:r>
+            <a:endParaRPr kumimoji="0" lang="en-US" sz="1150" b="0" i="0" u="none" strike="noStrike" kern="1200" cap="none" spc="0" normalizeH="0" baseline="0" noProof="0" dirty="0">
+              <a:ln>
+                <a:noFill/>
+              </a:ln>
+              <a:solidFill>
+                <a:prstClr val="black"/>
+              </a:solidFill>
+              <a:effectLst/>
+              <a:uLnTx/>
+              <a:uFillTx/>
+              <a:latin typeface="Calibri" panose="020F0502020204030204"/>
+              <a:ea typeface="+mn-ea"/>
+              <a:cs typeface="+mn-cs"/>
+            </a:endParaRPr>
+          </a:p>
+        </p:txBody>
+      </p:sp>
+      <p:sp>
+        <p:nvSpPr>
+          <p:cNvPr id="22" name="Shape 20"/>
+          <p:cNvSpPr/>
+          <p:nvPr/>
+        </p:nvSpPr>
+        <p:spPr>
+          <a:xfrm>
+            <a:off x="6172200" y="3584448"/>
+            <a:ext cx="5394960" cy="1417320"/>
+          </a:xfrm>
+          <a:prstGeom prst="roundRect">
+            <a:avLst>
+              <a:gd name="adj" fmla="val 3871"/>
+            </a:avLst>
+          </a:prstGeom>
+          <a:solidFill>
+            <a:srgbClr val="FFFFFF"/>
+          </a:solidFill>
+          <a:ln w="12700">
+            <a:solidFill>
+              <a:srgbClr val="E2DCCF"/>
+            </a:solidFill>
+            <a:prstDash val="solid"/>
+          </a:ln>
+          <a:effectLst>
+            <a:outerShdw blurRad="88900" dist="38100" dir="5400000" algn="bl" rotWithShape="0">
+              <a:srgbClr val="000000">
+                <a:alpha val="12000"/>
+              </a:srgbClr>
+            </a:outerShdw>
+          </a:effectLst>
+        </p:spPr>
+      </p:sp>
+      <p:sp>
+        <p:nvSpPr>
+          <p:cNvPr id="23" name="Shape 21"/>
+          <p:cNvSpPr/>
+          <p:nvPr/>
+        </p:nvSpPr>
+        <p:spPr>
+          <a:xfrm>
+            <a:off x="6172200" y="3584448"/>
+            <a:ext cx="91440" cy="1417320"/>
+          </a:xfrm>
+          <a:prstGeom prst="rect">
+            <a:avLst/>
+          </a:prstGeom>
+          <a:solidFill>
+            <a:srgbClr val="C0561B"/>
+          </a:solidFill>
+          <a:ln/>
+        </p:spPr>
+      </p:sp>
+      <p:sp>
+        <p:nvSpPr>
+          <p:cNvPr id="24" name="Text 22"/>
+          <p:cNvSpPr/>
+          <p:nvPr/>
+        </p:nvSpPr>
+        <p:spPr>
+          <a:xfrm>
+            <a:off x="6428232" y="3694176"/>
+            <a:ext cx="548640" cy="548640"/>
+          </a:xfrm>
+          <a:prstGeom prst="rect">
+            <a:avLst/>
+          </a:prstGeom>
+          <a:noFill/>
+          <a:ln/>
+        </p:spPr>
+        <p:txBody>
+          <a:bodyPr wrap="square" lIns="0" tIns="0" rIns="0" bIns="0" rtlCol="0" anchor="t"/>
+          <a:lstStyle/>
+          <a:p>
+            <a:pPr marL="0" marR="0" lvl="0" indent="0" algn="l" defTabSz="914400" rtl="0" eaLnBrk="1" fontAlgn="auto" latinLnBrk="0" hangingPunct="1">
+              <a:lnSpc>
+                <a:spcPct val="100000"/>
+              </a:lnSpc>
+              <a:spcBef>
+                <a:spcPts val="0"/>
+              </a:spcBef>
+              <a:spcAft>
+                <a:spcPts val="0"/>
+              </a:spcAft>
+              <a:buClrTx/>
+              <a:buSzTx/>
+              <a:buFontTx/>
+              <a:buNone/>
+              <a:tabLst/>
+              <a:defRPr/>
+            </a:pPr>
+            <a:r>
+              <a:rPr kumimoji="0" lang="en-US" sz="2600" b="1" i="0" u="none" strike="noStrike" kern="1200" cap="none" spc="0" normalizeH="0" baseline="0" noProof="0" dirty="0">
+                <a:ln>
+                  <a:noFill/>
+                </a:ln>
+                <a:solidFill>
+                  <a:srgbClr val="C0561B"/>
+                </a:solidFill>
+                <a:effectLst/>
+                <a:uLnTx/>
+                <a:uFillTx/>
+                <a:latin typeface="Georgia" pitchFamily="34" charset="0"/>
+                <a:ea typeface="Georgia" pitchFamily="34" charset="-122"/>
+                <a:cs typeface="Georgia" pitchFamily="34" charset="-120"/>
+              </a:rPr>
+              <a:t>4</a:t>
+            </a:r>
+            <a:endParaRPr kumimoji="0" lang="en-US" sz="2600" b="0" i="0" u="none" strike="noStrike" kern="1200" cap="none" spc="0" normalizeH="0" baseline="0" noProof="0" dirty="0">
+              <a:ln>
+                <a:noFill/>
+              </a:ln>
+              <a:solidFill>
+                <a:prstClr val="black"/>
+              </a:solidFill>
+              <a:effectLst/>
+              <a:uLnTx/>
+              <a:uFillTx/>
+              <a:latin typeface="Calibri" panose="020F0502020204030204"/>
+              <a:ea typeface="+mn-ea"/>
+              <a:cs typeface="+mn-cs"/>
+            </a:endParaRPr>
+          </a:p>
+        </p:txBody>
+      </p:sp>
+      <p:sp>
+        <p:nvSpPr>
+          <p:cNvPr id="25" name="Text 23"/>
+          <p:cNvSpPr/>
+          <p:nvPr/>
+        </p:nvSpPr>
+        <p:spPr>
+          <a:xfrm>
+            <a:off x="6995160" y="3730752"/>
+            <a:ext cx="4434840" cy="457200"/>
+          </a:xfrm>
+          <a:prstGeom prst="rect">
+            <a:avLst/>
+          </a:prstGeom>
+          <a:noFill/>
+          <a:ln/>
+        </p:spPr>
+        <p:txBody>
+          <a:bodyPr wrap="square" lIns="0" tIns="0" rIns="0" bIns="0" rtlCol="0" anchor="t"/>
+          <a:lstStyle/>
+          <a:p>
+            <a:pPr marL="0" marR="0" lvl="0" indent="0" algn="l" defTabSz="914400" rtl="0" eaLnBrk="1" fontAlgn="auto" latinLnBrk="0" hangingPunct="1">
+              <a:lnSpc>
+                <a:spcPct val="100000"/>
+              </a:lnSpc>
+              <a:spcBef>
+                <a:spcPts val="0"/>
+              </a:spcBef>
+              <a:spcAft>
+                <a:spcPts val="0"/>
+              </a:spcAft>
+              <a:buClrTx/>
+              <a:buSzTx/>
+              <a:buFontTx/>
+              <a:buNone/>
+              <a:tabLst/>
+              <a:defRPr/>
+            </a:pPr>
+            <a:r>
+              <a:rPr kumimoji="0" lang="en-US" sz="1450" b="1" i="0" u="none" strike="noStrike" kern="1200" cap="none" spc="0" normalizeH="0" baseline="0" noProof="0" dirty="0">
+                <a:ln>
+                  <a:noFill/>
+                </a:ln>
+                <a:solidFill>
+                  <a:srgbClr val="1B2B31"/>
+                </a:solidFill>
+                <a:effectLst/>
+                <a:uLnTx/>
+                <a:uFillTx/>
+                <a:latin typeface="Calibri" panose="020F0502020204030204"/>
+                <a:ea typeface="+mn-ea"/>
+                <a:cs typeface="+mn-cs"/>
+              </a:rPr>
+              <a:t>Stable across marker sets &amp; thresholds</a:t>
+            </a:r>
+            <a:endParaRPr kumimoji="0" lang="en-US" sz="1450" b="0" i="0" u="none" strike="noStrike" kern="1200" cap="none" spc="0" normalizeH="0" baseline="0" noProof="0" dirty="0">
+              <a:ln>
+                <a:noFill/>
+              </a:ln>
+              <a:solidFill>
+                <a:prstClr val="black"/>
+              </a:solidFill>
+              <a:effectLst/>
+              <a:uLnTx/>
+              <a:uFillTx/>
+              <a:latin typeface="Calibri" panose="020F0502020204030204"/>
+              <a:ea typeface="+mn-ea"/>
+              <a:cs typeface="+mn-cs"/>
+            </a:endParaRPr>
+          </a:p>
+        </p:txBody>
+      </p:sp>
+      <p:sp>
+        <p:nvSpPr>
+          <p:cNvPr id="26" name="Text 24"/>
+          <p:cNvSpPr/>
+          <p:nvPr/>
+        </p:nvSpPr>
+        <p:spPr>
+          <a:xfrm>
+            <a:off x="6995160" y="4151376"/>
+            <a:ext cx="4434840" cy="777240"/>
+          </a:xfrm>
+          <a:prstGeom prst="rect">
+            <a:avLst/>
+          </a:prstGeom>
+          <a:noFill/>
+          <a:ln/>
+        </p:spPr>
+        <p:txBody>
+          <a:bodyPr wrap="square" lIns="0" tIns="0" rIns="0" bIns="0" rtlCol="0" anchor="t"/>
+          <a:lstStyle/>
+          <a:p>
+            <a:pPr marL="0" marR="0" lvl="0" indent="0" algn="l" defTabSz="914400" rtl="0" eaLnBrk="1" fontAlgn="auto" latinLnBrk="0" hangingPunct="1">
+              <a:lnSpc>
+                <a:spcPct val="100000"/>
+              </a:lnSpc>
+              <a:spcBef>
+                <a:spcPts val="0"/>
+              </a:spcBef>
+              <a:spcAft>
+                <a:spcPts val="0"/>
+              </a:spcAft>
+              <a:buClrTx/>
+              <a:buSzTx/>
+              <a:buFontTx/>
+              <a:buNone/>
+              <a:tabLst/>
+              <a:defRPr/>
+            </a:pPr>
+            <a:r>
+              <a:rPr kumimoji="0" lang="en-US" sz="1150" b="0" i="0" u="none" strike="noStrike" kern="1200" cap="none" spc="0" normalizeH="0" baseline="0" noProof="0" dirty="0">
+                <a:ln>
+                  <a:noFill/>
+                </a:ln>
+                <a:solidFill>
+                  <a:srgbClr val="334155"/>
+                </a:solidFill>
+                <a:effectLst/>
+                <a:uLnTx/>
+                <a:uFillTx/>
+                <a:latin typeface="Calibri" panose="020F0502020204030204"/>
+                <a:ea typeface="+mn-ea"/>
+                <a:cs typeface="+mn-cs"/>
+              </a:rPr>
+              <a:t>The flat result holds on 6 marker sets (2–1,637 genes, incl. Paper 2’s own) and the full ≥1 / ≥2 / ≥3-UMI grid — no setting-dependent signal hiding in the variance.</a:t>
+            </a:r>
+            <a:endParaRPr kumimoji="0" lang="en-US" sz="1150" b="0" i="0" u="none" strike="noStrike" kern="1200" cap="none" spc="0" normalizeH="0" baseline="0" noProof="0" dirty="0">
+              <a:ln>
+                <a:noFill/>
+              </a:ln>
+              <a:solidFill>
+                <a:prstClr val="black"/>
+              </a:solidFill>
+              <a:effectLst/>
+              <a:uLnTx/>
+              <a:uFillTx/>
+              <a:latin typeface="Calibri" panose="020F0502020204030204"/>
+              <a:ea typeface="+mn-ea"/>
+              <a:cs typeface="+mn-cs"/>
+            </a:endParaRPr>
+          </a:p>
+        </p:txBody>
+      </p:sp>
+      <p:sp>
+        <p:nvSpPr>
+          <p:cNvPr id="27" name="Shape 25"/>
+          <p:cNvSpPr/>
+          <p:nvPr/>
+        </p:nvSpPr>
+        <p:spPr>
+          <a:xfrm>
+            <a:off x="640080" y="5257800"/>
+            <a:ext cx="10927080" cy="658368"/>
+          </a:xfrm>
+          <a:prstGeom prst="roundRect">
+            <a:avLst>
+              <a:gd name="adj" fmla="val 8333"/>
+            </a:avLst>
+          </a:prstGeom>
+          <a:solidFill>
+            <a:srgbClr val="E7F0EE"/>
+          </a:solidFill>
+          <a:ln w="12700">
+            <a:solidFill>
+              <a:srgbClr val="1B6E78"/>
+            </a:solidFill>
+            <a:prstDash val="solid"/>
+          </a:ln>
+        </p:spPr>
+      </p:sp>
+      <p:sp>
+        <p:nvSpPr>
+          <p:cNvPr id="28" name="Text 26"/>
+          <p:cNvSpPr/>
+          <p:nvPr/>
+        </p:nvSpPr>
+        <p:spPr>
+          <a:xfrm>
+            <a:off x="868680" y="5257800"/>
+            <a:ext cx="10515600" cy="658368"/>
+          </a:xfrm>
+          <a:prstGeom prst="rect">
+            <a:avLst/>
+          </a:prstGeom>
+          <a:noFill/>
+          <a:ln/>
+        </p:spPr>
+        <p:txBody>
+          <a:bodyPr wrap="square" rtlCol="0" anchor="ctr"/>
+          <a:lstStyle/>
+          <a:p>
+            <a:pPr marL="0" marR="0" lvl="0" indent="0" algn="l" defTabSz="914400" rtl="0" eaLnBrk="1" fontAlgn="auto" latinLnBrk="0" hangingPunct="1">
+              <a:lnSpc>
+                <a:spcPct val="100000"/>
+              </a:lnSpc>
+              <a:spcBef>
+                <a:spcPts val="0"/>
+              </a:spcBef>
+              <a:spcAft>
+                <a:spcPts val="0"/>
+              </a:spcAft>
+              <a:buClrTx/>
+              <a:buSzTx/>
+              <a:buFontTx/>
+              <a:buNone/>
+              <a:tabLst/>
+              <a:defRPr/>
+            </a:pPr>
+            <a:r>
+              <a:rPr kumimoji="0" lang="en-US" sz="1350" b="1" i="0" u="none" strike="noStrike" kern="1200" cap="none" spc="0" normalizeH="0" baseline="0" noProof="0" dirty="0">
+                <a:ln>
+                  <a:noFill/>
+                </a:ln>
+                <a:solidFill>
+                  <a:srgbClr val="123F47"/>
+                </a:solidFill>
+                <a:effectLst/>
+                <a:uLnTx/>
+                <a:uFillTx/>
+                <a:latin typeface="Calibri" panose="020F0502020204030204"/>
+                <a:ea typeface="+mn-ea"/>
+                <a:cs typeface="+mn-cs"/>
+              </a:rPr>
+              <a:t>Bottom line:  </a:t>
+            </a:r>
+            <a:r>
+              <a:rPr kumimoji="0" lang="en-US" sz="1350" b="0" i="0" u="none" strike="noStrike" kern="1200" cap="none" spc="0" normalizeH="0" baseline="0" noProof="0" dirty="0">
+                <a:ln>
+                  <a:noFill/>
+                </a:ln>
+                <a:solidFill>
+                  <a:srgbClr val="1B2B31"/>
+                </a:solidFill>
+                <a:effectLst/>
+                <a:uLnTx/>
+                <a:uFillTx/>
+                <a:latin typeface="Calibri" panose="020F0502020204030204"/>
+                <a:ea typeface="+mn-ea"/>
+                <a:cs typeface="+mn-cs"/>
+              </a:rPr>
+              <a:t>large person-to-person variance ≠ an undetectable signal. With donor-level inference and an equivalence bound, a large progressive de-zonation is </a:t>
+            </a:r>
+            <a:r>
+              <a:rPr kumimoji="0" lang="en-US" sz="1350" b="1" i="0" u="none" strike="noStrike" kern="1200" cap="none" spc="0" normalizeH="0" baseline="0" noProof="0" dirty="0">
+                <a:ln>
+                  <a:noFill/>
+                </a:ln>
+                <a:solidFill>
+                  <a:srgbClr val="123F47"/>
+                </a:solidFill>
+                <a:effectLst/>
+                <a:uLnTx/>
+                <a:uFillTx/>
+                <a:latin typeface="Calibri" panose="020F0502020204030204"/>
+                <a:ea typeface="+mn-ea"/>
+                <a:cs typeface="+mn-cs"/>
+              </a:rPr>
+              <a:t>excluded</a:t>
+            </a:r>
+            <a:r>
+              <a:rPr kumimoji="0" lang="en-US" sz="1350" b="0" i="0" u="none" strike="noStrike" kern="1200" cap="none" spc="0" normalizeH="0" baseline="0" noProof="0" dirty="0">
+                <a:ln>
+                  <a:noFill/>
+                </a:ln>
+                <a:solidFill>
+                  <a:srgbClr val="1B2B31"/>
+                </a:solidFill>
+                <a:effectLst/>
+                <a:uLnTx/>
+                <a:uFillTx/>
+                <a:latin typeface="Calibri" panose="020F0502020204030204"/>
+                <a:ea typeface="+mn-ea"/>
+                <a:cs typeface="+mn-cs"/>
+              </a:rPr>
+              <a:t> (a subtle ≤10-pp drift is not).</a:t>
+            </a:r>
+            <a:endParaRPr kumimoji="0" lang="en-US" sz="1350" b="0" i="0" u="none" strike="noStrike" kern="1200" cap="none" spc="0" normalizeH="0" baseline="0" noProof="0" dirty="0">
+              <a:ln>
+                <a:noFill/>
+              </a:ln>
+              <a:solidFill>
+                <a:prstClr val="black"/>
+              </a:solidFill>
+              <a:effectLst/>
+              <a:uLnTx/>
+              <a:uFillTx/>
+              <a:latin typeface="Calibri" panose="020F0502020204030204"/>
+              <a:ea typeface="+mn-ea"/>
+              <a:cs typeface="+mn-cs"/>
+            </a:endParaRPr>
+          </a:p>
+        </p:txBody>
+      </p:sp>
+      <p:sp>
+        <p:nvSpPr>
+          <p:cNvPr id="29" name="Text 27"/>
+          <p:cNvSpPr/>
+          <p:nvPr/>
+        </p:nvSpPr>
+        <p:spPr>
+          <a:xfrm>
+            <a:off x="457200" y="6510528"/>
+            <a:ext cx="9601200" cy="274320"/>
+          </a:xfrm>
+          <a:prstGeom prst="rect">
+            <a:avLst/>
+          </a:prstGeom>
+          <a:noFill/>
+          <a:ln/>
+        </p:spPr>
+        <p:txBody>
+          <a:bodyPr wrap="square" lIns="0" tIns="0" rIns="0" bIns="0" rtlCol="0" anchor="ctr"/>
+          <a:lstStyle/>
+          <a:p>
+            <a:pPr marL="0" marR="0" lvl="0" indent="0" algn="l" defTabSz="914400" rtl="0" eaLnBrk="1" fontAlgn="auto" latinLnBrk="0" hangingPunct="1">
+              <a:lnSpc>
+                <a:spcPct val="100000"/>
+              </a:lnSpc>
+              <a:spcBef>
+                <a:spcPts val="0"/>
+              </a:spcBef>
+              <a:spcAft>
+                <a:spcPts val="0"/>
+              </a:spcAft>
+              <a:buClrTx/>
+              <a:buSzTx/>
+              <a:buFontTx/>
+              <a:buNone/>
+              <a:tabLst/>
+              <a:defRPr/>
+            </a:pPr>
+            <a:r>
+              <a:rPr kumimoji="0" lang="en-US" sz="1050" b="0" i="0" u="none" strike="noStrike" kern="1200" cap="none" spc="0" normalizeH="0" baseline="0" noProof="0" dirty="0">
+                <a:ln>
+                  <a:noFill/>
+                </a:ln>
+                <a:solidFill>
+                  <a:srgbClr val="5C6E73"/>
+                </a:solidFill>
+                <a:effectLst/>
+                <a:uLnTx/>
+                <a:uFillTx/>
+                <a:latin typeface="Calibri" panose="020F0502020204030204"/>
+                <a:ea typeface="+mn-ea"/>
+                <a:cs typeface="+mn-cs"/>
+              </a:rPr>
+              <a:t>Computational Genomics 76553  ·  HUJI  ·  MASLD snRNA-seq hackathon</a:t>
+            </a:r>
+            <a:endParaRPr kumimoji="0" lang="en-US" sz="1050" b="0" i="0" u="none" strike="noStrike" kern="1200" cap="none" spc="0" normalizeH="0" baseline="0" noProof="0" dirty="0">
+              <a:ln>
+                <a:noFill/>
+              </a:ln>
+              <a:solidFill>
+                <a:prstClr val="black"/>
+              </a:solidFill>
+              <a:effectLst/>
+              <a:uLnTx/>
+              <a:uFillTx/>
+              <a:latin typeface="Calibri" panose="020F0502020204030204"/>
+              <a:ea typeface="+mn-ea"/>
+              <a:cs typeface="+mn-cs"/>
+            </a:endParaRPr>
+          </a:p>
+        </p:txBody>
+      </p:sp>
+    </p:spTree>
+  </p:cSld>
+  <p:clrMapOvr>
+    <a:masterClrMapping/>
+  </p:clrMapOvr>
+</p:sld>
+</file>
+
+<file path=ppt/slides/slide21.xml><?xml version="1.0" encoding="utf-8"?>
+<p:sld xmlns:a="http://schemas.openxmlformats.org/drawingml/2006/main" xmlns:r="http://schemas.openxmlformats.org/officeDocument/2006/relationships" xmlns:p="http://schemas.openxmlformats.org/presentationml/2006/main">
   <p:cSld name="Slide 18">
     <p:bg>
       <p:bgPr>
@@ -11864,7 +12210,7 @@
                   <a:srgbClr val="C0561B"/>
                 </a:solidFill>
               </a:rPr>
-              <a:t>BACKUP  ·  SECONDARY ENDPOINTS</a:t>
+              <a:t>QA  ·  SECONDARY ENDPOINTS</a:t>
             </a:r>
             <a:endParaRPr lang="en-US" sz="1300" dirty="0"/>
           </a:p>
@@ -12059,7 +12405,7 @@
 </p:sld>
 </file>
 
-<file path=ppt/slides/slide21.xml><?xml version="1.0" encoding="utf-8"?>
+<file path=ppt/slides/slide22.xml><?xml version="1.0" encoding="utf-8"?>
 <p:sld xmlns:a="http://schemas.openxmlformats.org/drawingml/2006/main" xmlns:r="http://schemas.openxmlformats.org/officeDocument/2006/relationships" xmlns:p="http://schemas.openxmlformats.org/presentationml/2006/main">
   <p:cSld name="Slide 19">
     <p:bg>
@@ -12141,7 +12487,7 @@
                   <a:srgbClr val="C0561B"/>
                 </a:solidFill>
               </a:rPr>
-              <a:t>BACKUP  ·  LOBE</a:t>
+              <a:t>QA  ·  LOBE</a:t>
             </a:r>
             <a:endParaRPr lang="en-US" sz="1300" dirty="0"/>
           </a:p>
@@ -12305,7 +12651,7 @@
 </p:sld>
 </file>
 
-<file path=ppt/slides/slide22.xml><?xml version="1.0" encoding="utf-8"?>
+<file path=ppt/slides/slide23.xml><?xml version="1.0" encoding="utf-8"?>
 <p:sld xmlns:a="http://schemas.openxmlformats.org/drawingml/2006/main" xmlns:r="http://schemas.openxmlformats.org/officeDocument/2006/relationships" xmlns:p="http://schemas.openxmlformats.org/presentationml/2006/main">
   <p:cSld name="Slide 20">
     <p:bg>
@@ -12387,7 +12733,7 @@
                   <a:srgbClr val="C0561B"/>
                 </a:solidFill>
               </a:rPr>
-              <a:t>BACKUP  ·  END-STAGE</a:t>
+              <a:t>QA  ·  END-STAGE</a:t>
             </a:r>
             <a:endParaRPr lang="en-US" sz="1300" dirty="0"/>
           </a:p>
@@ -12551,7 +12897,7 @@
 </p:sld>
 </file>
 
-<file path=ppt/slides/slide23.xml><?xml version="1.0" encoding="utf-8"?>
+<file path=ppt/slides/slide24.xml><?xml version="1.0" encoding="utf-8"?>
 <p:sld xmlns:a="http://schemas.openxmlformats.org/drawingml/2006/main" xmlns:r="http://schemas.openxmlformats.org/officeDocument/2006/relationships" xmlns:p="http://schemas.openxmlformats.org/presentationml/2006/main">
   <p:cSld name="Slide 21">
     <p:bg>
@@ -12633,7 +12979,7 @@
                   <a:srgbClr val="C0561B"/>
                 </a:solidFill>
               </a:rPr>
-              <a:t>BACKUP  ·  ROBUSTNESS</a:t>
+              <a:t>QA  ·  ROBUSTNESS</a:t>
             </a:r>
             <a:endParaRPr lang="en-US" sz="1300" dirty="0"/>
           </a:p>
@@ -12827,7 +13173,7 @@
 </p:sld>
 </file>
 
-<file path=ppt/slides/slide24.xml><?xml version="1.0" encoding="utf-8"?>
+<file path=ppt/slides/slide25.xml><?xml version="1.0" encoding="utf-8"?>
 <p:sld xmlns:a="http://schemas.openxmlformats.org/drawingml/2006/main" xmlns:r="http://schemas.openxmlformats.org/officeDocument/2006/relationships" xmlns:p="http://schemas.openxmlformats.org/presentationml/2006/main">
   <p:cSld name="Slide 22">
     <p:bg>
@@ -12909,7 +13255,7 @@
                   <a:srgbClr val="C0561B"/>
                 </a:solidFill>
               </a:rPr>
-              <a:t>BACKUP  ·  AUDIT DETAIL</a:t>
+              <a:t>QA  ·  AUDIT DETAIL</a:t>
             </a:r>
             <a:endParaRPr lang="en-US" sz="1300" dirty="0"/>
           </a:p>
@@ -15101,7 +15447,7 @@
 </p:sld>
 </file>
 
-<file path=ppt/slides/slide25.xml><?xml version="1.0" encoding="utf-8"?>
+<file path=ppt/slides/slide26.xml><?xml version="1.0" encoding="utf-8"?>
 <p:sld xmlns:a="http://schemas.openxmlformats.org/drawingml/2006/main" xmlns:r="http://schemas.openxmlformats.org/officeDocument/2006/relationships" xmlns:p="http://schemas.openxmlformats.org/presentationml/2006/main">
   <p:cSld name="Slide 23">
     <p:bg>
@@ -15183,7 +15529,7 @@
                   <a:srgbClr val="C0561B"/>
                 </a:solidFill>
               </a:rPr>
-              <a:t>BACKUP  ·  METHODS</a:t>
+              <a:t>QA  ·  METHODS</a:t>
             </a:r>
             <a:endParaRPr lang="en-US" sz="1300" dirty="0"/>
           </a:p>
@@ -15330,7 +15676,7 @@
 </p:sld>
 </file>
 
-<file path=ppt/slides/slide26.xml><?xml version="1.0" encoding="utf-8"?>
+<file path=ppt/slides/slide27.xml><?xml version="1.0" encoding="utf-8"?>
 <p:sld xmlns:a="http://schemas.openxmlformats.org/drawingml/2006/main" xmlns:r="http://schemas.openxmlformats.org/officeDocument/2006/relationships" xmlns:p="http://schemas.openxmlformats.org/presentationml/2006/main">
   <p:cSld name="Slide 24">
     <p:bg>
@@ -15412,7 +15758,7 @@
                   <a:srgbClr val="C0561B"/>
                 </a:solidFill>
               </a:rPr>
-              <a:t>BACKUP  ·  AMBIENT</a:t>
+              <a:t>QA  ·  AMBIENT</a:t>
             </a:r>
             <a:endParaRPr lang="en-US" sz="1300" dirty="0"/>
           </a:p>
@@ -15559,7 +15905,7 @@
 </p:sld>
 </file>
 
-<file path=ppt/slides/slide27.xml><?xml version="1.0" encoding="utf-8"?>
+<file path=ppt/slides/slide28.xml><?xml version="1.0" encoding="utf-8"?>
 <p:sld xmlns:a="http://schemas.openxmlformats.org/drawingml/2006/main" xmlns:r="http://schemas.openxmlformats.org/officeDocument/2006/relationships" xmlns:p="http://schemas.openxmlformats.org/presentationml/2006/main">
   <p:cSld name="Slide 25">
     <p:bg>
@@ -15641,7 +15987,7 @@
                   <a:srgbClr val="C0561B"/>
                 </a:solidFill>
               </a:rPr>
-              <a:t>BACKUP  ·  GENE-SET RESULT</a:t>
+              <a:t>QA  ·  GENE-SET RESULT</a:t>
             </a:r>
             <a:endParaRPr lang="en-US" sz="1300" dirty="0"/>
           </a:p>
@@ -19225,7 +19571,7 @@
 </p:sld>
 </file>
 
-<file path=ppt/slides/slide28.xml><?xml version="1.0" encoding="utf-8"?>
+<file path=ppt/slides/slide29.xml><?xml version="1.0" encoding="utf-8"?>
 <p:sld xmlns:a="http://schemas.openxmlformats.org/drawingml/2006/main" xmlns:r="http://schemas.openxmlformats.org/officeDocument/2006/relationships" xmlns:p="http://schemas.openxmlformats.org/presentationml/2006/main">
   <p:cSld name="Slide 26">
     <p:bg>
@@ -19307,7 +19653,7 @@
                   <a:srgbClr val="C0561B"/>
                 </a:solidFill>
               </a:rPr>
-              <a:t>BACKUP  ·  METHODS GLOSSARY</a:t>
+              <a:t>QA  ·  METHODS GLOSSARY</a:t>
             </a:r>
             <a:endParaRPr lang="en-US" sz="1300" dirty="0"/>
           </a:p>
@@ -19563,7 +19909,169 @@
 </p:sld>
 </file>
 
-<file path=ppt/slides/slide29.xml><?xml version="1.0" encoding="utf-8"?>
+<file path=ppt/slides/slide3.xml><?xml version="1.0" encoding="utf-8"?>
+<p:sld xmlns:a="http://schemas.openxmlformats.org/drawingml/2006/main" xmlns:r="http://schemas.openxmlformats.org/officeDocument/2006/relationships" xmlns:p="http://schemas.openxmlformats.org/presentationml/2006/main">
+  <p:cSld name="Slide 3">
+    <p:bg>
+      <p:bgPr>
+        <a:solidFill>
+          <a:srgbClr val="16242B"/>
+        </a:solidFill>
+        <a:effectLst/>
+      </p:bgPr>
+    </p:bg>
+    <p:spTree>
+      <p:nvGrpSpPr>
+        <p:cNvPr id="1" name=""/>
+        <p:cNvGrpSpPr/>
+        <p:nvPr/>
+      </p:nvGrpSpPr>
+      <p:grpSpPr>
+        <a:xfrm>
+          <a:off x="0" y="0"/>
+          <a:ext cx="0" cy="0"/>
+          <a:chOff x="0" y="0"/>
+          <a:chExt cx="0" cy="0"/>
+        </a:xfrm>
+      </p:grpSpPr>
+      <p:sp>
+        <p:nvSpPr>
+          <p:cNvPr id="2" name="Shape 0"/>
+          <p:cNvSpPr/>
+          <p:nvPr/>
+        </p:nvSpPr>
+        <p:spPr>
+          <a:xfrm>
+            <a:off x="0" y="0"/>
+            <a:ext cx="256032" cy="6858000"/>
+          </a:xfrm>
+          <a:prstGeom prst="rect">
+            <a:avLst/>
+          </a:prstGeom>
+          <a:solidFill>
+            <a:srgbClr val="1B6E78"/>
+          </a:solidFill>
+          <a:ln/>
+        </p:spPr>
+        <p:txBody>
+          <a:bodyPr/>
+          <a:lstStyle/>
+          <a:p>
+            <a:endParaRPr lang="en-US"/>
+          </a:p>
+        </p:txBody>
+      </p:sp>
+      <p:sp>
+        <p:nvSpPr>
+          <p:cNvPr id="3" name="Shape 1"/>
+          <p:cNvSpPr/>
+          <p:nvPr/>
+        </p:nvSpPr>
+        <p:spPr>
+          <a:xfrm>
+            <a:off x="256032" y="0"/>
+            <a:ext cx="109728" cy="6858000"/>
+          </a:xfrm>
+          <a:prstGeom prst="rect">
+            <a:avLst/>
+          </a:prstGeom>
+          <a:solidFill>
+            <a:srgbClr val="C0561B"/>
+          </a:solidFill>
+          <a:ln/>
+        </p:spPr>
+        <p:txBody>
+          <a:bodyPr/>
+          <a:lstStyle/>
+          <a:p>
+            <a:endParaRPr lang="en-US"/>
+          </a:p>
+        </p:txBody>
+      </p:sp>
+      <p:sp>
+        <p:nvSpPr>
+          <p:cNvPr id="4" name="Text 2"/>
+          <p:cNvSpPr/>
+          <p:nvPr/>
+        </p:nvSpPr>
+        <p:spPr>
+          <a:xfrm>
+            <a:off x="868680" y="2651760"/>
+            <a:ext cx="10515600" cy="1005840"/>
+          </a:xfrm>
+          <a:prstGeom prst="rect">
+            <a:avLst/>
+          </a:prstGeom>
+          <a:noFill/>
+          <a:ln/>
+        </p:spPr>
+        <p:txBody>
+          <a:bodyPr wrap="square" rtlCol="0" anchor="ctr"/>
+          <a:lstStyle/>
+          <a:p>
+            <a:pPr marL="0" indent="0" algn="l">
+              <a:buNone/>
+            </a:pPr>
+            <a:r>
+              <a:rPr lang="en-US" sz="4400" b="1" dirty="0">
+                <a:solidFill>
+                  <a:srgbClr val="FFFFFF"/>
+                </a:solidFill>
+                <a:latin typeface="Georgia" pitchFamily="34" charset="0"/>
+                <a:ea typeface="Georgia" pitchFamily="34" charset="-122"/>
+                <a:cs typeface="Georgia" pitchFamily="34" charset="-120"/>
+              </a:rPr>
+              <a:t>The catch</a:t>
+            </a:r>
+            <a:endParaRPr lang="en-US" sz="4400" dirty="0"/>
+          </a:p>
+        </p:txBody>
+      </p:sp>
+      <p:sp>
+        <p:nvSpPr>
+          <p:cNvPr id="5" name="Text 3"/>
+          <p:cNvSpPr/>
+          <p:nvPr/>
+        </p:nvSpPr>
+        <p:spPr>
+          <a:xfrm>
+            <a:off x="896112" y="3794760"/>
+            <a:ext cx="10515600" cy="457200"/>
+          </a:xfrm>
+          <a:prstGeom prst="rect">
+            <a:avLst/>
+          </a:prstGeom>
+          <a:noFill/>
+          <a:ln/>
+        </p:spPr>
+        <p:txBody>
+          <a:bodyPr wrap="square" rtlCol="0" anchor="ctr"/>
+          <a:lstStyle/>
+          <a:p>
+            <a:pPr marL="0" indent="0" algn="l">
+              <a:buNone/>
+            </a:pPr>
+            <a:r>
+              <a:rPr lang="en-US" sz="1700" i="1" dirty="0">
+                <a:solidFill>
+                  <a:srgbClr val="9FC0C4"/>
+                </a:solidFill>
+              </a:rPr>
+              <a:t>our first approach is misleading — and the tissue itself is confounded</a:t>
+            </a:r>
+            <a:endParaRPr lang="en-US" sz="1700" dirty="0"/>
+          </a:p>
+        </p:txBody>
+      </p:sp>
+    </p:spTree>
+  </p:cSld>
+  <p:clrMapOvr>
+    <a:masterClrMapping/>
+  </p:clrMapOvr>
+</p:sld>
+</file>
+
+<file path=ppt/slides/slide30.xml><?xml version="1.0" encoding="utf-8"?>
 <p:sld xmlns:a="http://schemas.openxmlformats.org/drawingml/2006/main" xmlns:r="http://schemas.openxmlformats.org/officeDocument/2006/relationships" xmlns:p="http://schemas.openxmlformats.org/presentationml/2006/main">
   <p:cSld name="Slide 27">
     <p:bg>
@@ -19645,7 +20153,7 @@
                   <a:srgbClr val="C0561B"/>
                 </a:solidFill>
               </a:rPr>
-              <a:t>BACKUP  ·  SCENARIO COVERAGE</a:t>
+              <a:t>QA  ·  SCENARIO COVERAGE</a:t>
             </a:r>
             <a:endParaRPr lang="en-US" sz="1300" dirty="0"/>
           </a:p>
@@ -22049,169 +22557,7 @@
 </p:sld>
 </file>
 
-<file path=ppt/slides/slide3.xml><?xml version="1.0" encoding="utf-8"?>
-<p:sld xmlns:a="http://schemas.openxmlformats.org/drawingml/2006/main" xmlns:r="http://schemas.openxmlformats.org/officeDocument/2006/relationships" xmlns:p="http://schemas.openxmlformats.org/presentationml/2006/main">
-  <p:cSld name="Slide 3">
-    <p:bg>
-      <p:bgPr>
-        <a:solidFill>
-          <a:srgbClr val="16242B"/>
-        </a:solidFill>
-        <a:effectLst/>
-      </p:bgPr>
-    </p:bg>
-    <p:spTree>
-      <p:nvGrpSpPr>
-        <p:cNvPr id="1" name=""/>
-        <p:cNvGrpSpPr/>
-        <p:nvPr/>
-      </p:nvGrpSpPr>
-      <p:grpSpPr>
-        <a:xfrm>
-          <a:off x="0" y="0"/>
-          <a:ext cx="0" cy="0"/>
-          <a:chOff x="0" y="0"/>
-          <a:chExt cx="0" cy="0"/>
-        </a:xfrm>
-      </p:grpSpPr>
-      <p:sp>
-        <p:nvSpPr>
-          <p:cNvPr id="2" name="Shape 0"/>
-          <p:cNvSpPr/>
-          <p:nvPr/>
-        </p:nvSpPr>
-        <p:spPr>
-          <a:xfrm>
-            <a:off x="0" y="0"/>
-            <a:ext cx="256032" cy="6858000"/>
-          </a:xfrm>
-          <a:prstGeom prst="rect">
-            <a:avLst/>
-          </a:prstGeom>
-          <a:solidFill>
-            <a:srgbClr val="1B6E78"/>
-          </a:solidFill>
-          <a:ln/>
-        </p:spPr>
-        <p:txBody>
-          <a:bodyPr/>
-          <a:lstStyle/>
-          <a:p>
-            <a:endParaRPr lang="en-US"/>
-          </a:p>
-        </p:txBody>
-      </p:sp>
-      <p:sp>
-        <p:nvSpPr>
-          <p:cNvPr id="3" name="Shape 1"/>
-          <p:cNvSpPr/>
-          <p:nvPr/>
-        </p:nvSpPr>
-        <p:spPr>
-          <a:xfrm>
-            <a:off x="256032" y="0"/>
-            <a:ext cx="109728" cy="6858000"/>
-          </a:xfrm>
-          <a:prstGeom prst="rect">
-            <a:avLst/>
-          </a:prstGeom>
-          <a:solidFill>
-            <a:srgbClr val="C0561B"/>
-          </a:solidFill>
-          <a:ln/>
-        </p:spPr>
-        <p:txBody>
-          <a:bodyPr/>
-          <a:lstStyle/>
-          <a:p>
-            <a:endParaRPr lang="en-US"/>
-          </a:p>
-        </p:txBody>
-      </p:sp>
-      <p:sp>
-        <p:nvSpPr>
-          <p:cNvPr id="4" name="Text 2"/>
-          <p:cNvSpPr/>
-          <p:nvPr/>
-        </p:nvSpPr>
-        <p:spPr>
-          <a:xfrm>
-            <a:off x="868680" y="2651760"/>
-            <a:ext cx="10515600" cy="1005840"/>
-          </a:xfrm>
-          <a:prstGeom prst="rect">
-            <a:avLst/>
-          </a:prstGeom>
-          <a:noFill/>
-          <a:ln/>
-        </p:spPr>
-        <p:txBody>
-          <a:bodyPr wrap="square" rtlCol="0" anchor="ctr"/>
-          <a:lstStyle/>
-          <a:p>
-            <a:pPr marL="0" indent="0" algn="l">
-              <a:buNone/>
-            </a:pPr>
-            <a:r>
-              <a:rPr lang="en-US" sz="4400" b="1" dirty="0">
-                <a:solidFill>
-                  <a:srgbClr val="FFFFFF"/>
-                </a:solidFill>
-                <a:latin typeface="Georgia" pitchFamily="34" charset="0"/>
-                <a:ea typeface="Georgia" pitchFamily="34" charset="-122"/>
-                <a:cs typeface="Georgia" pitchFamily="34" charset="-120"/>
-              </a:rPr>
-              <a:t>The catch</a:t>
-            </a:r>
-            <a:endParaRPr lang="en-US" sz="4400" dirty="0"/>
-          </a:p>
-        </p:txBody>
-      </p:sp>
-      <p:sp>
-        <p:nvSpPr>
-          <p:cNvPr id="5" name="Text 3"/>
-          <p:cNvSpPr/>
-          <p:nvPr/>
-        </p:nvSpPr>
-        <p:spPr>
-          <a:xfrm>
-            <a:off x="896112" y="3794760"/>
-            <a:ext cx="10515600" cy="457200"/>
-          </a:xfrm>
-          <a:prstGeom prst="rect">
-            <a:avLst/>
-          </a:prstGeom>
-          <a:noFill/>
-          <a:ln/>
-        </p:spPr>
-        <p:txBody>
-          <a:bodyPr wrap="square" rtlCol="0" anchor="ctr"/>
-          <a:lstStyle/>
-          <a:p>
-            <a:pPr marL="0" indent="0" algn="l">
-              <a:buNone/>
-            </a:pPr>
-            <a:r>
-              <a:rPr lang="en-US" sz="1700" i="1" dirty="0">
-                <a:solidFill>
-                  <a:srgbClr val="9FC0C4"/>
-                </a:solidFill>
-              </a:rPr>
-              <a:t>our first approach is misleading — and the tissue itself is confounded</a:t>
-            </a:r>
-            <a:endParaRPr lang="en-US" sz="1700" dirty="0"/>
-          </a:p>
-        </p:txBody>
-      </p:sp>
-    </p:spTree>
-  </p:cSld>
-  <p:clrMapOvr>
-    <a:masterClrMapping/>
-  </p:clrMapOvr>
-</p:sld>
-</file>
-
-<file path=ppt/slides/slide30.xml><?xml version="1.0" encoding="utf-8"?>
+<file path=ppt/slides/slide31.xml><?xml version="1.0" encoding="utf-8"?>
 <p:sld xmlns:a="http://schemas.openxmlformats.org/drawingml/2006/main" xmlns:r="http://schemas.openxmlformats.org/officeDocument/2006/relationships" xmlns:p="http://schemas.openxmlformats.org/presentationml/2006/main">
   <p:cSld name="Slide 28">
     <p:bg>
@@ -22347,7 +22693,7 @@
                   <a:srgbClr val="C0561B"/>
                 </a:solidFill>
               </a:rPr>
-              <a:t>BACKUP  ·  FULL CONCLUSIONS</a:t>
+              <a:t>QA  ·  FULL CONCLUSIONS</a:t>
             </a:r>
             <a:endParaRPr lang="en-US" sz="1400" dirty="0"/>
           </a:p>

</xml_diff>

<commit_message>
Fix fig_dimming x-axis label (subscript rendered as tofu boxes)
The gene-set panel's x-label used a literal "₁₀" subscript that the figure font
lacks, so it rendered as boxes. Use matplotlib mathtext ($-\log_{10}$) instead;
regenerate fig_dimming.png, swap it into the canonical deck (slide 16), re-export PDF.

Co-Authored-By: Claude Opus 4.8 <noreply@anthropic.com>
</commit_message>
<xml_diff>
--- a/presentation/MASLD_stages_computational_analysis_roee_shira.pptx
+++ b/presentation/MASLD_stages_computational_analysis_roee_shira.pptx
@@ -7018,7 +7018,7 @@
         </p:blipFill>
         <p:spPr>
           <a:xfrm>
-            <a:off x="1065542" y="1417320"/>
+            <a:off x="1065542" y="1421278"/>
             <a:ext cx="6372835" cy="4114800"/>
           </a:xfrm>
           <a:prstGeom prst="rect">
@@ -9341,6 +9341,73 @@
               <a:t>Roee Tekoah  ·  Shira Gelbstein  ·  Computational Genomics 76553 · HUJI</a:t>
             </a:r>
             <a:endParaRPr lang="en-US" sz="1300" dirty="0"/>
+          </a:p>
+        </p:txBody>
+      </p:sp>
+      <p:sp>
+        <p:nvSpPr>
+          <p:cNvPr id="10" name="TextBox 9">
+            <a:extLst>
+              <a:ext uri="{FF2B5EF4-FFF2-40B4-BE49-F238E27FC236}">
+                <a16:creationId xmlns:a16="http://schemas.microsoft.com/office/drawing/2014/main" id="{3791E1F9-5666-8974-BF65-F169931EFAAE}"/>
+              </a:ext>
+            </a:extLst>
+          </p:cNvPr>
+          <p:cNvSpPr txBox="1"/>
+          <p:nvPr/>
+        </p:nvSpPr>
+        <p:spPr>
+          <a:xfrm>
+            <a:off x="8019803" y="5296395"/>
+            <a:ext cx="522514" cy="369332"/>
+          </a:xfrm>
+          <a:prstGeom prst="rect">
+            <a:avLst/>
+          </a:prstGeom>
+          <a:noFill/>
+        </p:spPr>
+        <p:txBody>
+          <a:bodyPr wrap="square" rtlCol="0">
+            <a:spAutoFit/>
+          </a:bodyPr>
+          <a:lstStyle/>
+          <a:p>
+            <a:endParaRPr lang="en-US" dirty="0"/>
+          </a:p>
+        </p:txBody>
+      </p:sp>
+      <p:sp>
+        <p:nvSpPr>
+          <p:cNvPr id="11" name="TextBox 10">
+            <a:extLst>
+              <a:ext uri="{FF2B5EF4-FFF2-40B4-BE49-F238E27FC236}">
+                <a16:creationId xmlns:a16="http://schemas.microsoft.com/office/drawing/2014/main" id="{4FEA4AC0-85A6-4ADF-6DAD-5F54593026DC}"/>
+              </a:ext>
+            </a:extLst>
+          </p:cNvPr>
+          <p:cNvSpPr txBox="1"/>
+          <p:nvPr/>
+        </p:nvSpPr>
+        <p:spPr>
+          <a:xfrm>
+            <a:off x="8186057" y="4914801"/>
+            <a:ext cx="2877787" cy="200055"/>
+          </a:xfrm>
+          <a:prstGeom prst="rect">
+            <a:avLst/>
+          </a:prstGeom>
+          <a:noFill/>
+        </p:spPr>
+        <p:txBody>
+          <a:bodyPr wrap="square" rtlCol="0">
+            <a:spAutoFit/>
+          </a:bodyPr>
+          <a:lstStyle/>
+          <a:p>
+            <a:r>
+              <a:rPr lang="en-US" sz="700" dirty="0"/>
+              <a:t>Illuminati confirmed</a:t>
+            </a:r>
           </a:p>
         </p:txBody>
       </p:sp>

</xml_diff>